<commit_message>
Mesh import and debugging of aset management
</commit_message>
<xml_diff>
--- a/Documentation/Asset Pipeline.pptx
+++ b/Documentation/Asset Pipeline.pptx
@@ -5216,6 +5216,43 @@
         </a:p>
       </dgm:t>
     </dgm:pt>
+    <dgm:pt modelId="{F3AD5EC2-8CFC-44B4-84FC-1EC4053D23F7}">
+      <dgm:prSet/>
+      <dgm:spPr/>
+      <dgm:t>
+        <a:bodyPr/>
+        <a:lstStyle/>
+        <a:p>
+          <a:r>
+            <a:rPr lang="en-US" dirty="0" err="1"/>
+            <a:t>ACFilepath</a:t>
+          </a:r>
+          <a:endParaRPr lang="en-US" dirty="0"/>
+        </a:p>
+      </dgm:t>
+    </dgm:pt>
+    <dgm:pt modelId="{26F917EA-AD29-4A3B-B14D-422A7F30E6CB}" type="parTrans" cxnId="{CED242C2-2AE2-4C7E-9544-F89712FBA7FF}">
+      <dgm:prSet/>
+      <dgm:spPr/>
+      <dgm:t>
+        <a:bodyPr/>
+        <a:lstStyle/>
+        <a:p>
+          <a:endParaRPr lang="en-US"/>
+        </a:p>
+      </dgm:t>
+    </dgm:pt>
+    <dgm:pt modelId="{C33D2425-7930-4A96-95D5-06CBB2794C4E}" type="sibTrans" cxnId="{CED242C2-2AE2-4C7E-9544-F89712FBA7FF}">
+      <dgm:prSet/>
+      <dgm:spPr/>
+      <dgm:t>
+        <a:bodyPr/>
+        <a:lstStyle/>
+        <a:p>
+          <a:endParaRPr lang="en-US"/>
+        </a:p>
+      </dgm:t>
+    </dgm:pt>
     <dgm:pt modelId="{55AAB538-76C9-4018-AEB7-2E260B8A0B86}" type="pres">
       <dgm:prSet presAssocID="{7039D912-74EB-4508-A920-7B182744F6DB}" presName="Name0" presStyleCnt="0">
         <dgm:presLayoutVars>
@@ -5334,10 +5371,11 @@
     <dgm:cxn modelId="{F463DB0E-8EA0-4B3E-BF98-6DCCC8E81944}" type="presOf" srcId="{80A0FD3E-C6A0-4AC0-BEE3-F3D680FFDAD0}" destId="{80F7A185-5624-45A8-89B6-2DD3BEF2A364}" srcOrd="0" destOrd="0" presId="urn:microsoft.com/office/officeart/2005/8/layout/hList1"/>
     <dgm:cxn modelId="{D43EE20F-EE3E-4A3B-BB12-9F8DE43FDAED}" type="presOf" srcId="{D2C01B18-E3FB-474F-95E7-05455D92D4B8}" destId="{6418F341-AB79-40AC-B83F-0228C41F0524}" srcOrd="0" destOrd="2" presId="urn:microsoft.com/office/officeart/2005/8/layout/hList1"/>
     <dgm:cxn modelId="{46134B11-0D40-41B7-824A-2F6B7E540C49}" type="presOf" srcId="{7039D912-74EB-4508-A920-7B182744F6DB}" destId="{55AAB538-76C9-4018-AEB7-2E260B8A0B86}" srcOrd="0" destOrd="0" presId="urn:microsoft.com/office/officeart/2005/8/layout/hList1"/>
-    <dgm:cxn modelId="{1144D218-690B-4503-979B-D44F63A28C40}" type="presOf" srcId="{6503583A-94E3-47C8-8A37-17DCFD2C1B40}" destId="{7FD399BC-E510-491B-A043-67ACAEEF2E3C}" srcOrd="0" destOrd="4" presId="urn:microsoft.com/office/officeart/2005/8/layout/hList1"/>
+    <dgm:cxn modelId="{1144D218-690B-4503-979B-D44F63A28C40}" type="presOf" srcId="{6503583A-94E3-47C8-8A37-17DCFD2C1B40}" destId="{7FD399BC-E510-491B-A043-67ACAEEF2E3C}" srcOrd="0" destOrd="5" presId="urn:microsoft.com/office/officeart/2005/8/layout/hList1"/>
     <dgm:cxn modelId="{4E60AC19-DD0A-4536-B185-C694DBC110F7}" type="presOf" srcId="{BA1FBE3B-C182-4377-8E40-0B3C0C1956CA}" destId="{18D4A536-73DC-492C-A34F-711BC80D73A7}" srcOrd="0" destOrd="0" presId="urn:microsoft.com/office/officeart/2005/8/layout/hList1"/>
     <dgm:cxn modelId="{A6F8D720-AE9E-45A3-A002-FD66255E424E}" type="presOf" srcId="{CD488F8F-4BCF-4E6E-AB7E-52B6F7DE107C}" destId="{3116BB5E-4752-4A55-AB69-BB802C942660}" srcOrd="0" destOrd="0" presId="urn:microsoft.com/office/officeart/2005/8/layout/hList1"/>
     <dgm:cxn modelId="{B4FB6B21-7771-467F-B99A-310F26F093AF}" type="presOf" srcId="{03978623-FE6E-4F91-B2D0-9F9AABA0040F}" destId="{6418F341-AB79-40AC-B83F-0228C41F0524}" srcOrd="0" destOrd="5" presId="urn:microsoft.com/office/officeart/2005/8/layout/hList1"/>
+    <dgm:cxn modelId="{CA6C1B26-FBB7-4342-85C7-F5442404911A}" type="presOf" srcId="{F3AD5EC2-8CFC-44B4-84FC-1EC4053D23F7}" destId="{7FD399BC-E510-491B-A043-67ACAEEF2E3C}" srcOrd="0" destOrd="4" presId="urn:microsoft.com/office/officeart/2005/8/layout/hList1"/>
     <dgm:cxn modelId="{67253B26-93D2-4227-A902-6B76F8FE4290}" type="presOf" srcId="{2F3812DE-64E3-4474-B1D5-9435A23ED917}" destId="{2B7C4BE8-A646-4433-9446-B88A77065CA4}" srcOrd="0" destOrd="0" presId="urn:microsoft.com/office/officeart/2005/8/layout/hList1"/>
     <dgm:cxn modelId="{8D88D927-A102-426C-AA83-0B2B913EB7BF}" type="presOf" srcId="{90460D4B-7138-4725-ADD6-E6EC2A7BF7EC}" destId="{7FD399BC-E510-491B-A043-67ACAEEF2E3C}" srcOrd="0" destOrd="1" presId="urn:microsoft.com/office/officeart/2005/8/layout/hList1"/>
     <dgm:cxn modelId="{F1C3F229-E489-4B5E-8D0C-E831A502C0EF}" srcId="{6659A7E7-8158-4A6E-A471-DA323965CCE9}" destId="{F8E01428-B033-4EC5-88F3-B8113EC519CA}" srcOrd="2" destOrd="0" parTransId="{457C380B-CE0C-4872-9D79-E197AC5F6652}" sibTransId="{970C36A2-E083-4459-AF8D-EAF96CA16898}"/>
@@ -5353,11 +5391,11 @@
     <dgm:cxn modelId="{9935EB3F-1AC9-4199-871A-824A4FF48E38}" srcId="{6659A7E7-8158-4A6E-A471-DA323965CCE9}" destId="{102C854C-B1C2-4A0C-88C2-398DDB93C8BB}" srcOrd="5" destOrd="0" parTransId="{8EA49D74-8884-4CF4-B0CC-99ABA20E2550}" sibTransId="{B89AA19B-3619-42A2-82EB-3EEDD51F37E3}"/>
     <dgm:cxn modelId="{8CECAF5F-DA00-4341-87E9-C2783DAE97BE}" srcId="{80A0FD3E-C6A0-4AC0-BEE3-F3D680FFDAD0}" destId="{CD488F8F-4BCF-4E6E-AB7E-52B6F7DE107C}" srcOrd="0" destOrd="0" parTransId="{42DB6BCE-A83C-467A-9D66-74C413A8A0E4}" sibTransId="{2A9BE94D-3088-43DC-B867-A5CA10F425C8}"/>
     <dgm:cxn modelId="{CAC14864-0BA6-4CDB-A88E-772833859E4A}" srcId="{7CB9B775-851A-4061-A9DF-E60947B13BE6}" destId="{496EB545-0894-4B0F-8936-291577F9915D}" srcOrd="0" destOrd="0" parTransId="{EF545D9D-E807-485E-998A-0A5634E6EAEC}" sibTransId="{476CAC9E-4E5A-4010-AC78-FFD0504BEC2F}"/>
-    <dgm:cxn modelId="{F0CA5A45-C6DF-48B3-8B03-B35309CE3725}" srcId="{90460D4B-7138-4725-ADD6-E6EC2A7BF7EC}" destId="{65F19840-B0C0-478D-8303-0247D09C817A}" srcOrd="3" destOrd="0" parTransId="{F56F0E06-DB59-4373-BCD3-1E620BE207A3}" sibTransId="{1A56BC5E-3F05-4F0F-A1D0-BB1EED387864}"/>
+    <dgm:cxn modelId="{F0CA5A45-C6DF-48B3-8B03-B35309CE3725}" srcId="{90460D4B-7138-4725-ADD6-E6EC2A7BF7EC}" destId="{65F19840-B0C0-478D-8303-0247D09C817A}" srcOrd="4" destOrd="0" parTransId="{F56F0E06-DB59-4373-BCD3-1E620BE207A3}" sibTransId="{1A56BC5E-3F05-4F0F-A1D0-BB1EED387864}"/>
     <dgm:cxn modelId="{9EC9E745-E4AA-4A48-86E5-A56A9D07CF18}" srcId="{007B146B-7043-4DA4-9872-F19B6C46FDB4}" destId="{4700AFBE-57B8-4F45-85FC-78D11916CE41}" srcOrd="2" destOrd="0" parTransId="{A8B03DD9-09C7-4E7B-B063-D61132B46139}" sibTransId="{15F71444-0CE4-46DA-8E0D-82349D1C5ED7}"/>
     <dgm:cxn modelId="{F4ECD369-4640-4290-8817-A810CB0A866F}" type="presOf" srcId="{007B146B-7043-4DA4-9872-F19B6C46FDB4}" destId="{6418F341-AB79-40AC-B83F-0228C41F0524}" srcOrd="0" destOrd="1" presId="urn:microsoft.com/office/officeart/2005/8/layout/hList1"/>
     <dgm:cxn modelId="{860CDD4B-2E77-49B5-AEBE-1A85A176A7C3}" type="presOf" srcId="{A521DE87-592D-424F-B359-261E6644A127}" destId="{2B7C4BE8-A646-4433-9446-B88A77065CA4}" srcOrd="0" destOrd="3" presId="urn:microsoft.com/office/officeart/2005/8/layout/hList1"/>
-    <dgm:cxn modelId="{A4154A6D-056D-4EE4-A395-C0CF04701971}" srcId="{90460D4B-7138-4725-ADD6-E6EC2A7BF7EC}" destId="{6503583A-94E3-47C8-8A37-17DCFD2C1B40}" srcOrd="2" destOrd="0" parTransId="{C160F51E-FCFD-4661-9B7C-39FB92B88A36}" sibTransId="{7D0024F7-DB83-4DAB-8350-82F13C69336B}"/>
+    <dgm:cxn modelId="{A4154A6D-056D-4EE4-A395-C0CF04701971}" srcId="{90460D4B-7138-4725-ADD6-E6EC2A7BF7EC}" destId="{6503583A-94E3-47C8-8A37-17DCFD2C1B40}" srcOrd="3" destOrd="0" parTransId="{C160F51E-FCFD-4661-9B7C-39FB92B88A36}" sibTransId="{7D0024F7-DB83-4DAB-8350-82F13C69336B}"/>
     <dgm:cxn modelId="{AD5CA36D-447E-463A-AADC-33C199AAA439}" type="presOf" srcId="{7AF5FCE1-11D6-46FB-8B9D-23C7E613916E}" destId="{E09129F2-95E6-4C8B-BC91-BBC3BDA85498}" srcOrd="0" destOrd="0" presId="urn:microsoft.com/office/officeart/2005/8/layout/hList1"/>
     <dgm:cxn modelId="{EC663551-D8A7-4060-A28A-383737E6BD65}" type="presOf" srcId="{78F88E26-8B8C-4948-BF99-63EA46AFCFA3}" destId="{7FD399BC-E510-491B-A043-67ACAEEF2E3C}" srcOrd="0" destOrd="3" presId="urn:microsoft.com/office/officeart/2005/8/layout/hList1"/>
     <dgm:cxn modelId="{503C8454-F428-4243-AECB-265FA4B8D9BA}" srcId="{E53FD2FB-F572-421B-BB4D-59CD3C203DA6}" destId="{7CB9B775-851A-4061-A9DF-E60947B13BE6}" srcOrd="1" destOrd="0" parTransId="{D780929A-2D37-4C25-BF8A-9A0E8157996A}" sibTransId="{88D8659E-869C-4503-8503-4E5AACA8FA3E}"/>
@@ -5370,7 +5408,7 @@
     <dgm:cxn modelId="{621C7697-1F0B-40BB-B63B-B262ED275C28}" srcId="{7CB9B775-851A-4061-A9DF-E60947B13BE6}" destId="{829080E2-2793-47D4-8AB2-3E71A7C02F83}" srcOrd="2" destOrd="0" parTransId="{17717102-DC23-4339-A4BD-626C0DBCE9E7}" sibTransId="{E9E0E638-0E46-452D-A812-122B1603FC93}"/>
     <dgm:cxn modelId="{86F77799-BDB9-4411-B889-07E61E633FAC}" srcId="{E53FD2FB-F572-421B-BB4D-59CD3C203DA6}" destId="{2F3812DE-64E3-4474-B1D5-9435A23ED917}" srcOrd="0" destOrd="0" parTransId="{F852C2A1-23E1-4F41-B098-8EAC2C189ACA}" sibTransId="{B68CD15B-C645-4506-A8E5-2D86C0335B27}"/>
     <dgm:cxn modelId="{A5A6969C-93D7-437F-A7AE-83304180A89A}" type="presOf" srcId="{E53FD2FB-F572-421B-BB4D-59CD3C203DA6}" destId="{A97189DC-B62A-4226-BE84-683C8D0EEFD3}" srcOrd="0" destOrd="0" presId="urn:microsoft.com/office/officeart/2005/8/layout/hList1"/>
-    <dgm:cxn modelId="{FCE95EA2-9EAD-4902-A656-CF8FCC0A08B2}" type="presOf" srcId="{65F19840-B0C0-478D-8303-0247D09C817A}" destId="{7FD399BC-E510-491B-A043-67ACAEEF2E3C}" srcOrd="0" destOrd="5" presId="urn:microsoft.com/office/officeart/2005/8/layout/hList1"/>
+    <dgm:cxn modelId="{FCE95EA2-9EAD-4902-A656-CF8FCC0A08B2}" type="presOf" srcId="{65F19840-B0C0-478D-8303-0247D09C817A}" destId="{7FD399BC-E510-491B-A043-67ACAEEF2E3C}" srcOrd="0" destOrd="6" presId="urn:microsoft.com/office/officeart/2005/8/layout/hList1"/>
     <dgm:cxn modelId="{BC10DEA3-76F5-473A-AEC8-0DA8D2917C86}" type="presOf" srcId="{6659A7E7-8158-4A6E-A471-DA323965CCE9}" destId="{3116BB5E-4752-4A55-AB69-BB802C942660}" srcOrd="0" destOrd="1" presId="urn:microsoft.com/office/officeart/2005/8/layout/hList1"/>
     <dgm:cxn modelId="{B52F73A8-5A20-405E-BFC7-51B34FC95885}" srcId="{90460D4B-7138-4725-ADD6-E6EC2A7BF7EC}" destId="{78F88E26-8B8C-4948-BF99-63EA46AFCFA3}" srcOrd="1" destOrd="0" parTransId="{98D5557D-40C2-4744-8D4F-EFF73CDEC0DD}" sibTransId="{5271797F-73B1-4CF2-8588-CD56DF1624E8}"/>
     <dgm:cxn modelId="{AD8797A8-4E33-4E39-8B6B-3E1CEFD1E8AE}" type="presOf" srcId="{DB82E421-8B43-400F-B820-4E5E46890ACB}" destId="{6418F341-AB79-40AC-B83F-0228C41F0524}" srcOrd="0" destOrd="3" presId="urn:microsoft.com/office/officeart/2005/8/layout/hList1"/>
@@ -5380,6 +5418,7 @@
     <dgm:cxn modelId="{B8BB1DBC-DCF9-45E4-A9CB-F20700E5AC91}" type="presOf" srcId="{C55CDAA4-0A7B-4072-9CD3-6D7896772C6F}" destId="{7FD399BC-E510-491B-A043-67ACAEEF2E3C}" srcOrd="0" destOrd="2" presId="urn:microsoft.com/office/officeart/2005/8/layout/hList1"/>
     <dgm:cxn modelId="{148D22BD-FB6A-484C-874B-142384834133}" srcId="{007B146B-7043-4DA4-9872-F19B6C46FDB4}" destId="{D2C01B18-E3FB-474F-95E7-05455D92D4B8}" srcOrd="0" destOrd="0" parTransId="{166E2CA8-82CF-4E76-934C-7C71BC0CDAC7}" sibTransId="{CACF65A1-3C5E-421B-891C-4717F0280A2B}"/>
     <dgm:cxn modelId="{B28B66BF-5ADA-4132-A98F-8A1708B02064}" srcId="{7AF5FCE1-11D6-46FB-8B9D-23C7E613916E}" destId="{8118D722-B82D-4483-BDDC-1B53D47D868F}" srcOrd="0" destOrd="0" parTransId="{7D59BDDC-B779-4518-9ED4-05DEF339598E}" sibTransId="{6083E495-5339-4A68-A268-849A9733BA49}"/>
+    <dgm:cxn modelId="{CED242C2-2AE2-4C7E-9544-F89712FBA7FF}" srcId="{90460D4B-7138-4725-ADD6-E6EC2A7BF7EC}" destId="{F3AD5EC2-8CFC-44B4-84FC-1EC4053D23F7}" srcOrd="2" destOrd="0" parTransId="{26F917EA-AD29-4A3B-B14D-422A7F30E6CB}" sibTransId="{C33D2425-7930-4A96-95D5-06CBB2794C4E}"/>
     <dgm:cxn modelId="{A66959CA-0A49-47BE-80E8-FFFE5975A6C5}" srcId="{007B146B-7043-4DA4-9872-F19B6C46FDB4}" destId="{DB82E421-8B43-400F-B820-4E5E46890ACB}" srcOrd="1" destOrd="0" parTransId="{B3C3E713-BA38-4F09-9DB9-B14F0187D506}" sibTransId="{7330DEA7-B961-43C2-BBE9-ACA2D8ECB655}"/>
     <dgm:cxn modelId="{78C996D1-9E72-49F5-AB9C-2C2B83D0DE17}" srcId="{6659A7E7-8158-4A6E-A471-DA323965CCE9}" destId="{88EF3DC1-C7EB-42FB-8165-F41505DC47A3}" srcOrd="6" destOrd="0" parTransId="{79420B54-54CF-4606-A37C-1265DA7D9C5D}" sibTransId="{25327A15-6A41-432C-B6BA-788D84B2D7D4}"/>
     <dgm:cxn modelId="{9DCB9FE5-DD06-48A2-A44A-B1DC9C7CF1CB}" srcId="{6659A7E7-8158-4A6E-A471-DA323965CCE9}" destId="{6992C787-FC19-4B56-B86B-85751586ED68}" srcOrd="4" destOrd="0" parTransId="{A98B85C6-1E8C-4647-9359-DAA18747BAC1}" sibTransId="{EC823E0B-2B97-4EC1-87E0-FDEB74036751}"/>
@@ -8340,6 +8379,25 @@
           </a:pPr>
           <a:r>
             <a:rPr lang="en-US" sz="1500" kern="1200" dirty="0" err="1"/>
+            <a:t>ACFilepath</a:t>
+          </a:r>
+          <a:endParaRPr lang="en-US" sz="1500" kern="1200" dirty="0"/>
+        </a:p>
+        <a:p>
+          <a:pPr marL="228600" lvl="2" indent="-114300" algn="l" defTabSz="666750">
+            <a:lnSpc>
+              <a:spcPct val="90000"/>
+            </a:lnSpc>
+            <a:spcBef>
+              <a:spcPct val="0"/>
+            </a:spcBef>
+            <a:spcAft>
+              <a:spcPct val="15000"/>
+            </a:spcAft>
+            <a:buChar char="•"/>
+          </a:pPr>
+          <a:r>
+            <a:rPr lang="en-US" sz="1500" kern="1200" dirty="0" err="1"/>
             <a:t>CoreComponent</a:t>
           </a:r>
           <a:endParaRPr lang="en-US" sz="1500" kern="1200" dirty="0"/>
@@ -14492,7 +14550,7 @@
           <a:p>
             <a:fld id="{D0E2DD2C-27F7-4F93-96E8-CD28AD9267D9}" type="datetimeFigureOut">
               <a:rPr lang="en-US" smtClean="0"/>
-              <a:t>6/22/2025</a:t>
+              <a:t>6/24/2025</a:t>
             </a:fld>
             <a:endParaRPr lang="en-US"/>
           </a:p>
@@ -15315,7 +15373,7 @@
           <a:p>
             <a:fld id="{783DC7D5-4D76-4679-A391-31CBAFA90932}" type="datetimeFigureOut">
               <a:rPr lang="en-US" smtClean="0"/>
-              <a:t>6/22/2025</a:t>
+              <a:t>6/24/2025</a:t>
             </a:fld>
             <a:endParaRPr lang="en-US"/>
           </a:p>
@@ -15513,7 +15571,7 @@
           <a:p>
             <a:fld id="{783DC7D5-4D76-4679-A391-31CBAFA90932}" type="datetimeFigureOut">
               <a:rPr lang="en-US" smtClean="0"/>
-              <a:t>6/22/2025</a:t>
+              <a:t>6/24/2025</a:t>
             </a:fld>
             <a:endParaRPr lang="en-US"/>
           </a:p>
@@ -15721,7 +15779,7 @@
           <a:p>
             <a:fld id="{783DC7D5-4D76-4679-A391-31CBAFA90932}" type="datetimeFigureOut">
               <a:rPr lang="en-US" smtClean="0"/>
-              <a:t>6/22/2025</a:t>
+              <a:t>6/24/2025</a:t>
             </a:fld>
             <a:endParaRPr lang="en-US"/>
           </a:p>
@@ -15919,7 +15977,7 @@
           <a:p>
             <a:fld id="{783DC7D5-4D76-4679-A391-31CBAFA90932}" type="datetimeFigureOut">
               <a:rPr lang="en-US" smtClean="0"/>
-              <a:t>6/22/2025</a:t>
+              <a:t>6/24/2025</a:t>
             </a:fld>
             <a:endParaRPr lang="en-US"/>
           </a:p>
@@ -16194,7 +16252,7 @@
           <a:p>
             <a:fld id="{783DC7D5-4D76-4679-A391-31CBAFA90932}" type="datetimeFigureOut">
               <a:rPr lang="en-US" smtClean="0"/>
-              <a:t>6/22/2025</a:t>
+              <a:t>6/24/2025</a:t>
             </a:fld>
             <a:endParaRPr lang="en-US"/>
           </a:p>
@@ -16459,7 +16517,7 @@
           <a:p>
             <a:fld id="{783DC7D5-4D76-4679-A391-31CBAFA90932}" type="datetimeFigureOut">
               <a:rPr lang="en-US" smtClean="0"/>
-              <a:t>6/22/2025</a:t>
+              <a:t>6/24/2025</a:t>
             </a:fld>
             <a:endParaRPr lang="en-US"/>
           </a:p>
@@ -16871,7 +16929,7 @@
           <a:p>
             <a:fld id="{783DC7D5-4D76-4679-A391-31CBAFA90932}" type="datetimeFigureOut">
               <a:rPr lang="en-US" smtClean="0"/>
-              <a:t>6/22/2025</a:t>
+              <a:t>6/24/2025</a:t>
             </a:fld>
             <a:endParaRPr lang="en-US"/>
           </a:p>
@@ -17012,7 +17070,7 @@
           <a:p>
             <a:fld id="{783DC7D5-4D76-4679-A391-31CBAFA90932}" type="datetimeFigureOut">
               <a:rPr lang="en-US" smtClean="0"/>
-              <a:t>6/22/2025</a:t>
+              <a:t>6/24/2025</a:t>
             </a:fld>
             <a:endParaRPr lang="en-US"/>
           </a:p>
@@ -17125,7 +17183,7 @@
           <a:p>
             <a:fld id="{783DC7D5-4D76-4679-A391-31CBAFA90932}" type="datetimeFigureOut">
               <a:rPr lang="en-US" smtClean="0"/>
-              <a:t>6/22/2025</a:t>
+              <a:t>6/24/2025</a:t>
             </a:fld>
             <a:endParaRPr lang="en-US"/>
           </a:p>
@@ -17436,7 +17494,7 @@
           <a:p>
             <a:fld id="{783DC7D5-4D76-4679-A391-31CBAFA90932}" type="datetimeFigureOut">
               <a:rPr lang="en-US" smtClean="0"/>
-              <a:t>6/22/2025</a:t>
+              <a:t>6/24/2025</a:t>
             </a:fld>
             <a:endParaRPr lang="en-US"/>
           </a:p>
@@ -17724,7 +17782,7 @@
           <a:p>
             <a:fld id="{783DC7D5-4D76-4679-A391-31CBAFA90932}" type="datetimeFigureOut">
               <a:rPr lang="en-US" smtClean="0"/>
-              <a:t>6/22/2025</a:t>
+              <a:t>6/24/2025</a:t>
             </a:fld>
             <a:endParaRPr lang="en-US"/>
           </a:p>
@@ -17965,7 +18023,7 @@
           <a:p>
             <a:fld id="{783DC7D5-4D76-4679-A391-31CBAFA90932}" type="datetimeFigureOut">
               <a:rPr lang="en-US" smtClean="0"/>
-              <a:t>6/22/2025</a:t>
+              <a:t>6/24/2025</a:t>
             </a:fld>
             <a:endParaRPr lang="en-US"/>
           </a:p>
@@ -21083,7 +21141,7 @@
           <p:nvPr>
             <p:extLst>
               <p:ext uri="{D42A27DB-BD31-4B8C-83A1-F6EECF244321}">
-                <p14:modId xmlns:p14="http://schemas.microsoft.com/office/powerpoint/2010/main" val="2865534583"/>
+                <p14:modId xmlns:p14="http://schemas.microsoft.com/office/powerpoint/2010/main" val="4027418349"/>
               </p:ext>
             </p:extLst>
           </p:nvPr>

</xml_diff>

<commit_message>
AssetHandle UI widget drawing part 2
</commit_message>
<xml_diff>
--- a/Documentation/Asset Pipeline.pptx
+++ b/Documentation/Asset Pipeline.pptx
@@ -4202,7 +4202,11 @@
         <a:p>
           <a:r>
             <a:rPr lang="en-US" dirty="0"/>
-            <a:t>Assets often contain references to other assets. Internal assets are only ever referenced by other assets. Fully hidden from the user.</a:t>
+            <a:t>Internal Assets are only ever referenced by other asset</a:t>
+          </a:r>
+          <a:r>
+            <a:rPr lang="en-US" noProof="0" dirty="0"/>
+            <a:t>s. They are conceptually parts of Project Assets and they get imported together.</a:t>
           </a:r>
         </a:p>
       </dgm:t>
@@ -5253,6 +5257,43 @@
         </a:p>
       </dgm:t>
     </dgm:pt>
+    <dgm:pt modelId="{EC6B208F-AA07-4878-9479-15F07D0A00F0}">
+      <dgm:prSet/>
+      <dgm:spPr/>
+      <dgm:t>
+        <a:bodyPr/>
+        <a:lstStyle/>
+        <a:p>
+          <a:r>
+            <a:rPr lang="en-US" dirty="0"/>
+            <a:t>Fully hidden from the user.</a:t>
+          </a:r>
+          <a:endParaRPr lang="en-US" noProof="0" dirty="0"/>
+        </a:p>
+      </dgm:t>
+    </dgm:pt>
+    <dgm:pt modelId="{46D7FAB6-E954-41BA-B72C-810F09D29662}" type="parTrans" cxnId="{1C102DE7-3811-4E71-A3D4-7D3451720805}">
+      <dgm:prSet/>
+      <dgm:spPr/>
+      <dgm:t>
+        <a:bodyPr/>
+        <a:lstStyle/>
+        <a:p>
+          <a:endParaRPr lang="en-US"/>
+        </a:p>
+      </dgm:t>
+    </dgm:pt>
+    <dgm:pt modelId="{B4302993-1B23-4872-8714-D974D5F5192F}" type="sibTrans" cxnId="{1C102DE7-3811-4E71-A3D4-7D3451720805}">
+      <dgm:prSet/>
+      <dgm:spPr/>
+      <dgm:t>
+        <a:bodyPr/>
+        <a:lstStyle/>
+        <a:p>
+          <a:endParaRPr lang="en-US"/>
+        </a:p>
+      </dgm:t>
+    </dgm:pt>
     <dgm:pt modelId="{55AAB538-76C9-4018-AEB7-2E260B8A0B86}" type="pres">
       <dgm:prSet presAssocID="{7039D912-74EB-4508-A920-7B182744F6DB}" presName="Name0" presStyleCnt="0">
         <dgm:presLayoutVars>
@@ -5369,12 +5410,12 @@
     <dgm:cxn modelId="{7FC7E906-E056-4E64-859A-8476EDCD4365}" type="presOf" srcId="{7CB9B775-851A-4061-A9DF-E60947B13BE6}" destId="{2B7C4BE8-A646-4433-9446-B88A77065CA4}" srcOrd="0" destOrd="1" presId="urn:microsoft.com/office/officeart/2005/8/layout/hList1"/>
     <dgm:cxn modelId="{1E78A00D-9FF8-4862-A084-AC01618389EA}" srcId="{80A0FD3E-C6A0-4AC0-BEE3-F3D680FFDAD0}" destId="{6659A7E7-8158-4A6E-A471-DA323965CCE9}" srcOrd="1" destOrd="0" parTransId="{0651B8AE-3C39-4FE7-BB50-305118B07273}" sibTransId="{6D812D89-DC62-4CF9-8AB3-702740139B84}"/>
     <dgm:cxn modelId="{F463DB0E-8EA0-4B3E-BF98-6DCCC8E81944}" type="presOf" srcId="{80A0FD3E-C6A0-4AC0-BEE3-F3D680FFDAD0}" destId="{80F7A185-5624-45A8-89B6-2DD3BEF2A364}" srcOrd="0" destOrd="0" presId="urn:microsoft.com/office/officeart/2005/8/layout/hList1"/>
-    <dgm:cxn modelId="{D43EE20F-EE3E-4A3B-BB12-9F8DE43FDAED}" type="presOf" srcId="{D2C01B18-E3FB-474F-95E7-05455D92D4B8}" destId="{6418F341-AB79-40AC-B83F-0228C41F0524}" srcOrd="0" destOrd="2" presId="urn:microsoft.com/office/officeart/2005/8/layout/hList1"/>
+    <dgm:cxn modelId="{D43EE20F-EE3E-4A3B-BB12-9F8DE43FDAED}" type="presOf" srcId="{D2C01B18-E3FB-474F-95E7-05455D92D4B8}" destId="{6418F341-AB79-40AC-B83F-0228C41F0524}" srcOrd="0" destOrd="3" presId="urn:microsoft.com/office/officeart/2005/8/layout/hList1"/>
     <dgm:cxn modelId="{46134B11-0D40-41B7-824A-2F6B7E540C49}" type="presOf" srcId="{7039D912-74EB-4508-A920-7B182744F6DB}" destId="{55AAB538-76C9-4018-AEB7-2E260B8A0B86}" srcOrd="0" destOrd="0" presId="urn:microsoft.com/office/officeart/2005/8/layout/hList1"/>
     <dgm:cxn modelId="{1144D218-690B-4503-979B-D44F63A28C40}" type="presOf" srcId="{6503583A-94E3-47C8-8A37-17DCFD2C1B40}" destId="{7FD399BC-E510-491B-A043-67ACAEEF2E3C}" srcOrd="0" destOrd="5" presId="urn:microsoft.com/office/officeart/2005/8/layout/hList1"/>
     <dgm:cxn modelId="{4E60AC19-DD0A-4536-B185-C694DBC110F7}" type="presOf" srcId="{BA1FBE3B-C182-4377-8E40-0B3C0C1956CA}" destId="{18D4A536-73DC-492C-A34F-711BC80D73A7}" srcOrd="0" destOrd="0" presId="urn:microsoft.com/office/officeart/2005/8/layout/hList1"/>
     <dgm:cxn modelId="{A6F8D720-AE9E-45A3-A002-FD66255E424E}" type="presOf" srcId="{CD488F8F-4BCF-4E6E-AB7E-52B6F7DE107C}" destId="{3116BB5E-4752-4A55-AB69-BB802C942660}" srcOrd="0" destOrd="0" presId="urn:microsoft.com/office/officeart/2005/8/layout/hList1"/>
-    <dgm:cxn modelId="{B4FB6B21-7771-467F-B99A-310F26F093AF}" type="presOf" srcId="{03978623-FE6E-4F91-B2D0-9F9AABA0040F}" destId="{6418F341-AB79-40AC-B83F-0228C41F0524}" srcOrd="0" destOrd="5" presId="urn:microsoft.com/office/officeart/2005/8/layout/hList1"/>
+    <dgm:cxn modelId="{B4FB6B21-7771-467F-B99A-310F26F093AF}" type="presOf" srcId="{03978623-FE6E-4F91-B2D0-9F9AABA0040F}" destId="{6418F341-AB79-40AC-B83F-0228C41F0524}" srcOrd="0" destOrd="6" presId="urn:microsoft.com/office/officeart/2005/8/layout/hList1"/>
     <dgm:cxn modelId="{CA6C1B26-FBB7-4342-85C7-F5442404911A}" type="presOf" srcId="{F3AD5EC2-8CFC-44B4-84FC-1EC4053D23F7}" destId="{7FD399BC-E510-491B-A043-67ACAEEF2E3C}" srcOrd="0" destOrd="4" presId="urn:microsoft.com/office/officeart/2005/8/layout/hList1"/>
     <dgm:cxn modelId="{67253B26-93D2-4227-A902-6B76F8FE4290}" type="presOf" srcId="{2F3812DE-64E3-4474-B1D5-9435A23ED917}" destId="{2B7C4BE8-A646-4433-9446-B88A77065CA4}" srcOrd="0" destOrd="0" presId="urn:microsoft.com/office/officeart/2005/8/layout/hList1"/>
     <dgm:cxn modelId="{8D88D927-A102-426C-AA83-0B2B913EB7BF}" type="presOf" srcId="{90460D4B-7138-4725-ADD6-E6EC2A7BF7EC}" destId="{7FD399BC-E510-491B-A043-67ACAEEF2E3C}" srcOrd="0" destOrd="1" presId="urn:microsoft.com/office/officeart/2005/8/layout/hList1"/>
@@ -5385,21 +5426,22 @@
     <dgm:cxn modelId="{E19B1832-913A-4E22-9C28-629DB7F93C5B}" type="presOf" srcId="{F8E01428-B033-4EC5-88F3-B8113EC519CA}" destId="{3116BB5E-4752-4A55-AB69-BB802C942660}" srcOrd="0" destOrd="4" presId="urn:microsoft.com/office/officeart/2005/8/layout/hList1"/>
     <dgm:cxn modelId="{A0A59932-CE58-4460-8CD0-6FB7805F17AF}" srcId="{7039D912-74EB-4508-A920-7B182744F6DB}" destId="{BA1FBE3B-C182-4377-8E40-0B3C0C1956CA}" srcOrd="3" destOrd="0" parTransId="{E30795FF-31C8-476E-809D-96D9B56B0077}" sibTransId="{597A5E4D-60FA-4710-927D-4F0900372DD4}"/>
     <dgm:cxn modelId="{8252BB38-8E22-41E9-B65D-14D24DB38772}" type="presOf" srcId="{8118D722-B82D-4483-BDDC-1B53D47D868F}" destId="{6418F341-AB79-40AC-B83F-0228C41F0524}" srcOrd="0" destOrd="0" presId="urn:microsoft.com/office/officeart/2005/8/layout/hList1"/>
-    <dgm:cxn modelId="{5150B839-1C83-47F0-B34B-4EE10AD1A6B7}" type="presOf" srcId="{D91083A4-A3FF-46EE-B215-B4E06D455191}" destId="{6418F341-AB79-40AC-B83F-0228C41F0524}" srcOrd="0" destOrd="6" presId="urn:microsoft.com/office/officeart/2005/8/layout/hList1"/>
+    <dgm:cxn modelId="{5150B839-1C83-47F0-B34B-4EE10AD1A6B7}" type="presOf" srcId="{D91083A4-A3FF-46EE-B215-B4E06D455191}" destId="{6418F341-AB79-40AC-B83F-0228C41F0524}" srcOrd="0" destOrd="7" presId="urn:microsoft.com/office/officeart/2005/8/layout/hList1"/>
     <dgm:cxn modelId="{D20A803E-6938-4D68-A359-982984092BEE}" type="presOf" srcId="{C070E80E-8CCB-43DE-89B8-CF105FAAA75A}" destId="{3116BB5E-4752-4A55-AB69-BB802C942660}" srcOrd="0" destOrd="5" presId="urn:microsoft.com/office/officeart/2005/8/layout/hList1"/>
     <dgm:cxn modelId="{83989A3F-F98C-4560-8FDB-A9758D57D8B8}" type="presOf" srcId="{102C854C-B1C2-4A0C-88C2-398DDB93C8BB}" destId="{3116BB5E-4752-4A55-AB69-BB802C942660}" srcOrd="0" destOrd="7" presId="urn:microsoft.com/office/officeart/2005/8/layout/hList1"/>
     <dgm:cxn modelId="{9935EB3F-1AC9-4199-871A-824A4FF48E38}" srcId="{6659A7E7-8158-4A6E-A471-DA323965CCE9}" destId="{102C854C-B1C2-4A0C-88C2-398DDB93C8BB}" srcOrd="5" destOrd="0" parTransId="{8EA49D74-8884-4CF4-B0CC-99ABA20E2550}" sibTransId="{B89AA19B-3619-42A2-82EB-3EEDD51F37E3}"/>
     <dgm:cxn modelId="{8CECAF5F-DA00-4341-87E9-C2783DAE97BE}" srcId="{80A0FD3E-C6A0-4AC0-BEE3-F3D680FFDAD0}" destId="{CD488F8F-4BCF-4E6E-AB7E-52B6F7DE107C}" srcOrd="0" destOrd="0" parTransId="{42DB6BCE-A83C-467A-9D66-74C413A8A0E4}" sibTransId="{2A9BE94D-3088-43DC-B867-A5CA10F425C8}"/>
     <dgm:cxn modelId="{CAC14864-0BA6-4CDB-A88E-772833859E4A}" srcId="{7CB9B775-851A-4061-A9DF-E60947B13BE6}" destId="{496EB545-0894-4B0F-8936-291577F9915D}" srcOrd="0" destOrd="0" parTransId="{EF545D9D-E807-485E-998A-0A5634E6EAEC}" sibTransId="{476CAC9E-4E5A-4010-AC78-FFD0504BEC2F}"/>
+    <dgm:cxn modelId="{DDC28A44-B0EF-4440-863E-FCF4E569B42A}" type="presOf" srcId="{EC6B208F-AA07-4878-9479-15F07D0A00F0}" destId="{6418F341-AB79-40AC-B83F-0228C41F0524}" srcOrd="0" destOrd="1" presId="urn:microsoft.com/office/officeart/2005/8/layout/hList1"/>
     <dgm:cxn modelId="{F0CA5A45-C6DF-48B3-8B03-B35309CE3725}" srcId="{90460D4B-7138-4725-ADD6-E6EC2A7BF7EC}" destId="{65F19840-B0C0-478D-8303-0247D09C817A}" srcOrd="4" destOrd="0" parTransId="{F56F0E06-DB59-4373-BCD3-1E620BE207A3}" sibTransId="{1A56BC5E-3F05-4F0F-A1D0-BB1EED387864}"/>
     <dgm:cxn modelId="{9EC9E745-E4AA-4A48-86E5-A56A9D07CF18}" srcId="{007B146B-7043-4DA4-9872-F19B6C46FDB4}" destId="{4700AFBE-57B8-4F45-85FC-78D11916CE41}" srcOrd="2" destOrd="0" parTransId="{A8B03DD9-09C7-4E7B-B063-D61132B46139}" sibTransId="{15F71444-0CE4-46DA-8E0D-82349D1C5ED7}"/>
-    <dgm:cxn modelId="{F4ECD369-4640-4290-8817-A810CB0A866F}" type="presOf" srcId="{007B146B-7043-4DA4-9872-F19B6C46FDB4}" destId="{6418F341-AB79-40AC-B83F-0228C41F0524}" srcOrd="0" destOrd="1" presId="urn:microsoft.com/office/officeart/2005/8/layout/hList1"/>
+    <dgm:cxn modelId="{F4ECD369-4640-4290-8817-A810CB0A866F}" type="presOf" srcId="{007B146B-7043-4DA4-9872-F19B6C46FDB4}" destId="{6418F341-AB79-40AC-B83F-0228C41F0524}" srcOrd="0" destOrd="2" presId="urn:microsoft.com/office/officeart/2005/8/layout/hList1"/>
     <dgm:cxn modelId="{860CDD4B-2E77-49B5-AEBE-1A85A176A7C3}" type="presOf" srcId="{A521DE87-592D-424F-B359-261E6644A127}" destId="{2B7C4BE8-A646-4433-9446-B88A77065CA4}" srcOrd="0" destOrd="3" presId="urn:microsoft.com/office/officeart/2005/8/layout/hList1"/>
     <dgm:cxn modelId="{A4154A6D-056D-4EE4-A395-C0CF04701971}" srcId="{90460D4B-7138-4725-ADD6-E6EC2A7BF7EC}" destId="{6503583A-94E3-47C8-8A37-17DCFD2C1B40}" srcOrd="3" destOrd="0" parTransId="{C160F51E-FCFD-4661-9B7C-39FB92B88A36}" sibTransId="{7D0024F7-DB83-4DAB-8350-82F13C69336B}"/>
     <dgm:cxn modelId="{AD5CA36D-447E-463A-AADC-33C199AAA439}" type="presOf" srcId="{7AF5FCE1-11D6-46FB-8B9D-23C7E613916E}" destId="{E09129F2-95E6-4C8B-BC91-BBC3BDA85498}" srcOrd="0" destOrd="0" presId="urn:microsoft.com/office/officeart/2005/8/layout/hList1"/>
     <dgm:cxn modelId="{EC663551-D8A7-4060-A28A-383737E6BD65}" type="presOf" srcId="{78F88E26-8B8C-4948-BF99-63EA46AFCFA3}" destId="{7FD399BC-E510-491B-A043-67ACAEEF2E3C}" srcOrd="0" destOrd="3" presId="urn:microsoft.com/office/officeart/2005/8/layout/hList1"/>
     <dgm:cxn modelId="{503C8454-F428-4243-AECB-265FA4B8D9BA}" srcId="{E53FD2FB-F572-421B-BB4D-59CD3C203DA6}" destId="{7CB9B775-851A-4061-A9DF-E60947B13BE6}" srcOrd="1" destOrd="0" parTransId="{D780929A-2D37-4C25-BF8A-9A0E8157996A}" sibTransId="{88D8659E-869C-4503-8503-4E5AACA8FA3E}"/>
-    <dgm:cxn modelId="{43275F56-BEA0-4E87-905C-8FDE7B22DBD4}" srcId="{7AF5FCE1-11D6-46FB-8B9D-23C7E613916E}" destId="{007B146B-7043-4DA4-9872-F19B6C46FDB4}" srcOrd="1" destOrd="0" parTransId="{A173CFB8-8E05-4375-B9CE-97311CD3065B}" sibTransId="{D2745B64-D5FE-4DF3-BE60-022EDD8E8D07}"/>
+    <dgm:cxn modelId="{43275F56-BEA0-4E87-905C-8FDE7B22DBD4}" srcId="{7AF5FCE1-11D6-46FB-8B9D-23C7E613916E}" destId="{007B146B-7043-4DA4-9872-F19B6C46FDB4}" srcOrd="2" destOrd="0" parTransId="{A173CFB8-8E05-4375-B9CE-97311CD3065B}" sibTransId="{D2745B64-D5FE-4DF3-BE60-022EDD8E8D07}"/>
     <dgm:cxn modelId="{F999BF5A-9607-44EF-9295-10775E7E7CDB}" type="presOf" srcId="{ADFB65C5-7830-4D40-BD55-A77D738EBBB8}" destId="{3116BB5E-4752-4A55-AB69-BB802C942660}" srcOrd="0" destOrd="3" presId="urn:microsoft.com/office/officeart/2005/8/layout/hList1"/>
     <dgm:cxn modelId="{FE4CFB82-DF6D-4101-934E-B138BCE31401}" type="presOf" srcId="{88EF3DC1-C7EB-42FB-8165-F41505DC47A3}" destId="{3116BB5E-4752-4A55-AB69-BB802C942660}" srcOrd="0" destOrd="8" presId="urn:microsoft.com/office/officeart/2005/8/layout/hList1"/>
     <dgm:cxn modelId="{C963DE92-9FFA-416E-9CBB-F1D96E4F23A2}" srcId="{BA1FBE3B-C182-4377-8E40-0B3C0C1956CA}" destId="{90460D4B-7138-4725-ADD6-E6EC2A7BF7EC}" srcOrd="1" destOrd="0" parTransId="{5CAE3443-D2EC-438E-BAA1-5E5A5619E4B8}" sibTransId="{023AE1A4-1C73-440E-8E5B-82164B5EE816}"/>
@@ -5411,8 +5453,8 @@
     <dgm:cxn modelId="{FCE95EA2-9EAD-4902-A656-CF8FCC0A08B2}" type="presOf" srcId="{65F19840-B0C0-478D-8303-0247D09C817A}" destId="{7FD399BC-E510-491B-A043-67ACAEEF2E3C}" srcOrd="0" destOrd="6" presId="urn:microsoft.com/office/officeart/2005/8/layout/hList1"/>
     <dgm:cxn modelId="{BC10DEA3-76F5-473A-AEC8-0DA8D2917C86}" type="presOf" srcId="{6659A7E7-8158-4A6E-A471-DA323965CCE9}" destId="{3116BB5E-4752-4A55-AB69-BB802C942660}" srcOrd="0" destOrd="1" presId="urn:microsoft.com/office/officeart/2005/8/layout/hList1"/>
     <dgm:cxn modelId="{B52F73A8-5A20-405E-BFC7-51B34FC95885}" srcId="{90460D4B-7138-4725-ADD6-E6EC2A7BF7EC}" destId="{78F88E26-8B8C-4948-BF99-63EA46AFCFA3}" srcOrd="1" destOrd="0" parTransId="{98D5557D-40C2-4744-8D4F-EFF73CDEC0DD}" sibTransId="{5271797F-73B1-4CF2-8588-CD56DF1624E8}"/>
-    <dgm:cxn modelId="{AD8797A8-4E33-4E39-8B6B-3E1CEFD1E8AE}" type="presOf" srcId="{DB82E421-8B43-400F-B820-4E5E46890ACB}" destId="{6418F341-AB79-40AC-B83F-0228C41F0524}" srcOrd="0" destOrd="3" presId="urn:microsoft.com/office/officeart/2005/8/layout/hList1"/>
-    <dgm:cxn modelId="{9FB4D4B0-DAF9-4D63-BFA5-2042F9E22DFC}" type="presOf" srcId="{4700AFBE-57B8-4F45-85FC-78D11916CE41}" destId="{6418F341-AB79-40AC-B83F-0228C41F0524}" srcOrd="0" destOrd="4" presId="urn:microsoft.com/office/officeart/2005/8/layout/hList1"/>
+    <dgm:cxn modelId="{AD8797A8-4E33-4E39-8B6B-3E1CEFD1E8AE}" type="presOf" srcId="{DB82E421-8B43-400F-B820-4E5E46890ACB}" destId="{6418F341-AB79-40AC-B83F-0228C41F0524}" srcOrd="0" destOrd="4" presId="urn:microsoft.com/office/officeart/2005/8/layout/hList1"/>
+    <dgm:cxn modelId="{9FB4D4B0-DAF9-4D63-BFA5-2042F9E22DFC}" type="presOf" srcId="{4700AFBE-57B8-4F45-85FC-78D11916CE41}" destId="{6418F341-AB79-40AC-B83F-0228C41F0524}" srcOrd="0" destOrd="5" presId="urn:microsoft.com/office/officeart/2005/8/layout/hList1"/>
     <dgm:cxn modelId="{3F0E60BA-2CB3-4554-AA2D-CCC7DDF0A365}" srcId="{7039D912-74EB-4508-A920-7B182744F6DB}" destId="{80A0FD3E-C6A0-4AC0-BEE3-F3D680FFDAD0}" srcOrd="0" destOrd="0" parTransId="{154B9B54-5D30-4E28-8681-5934842B5FBB}" sibTransId="{EFC7F8D0-9924-4CF0-859E-271812450D6A}"/>
     <dgm:cxn modelId="{2D518CBB-959F-4128-BEF7-70D4BF4546B9}" srcId="{7039D912-74EB-4508-A920-7B182744F6DB}" destId="{7AF5FCE1-11D6-46FB-8B9D-23C7E613916E}" srcOrd="1" destOrd="0" parTransId="{740CD777-E294-48B6-90F3-B3CEC219F2C4}" sibTransId="{C3102B43-D99C-4965-8C40-204A9F62CBC0}"/>
     <dgm:cxn modelId="{B8BB1DBC-DCF9-45E4-A9CB-F20700E5AC91}" type="presOf" srcId="{C55CDAA4-0A7B-4072-9CD3-6D7896772C6F}" destId="{7FD399BC-E510-491B-A043-67ACAEEF2E3C}" srcOrd="0" destOrd="2" presId="urn:microsoft.com/office/officeart/2005/8/layout/hList1"/>
@@ -5422,6 +5464,7 @@
     <dgm:cxn modelId="{A66959CA-0A49-47BE-80E8-FFFE5975A6C5}" srcId="{007B146B-7043-4DA4-9872-F19B6C46FDB4}" destId="{DB82E421-8B43-400F-B820-4E5E46890ACB}" srcOrd="1" destOrd="0" parTransId="{B3C3E713-BA38-4F09-9DB9-B14F0187D506}" sibTransId="{7330DEA7-B961-43C2-BBE9-ACA2D8ECB655}"/>
     <dgm:cxn modelId="{78C996D1-9E72-49F5-AB9C-2C2B83D0DE17}" srcId="{6659A7E7-8158-4A6E-A471-DA323965CCE9}" destId="{88EF3DC1-C7EB-42FB-8165-F41505DC47A3}" srcOrd="6" destOrd="0" parTransId="{79420B54-54CF-4606-A37C-1265DA7D9C5D}" sibTransId="{25327A15-6A41-432C-B6BA-788D84B2D7D4}"/>
     <dgm:cxn modelId="{9DCB9FE5-DD06-48A2-A44A-B1DC9C7CF1CB}" srcId="{6659A7E7-8158-4A6E-A471-DA323965CCE9}" destId="{6992C787-FC19-4B56-B86B-85751586ED68}" srcOrd="4" destOrd="0" parTransId="{A98B85C6-1E8C-4647-9359-DAA18747BAC1}" sibTransId="{EC823E0B-2B97-4EC1-87E0-FDEB74036751}"/>
+    <dgm:cxn modelId="{1C102DE7-3811-4E71-A3D4-7D3451720805}" srcId="{7AF5FCE1-11D6-46FB-8B9D-23C7E613916E}" destId="{EC6B208F-AA07-4878-9479-15F07D0A00F0}" srcOrd="1" destOrd="0" parTransId="{46D7FAB6-E954-41BA-B72C-810F09D29662}" sibTransId="{B4302993-1B23-4872-8714-D974D5F5192F}"/>
     <dgm:cxn modelId="{E1EA81ED-FE5B-4917-880A-0CA09B45A253}" srcId="{90460D4B-7138-4725-ADD6-E6EC2A7BF7EC}" destId="{C55CDAA4-0A7B-4072-9CD3-6D7896772C6F}" srcOrd="0" destOrd="0" parTransId="{CDF5DCCF-2E2A-4296-AD6C-ABE6E27E5F15}" sibTransId="{12918B51-1EE7-4110-A777-AFBA2DE18C29}"/>
     <dgm:cxn modelId="{99924AF0-07D7-4D56-A77D-BBD5261EAA59}" srcId="{7039D912-74EB-4508-A920-7B182744F6DB}" destId="{E53FD2FB-F572-421B-BB4D-59CD3C203DA6}" srcOrd="2" destOrd="0" parTransId="{252CD36A-2224-4DE0-B794-720E6D43E594}" sibTransId="{B316E1F1-06D1-4214-AA2E-AFE057B76A4B}"/>
     <dgm:cxn modelId="{C39B41F2-7752-4B76-B5E3-BE83612F50B2}" srcId="{6659A7E7-8158-4A6E-A471-DA323965CCE9}" destId="{A1FD628F-B8FF-43A2-8AB5-11FF7C2A601C}" srcOrd="0" destOrd="0" parTransId="{DD71F879-133C-4350-AFBB-C943DF617CAC}" sibTransId="{04649C6A-C328-4F3F-96D0-2871A85AEF53}"/>
@@ -7353,8 +7396,8 @@
       </dsp:nvSpPr>
       <dsp:spPr>
         <a:xfrm>
-          <a:off x="4282" y="236909"/>
-          <a:ext cx="2575156" cy="432000"/>
+          <a:off x="4282" y="88727"/>
+          <a:ext cx="2575156" cy="518400"/>
         </a:xfrm>
         <a:prstGeom prst="rect">
           <a:avLst/>
@@ -7396,12 +7439,12 @@
         </a:fontRef>
       </dsp:style>
       <dsp:txBody>
-        <a:bodyPr spcFirstLastPara="0" vert="horz" wrap="square" lIns="106680" tIns="60960" rIns="106680" bIns="60960" numCol="1" spcCol="1270" anchor="ctr" anchorCtr="0">
+        <a:bodyPr spcFirstLastPara="0" vert="horz" wrap="square" lIns="128016" tIns="73152" rIns="128016" bIns="73152" numCol="1" spcCol="1270" anchor="ctr" anchorCtr="0">
           <a:noAutofit/>
         </a:bodyPr>
         <a:lstStyle/>
         <a:p>
-          <a:pPr marL="0" lvl="0" indent="0" algn="ctr" defTabSz="666750">
+          <a:pPr marL="0" lvl="0" indent="0" algn="ctr" defTabSz="800100">
             <a:lnSpc>
               <a:spcPct val="90000"/>
             </a:lnSpc>
@@ -7414,14 +7457,14 @@
             <a:buNone/>
           </a:pPr>
           <a:r>
-            <a:rPr lang="en-US" sz="1500" kern="1200" dirty="0"/>
+            <a:rPr lang="en-US" sz="1800" kern="1200" dirty="0"/>
             <a:t>Project Asset</a:t>
           </a:r>
         </a:p>
       </dsp:txBody>
       <dsp:txXfrm>
-        <a:off x="4282" y="236909"/>
-        <a:ext cx="2575156" cy="432000"/>
+        <a:off x="4282" y="88727"/>
+        <a:ext cx="2575156" cy="518400"/>
       </dsp:txXfrm>
     </dsp:sp>
     <dsp:sp modelId="{3116BB5E-4752-4A55-AB69-BB802C942660}">
@@ -7431,8 +7474,8 @@
       </dsp:nvSpPr>
       <dsp:spPr>
         <a:xfrm>
-          <a:off x="4282" y="668909"/>
-          <a:ext cx="2575156" cy="3149887"/>
+          <a:off x="4282" y="607127"/>
+          <a:ext cx="2575156" cy="4619834"/>
         </a:xfrm>
         <a:prstGeom prst="rect">
           <a:avLst/>
@@ -7476,12 +7519,12 @@
         <a:fontRef idx="minor"/>
       </dsp:style>
       <dsp:txBody>
-        <a:bodyPr spcFirstLastPara="0" vert="horz" wrap="square" lIns="80010" tIns="80010" rIns="106680" bIns="120015" numCol="1" spcCol="1270" anchor="t" anchorCtr="0">
+        <a:bodyPr spcFirstLastPara="0" vert="horz" wrap="square" lIns="96012" tIns="96012" rIns="128016" bIns="144018" numCol="1" spcCol="1270" anchor="t" anchorCtr="0">
           <a:noAutofit/>
         </a:bodyPr>
         <a:lstStyle/>
         <a:p>
-          <a:pPr marL="114300" lvl="1" indent="-114300" algn="l" defTabSz="666750">
+          <a:pPr marL="171450" lvl="1" indent="-171450" algn="l" defTabSz="800100">
             <a:lnSpc>
               <a:spcPct val="90000"/>
             </a:lnSpc>
@@ -7494,12 +7537,12 @@
             <a:buChar char="•"/>
           </a:pPr>
           <a:r>
-            <a:rPr lang="en-US" sz="1500" kern="1200" dirty="0"/>
+            <a:rPr lang="en-US" sz="1800" kern="1200" dirty="0"/>
             <a:t>Assets that the game developer operates on.</a:t>
           </a:r>
         </a:p>
         <a:p>
-          <a:pPr marL="114300" lvl="1" indent="-114300" algn="l" defTabSz="666750">
+          <a:pPr marL="171450" lvl="1" indent="-171450" algn="l" defTabSz="800100">
             <a:lnSpc>
               <a:spcPct val="90000"/>
             </a:lnSpc>
@@ -7512,12 +7555,12 @@
             <a:buChar char="•"/>
           </a:pPr>
           <a:r>
-            <a:rPr lang="en-US" sz="1500" kern="1200" dirty="0"/>
+            <a:rPr lang="en-US" sz="1800" kern="1200" dirty="0"/>
             <a:t>Components:</a:t>
           </a:r>
         </a:p>
         <a:p>
-          <a:pPr marL="228600" lvl="2" indent="-114300" algn="l" defTabSz="666750">
+          <a:pPr marL="342900" lvl="2" indent="-171450" algn="l" defTabSz="800100">
             <a:lnSpc>
               <a:spcPct val="90000"/>
             </a:lnSpc>
@@ -7530,13 +7573,13 @@
             <a:buChar char="•"/>
           </a:pPr>
           <a:r>
-            <a:rPr lang="en-US" sz="1500" kern="1200" dirty="0" err="1"/>
+            <a:rPr lang="en-US" sz="1800" kern="1200" dirty="0" err="1"/>
             <a:t>ACAssetType</a:t>
           </a:r>
-          <a:endParaRPr lang="en-US" sz="1500" kern="1200" dirty="0"/>
+          <a:endParaRPr lang="en-US" sz="1800" kern="1200" dirty="0"/>
         </a:p>
         <a:p>
-          <a:pPr marL="228600" lvl="2" indent="-114300" algn="l" defTabSz="666750">
+          <a:pPr marL="342900" lvl="2" indent="-171450" algn="l" defTabSz="800100">
             <a:lnSpc>
               <a:spcPct val="90000"/>
             </a:lnSpc>
@@ -7549,12 +7592,12 @@
             <a:buChar char="•"/>
           </a:pPr>
           <a:r>
-            <a:rPr lang="en-US" sz="1500" kern="1200" dirty="0"/>
+            <a:rPr lang="en-US" sz="1800" kern="1200" dirty="0"/>
             <a:t>ACUUID</a:t>
           </a:r>
         </a:p>
         <a:p>
-          <a:pPr marL="228600" lvl="2" indent="-114300" algn="l" defTabSz="666750">
+          <a:pPr marL="342900" lvl="2" indent="-171450" algn="l" defTabSz="800100">
             <a:lnSpc>
               <a:spcPct val="90000"/>
             </a:lnSpc>
@@ -7567,13 +7610,13 @@
             <a:buChar char="•"/>
           </a:pPr>
           <a:r>
-            <a:rPr lang="en-US" sz="1500" kern="1200" dirty="0" err="1"/>
+            <a:rPr lang="en-US" sz="1800" kern="1200" dirty="0" err="1"/>
             <a:t>ACFilepath</a:t>
           </a:r>
-          <a:endParaRPr lang="en-US" sz="1500" kern="1200" dirty="0"/>
+          <a:endParaRPr lang="en-US" sz="1800" kern="1200" dirty="0"/>
         </a:p>
         <a:p>
-          <a:pPr marL="228600" lvl="2" indent="-114300" algn="l" defTabSz="666750">
+          <a:pPr marL="342900" lvl="2" indent="-171450" algn="l" defTabSz="800100">
             <a:lnSpc>
               <a:spcPct val="90000"/>
             </a:lnSpc>
@@ -7586,13 +7629,13 @@
             <a:buChar char="•"/>
           </a:pPr>
           <a:r>
-            <a:rPr lang="en-US" sz="1500" kern="1200" dirty="0" err="1"/>
+            <a:rPr lang="en-US" sz="1800" kern="1200" dirty="0" err="1"/>
             <a:t>ACSourceFilepath</a:t>
           </a:r>
-          <a:endParaRPr lang="en-US" sz="1500" kern="1200" dirty="0"/>
+          <a:endParaRPr lang="en-US" sz="1800" kern="1200" dirty="0"/>
         </a:p>
         <a:p>
-          <a:pPr marL="228600" lvl="2" indent="-114300" algn="l" defTabSz="666750">
+          <a:pPr marL="342900" lvl="2" indent="-171450" algn="l" defTabSz="800100">
             <a:lnSpc>
               <a:spcPct val="90000"/>
             </a:lnSpc>
@@ -7605,13 +7648,13 @@
             <a:buChar char="•"/>
           </a:pPr>
           <a:r>
-            <a:rPr lang="en-US" sz="1500" kern="1200" dirty="0" err="1"/>
+            <a:rPr lang="en-US" sz="1800" kern="1200" dirty="0" err="1"/>
             <a:t>ACRefsCounters</a:t>
           </a:r>
-          <a:endParaRPr lang="en-US" sz="1500" kern="1200" dirty="0"/>
+          <a:endParaRPr lang="en-US" sz="1800" kern="1200" dirty="0"/>
         </a:p>
         <a:p>
-          <a:pPr marL="228600" lvl="2" indent="-114300" algn="l" defTabSz="666750">
+          <a:pPr marL="342900" lvl="2" indent="-171450" algn="l" defTabSz="800100">
             <a:lnSpc>
               <a:spcPct val="90000"/>
             </a:lnSpc>
@@ -7624,13 +7667,13 @@
             <a:buChar char="•"/>
           </a:pPr>
           <a:r>
-            <a:rPr lang="en-US" sz="1500" kern="1200" dirty="0" err="1"/>
+            <a:rPr lang="en-US" sz="1800" kern="1200" dirty="0" err="1"/>
             <a:t>CoreComponent</a:t>
           </a:r>
-          <a:endParaRPr lang="en-US" sz="1500" kern="1200" dirty="0"/>
+          <a:endParaRPr lang="en-US" sz="1800" kern="1200" dirty="0"/>
         </a:p>
         <a:p>
-          <a:pPr marL="228600" lvl="2" indent="-114300" algn="l" defTabSz="666750">
+          <a:pPr marL="342900" lvl="2" indent="-171450" algn="l" defTabSz="800100">
             <a:lnSpc>
               <a:spcPct val="90000"/>
             </a:lnSpc>
@@ -7643,14 +7686,14 @@
             <a:buChar char="•"/>
           </a:pPr>
           <a:r>
-            <a:rPr lang="en-US" sz="1500" kern="1200" dirty="0"/>
+            <a:rPr lang="en-US" sz="1800" kern="1200" dirty="0"/>
             <a:t>other, asset type specific components</a:t>
           </a:r>
         </a:p>
       </dsp:txBody>
       <dsp:txXfrm>
-        <a:off x="4282" y="668909"/>
-        <a:ext cx="2575156" cy="3149887"/>
+        <a:off x="4282" y="607127"/>
+        <a:ext cx="2575156" cy="4619834"/>
       </dsp:txXfrm>
     </dsp:sp>
     <dsp:sp modelId="{E09129F2-95E6-4C8B-BC91-BBC3BDA85498}">
@@ -7660,8 +7703,8 @@
       </dsp:nvSpPr>
       <dsp:spPr>
         <a:xfrm>
-          <a:off x="2939961" y="236909"/>
-          <a:ext cx="2575156" cy="432000"/>
+          <a:off x="2939961" y="88727"/>
+          <a:ext cx="2575156" cy="518400"/>
         </a:xfrm>
         <a:prstGeom prst="rect">
           <a:avLst/>
@@ -7703,12 +7746,12 @@
         </a:fontRef>
       </dsp:style>
       <dsp:txBody>
-        <a:bodyPr spcFirstLastPara="0" vert="horz" wrap="square" lIns="106680" tIns="60960" rIns="106680" bIns="60960" numCol="1" spcCol="1270" anchor="ctr" anchorCtr="0">
+        <a:bodyPr spcFirstLastPara="0" vert="horz" wrap="square" lIns="128016" tIns="73152" rIns="128016" bIns="73152" numCol="1" spcCol="1270" anchor="ctr" anchorCtr="0">
           <a:noAutofit/>
         </a:bodyPr>
         <a:lstStyle/>
         <a:p>
-          <a:pPr marL="0" lvl="0" indent="0" algn="ctr" defTabSz="666750">
+          <a:pPr marL="0" lvl="0" indent="0" algn="ctr" defTabSz="800100">
             <a:lnSpc>
               <a:spcPct val="90000"/>
             </a:lnSpc>
@@ -7721,14 +7764,14 @@
             <a:buNone/>
           </a:pPr>
           <a:r>
-            <a:rPr lang="en-US" sz="1500" kern="1200" dirty="0"/>
+            <a:rPr lang="en-US" sz="1800" kern="1200" dirty="0"/>
             <a:t>Internal Asset</a:t>
           </a:r>
         </a:p>
       </dsp:txBody>
       <dsp:txXfrm>
-        <a:off x="2939961" y="236909"/>
-        <a:ext cx="2575156" cy="432000"/>
+        <a:off x="2939961" y="88727"/>
+        <a:ext cx="2575156" cy="518400"/>
       </dsp:txXfrm>
     </dsp:sp>
     <dsp:sp modelId="{6418F341-AB79-40AC-B83F-0228C41F0524}">
@@ -7738,8 +7781,8 @@
       </dsp:nvSpPr>
       <dsp:spPr>
         <a:xfrm>
-          <a:off x="2939961" y="668909"/>
-          <a:ext cx="2575156" cy="3149887"/>
+          <a:off x="2939961" y="607127"/>
+          <a:ext cx="2575156" cy="4619834"/>
         </a:xfrm>
         <a:prstGeom prst="rect">
           <a:avLst/>
@@ -7783,12 +7826,12 @@
         <a:fontRef idx="minor"/>
       </dsp:style>
       <dsp:txBody>
-        <a:bodyPr spcFirstLastPara="0" vert="horz" wrap="square" lIns="80010" tIns="80010" rIns="106680" bIns="120015" numCol="1" spcCol="1270" anchor="t" anchorCtr="0">
+        <a:bodyPr spcFirstLastPara="0" vert="horz" wrap="square" lIns="96012" tIns="96012" rIns="128016" bIns="144018" numCol="1" spcCol="1270" anchor="t" anchorCtr="0">
           <a:noAutofit/>
         </a:bodyPr>
         <a:lstStyle/>
         <a:p>
-          <a:pPr marL="114300" lvl="1" indent="-114300" algn="l" defTabSz="666750">
+          <a:pPr marL="171450" lvl="1" indent="-171450" algn="l" defTabSz="800100">
             <a:lnSpc>
               <a:spcPct val="90000"/>
             </a:lnSpc>
@@ -7801,12 +7844,16 @@
             <a:buChar char="•"/>
           </a:pPr>
           <a:r>
-            <a:rPr lang="en-US" sz="1500" kern="1200" dirty="0"/>
-            <a:t>Assets often contain references to other assets. Internal assets are only ever referenced by other assets. Fully hidden from the user.</a:t>
+            <a:rPr lang="en-US" sz="1800" kern="1200" dirty="0"/>
+            <a:t>Internal Assets are only ever referenced by other asset</a:t>
+          </a:r>
+          <a:r>
+            <a:rPr lang="en-US" sz="1800" kern="1200" noProof="0" dirty="0"/>
+            <a:t>s. They are conceptually parts of Project Assets and they get imported together.</a:t>
           </a:r>
         </a:p>
         <a:p>
-          <a:pPr marL="114300" lvl="1" indent="-114300" algn="l" defTabSz="666750">
+          <a:pPr marL="171450" lvl="1" indent="-171450" algn="l" defTabSz="800100">
             <a:lnSpc>
               <a:spcPct val="90000"/>
             </a:lnSpc>
@@ -7819,12 +7866,13 @@
             <a:buChar char="•"/>
           </a:pPr>
           <a:r>
-            <a:rPr lang="en-US" sz="1500" kern="1200" dirty="0"/>
-            <a:t>Components:</a:t>
+            <a:rPr lang="en-US" sz="1800" kern="1200" dirty="0"/>
+            <a:t>Fully hidden from the user.</a:t>
           </a:r>
+          <a:endParaRPr lang="en-US" sz="1800" kern="1200" noProof="0" dirty="0"/>
         </a:p>
         <a:p>
-          <a:pPr marL="228600" lvl="2" indent="-114300" algn="l" defTabSz="666750">
+          <a:pPr marL="171450" lvl="1" indent="-171450" algn="l" defTabSz="800100">
             <a:lnSpc>
               <a:spcPct val="90000"/>
             </a:lnSpc>
@@ -7837,13 +7885,12 @@
             <a:buChar char="•"/>
           </a:pPr>
           <a:r>
-            <a:rPr lang="en-US" sz="1500" kern="1200" dirty="0" err="1"/>
-            <a:t>ACAssetType</a:t>
+            <a:rPr lang="en-US" sz="1800" kern="1200" dirty="0"/>
+            <a:t>Components:</a:t>
           </a:r>
-          <a:endParaRPr lang="en-US" sz="1500" kern="1200" dirty="0"/>
         </a:p>
         <a:p>
-          <a:pPr marL="228600" lvl="2" indent="-114300" algn="l" defTabSz="666750">
+          <a:pPr marL="342900" lvl="2" indent="-171450" algn="l" defTabSz="800100">
             <a:lnSpc>
               <a:spcPct val="90000"/>
             </a:lnSpc>
@@ -7856,12 +7903,13 @@
             <a:buChar char="•"/>
           </a:pPr>
           <a:r>
-            <a:rPr lang="en-US" sz="1500" kern="1200" dirty="0"/>
-            <a:t>ACUUID</a:t>
+            <a:rPr lang="en-US" sz="1800" kern="1200" dirty="0" err="1"/>
+            <a:t>ACAssetType</a:t>
           </a:r>
+          <a:endParaRPr lang="en-US" sz="1800" kern="1200" dirty="0"/>
         </a:p>
         <a:p>
-          <a:pPr marL="228600" lvl="2" indent="-114300" algn="l" defTabSz="666750">
+          <a:pPr marL="342900" lvl="2" indent="-171450" algn="l" defTabSz="800100">
             <a:lnSpc>
               <a:spcPct val="90000"/>
             </a:lnSpc>
@@ -7874,16 +7922,12 @@
             <a:buChar char="•"/>
           </a:pPr>
           <a:r>
-            <a:rPr lang="en-US" sz="1500" kern="1200" dirty="0" err="1"/>
-            <a:t>ACMasterAsset</a:t>
-          </a:r>
-          <a:r>
-            <a:rPr lang="en-US" sz="1500" kern="1200" dirty="0"/>
-            <a:t> (ref back to Project Asset)</a:t>
+            <a:rPr lang="en-US" sz="1800" kern="1200" dirty="0"/>
+            <a:t>ACUUID</a:t>
           </a:r>
         </a:p>
         <a:p>
-          <a:pPr marL="228600" lvl="2" indent="-114300" algn="l" defTabSz="666750">
+          <a:pPr marL="342900" lvl="2" indent="-171450" algn="l" defTabSz="800100">
             <a:lnSpc>
               <a:spcPct val="90000"/>
             </a:lnSpc>
@@ -7896,13 +7940,16 @@
             <a:buChar char="•"/>
           </a:pPr>
           <a:r>
-            <a:rPr lang="en-US" sz="1500" kern="1200" dirty="0" err="1"/>
-            <a:t>CoreComponent</a:t>
+            <a:rPr lang="en-US" sz="1800" kern="1200" dirty="0" err="1"/>
+            <a:t>ACMasterAsset</a:t>
           </a:r>
-          <a:endParaRPr lang="en-US" sz="1500" kern="1200" dirty="0"/>
+          <a:r>
+            <a:rPr lang="en-US" sz="1800" kern="1200" dirty="0"/>
+            <a:t> (ref back to Project Asset)</a:t>
+          </a:r>
         </a:p>
         <a:p>
-          <a:pPr marL="228600" lvl="2" indent="-114300" algn="l" defTabSz="666750">
+          <a:pPr marL="342900" lvl="2" indent="-171450" algn="l" defTabSz="800100">
             <a:lnSpc>
               <a:spcPct val="90000"/>
             </a:lnSpc>
@@ -7915,14 +7962,33 @@
             <a:buChar char="•"/>
           </a:pPr>
           <a:r>
-            <a:rPr lang="en-US" sz="1500" kern="1200" dirty="0"/>
+            <a:rPr lang="en-US" sz="1800" kern="1200" dirty="0" err="1"/>
+            <a:t>CoreComponent</a:t>
+          </a:r>
+          <a:endParaRPr lang="en-US" sz="1800" kern="1200" dirty="0"/>
+        </a:p>
+        <a:p>
+          <a:pPr marL="342900" lvl="2" indent="-171450" algn="l" defTabSz="800100">
+            <a:lnSpc>
+              <a:spcPct val="90000"/>
+            </a:lnSpc>
+            <a:spcBef>
+              <a:spcPct val="0"/>
+            </a:spcBef>
+            <a:spcAft>
+              <a:spcPct val="15000"/>
+            </a:spcAft>
+            <a:buChar char="•"/>
+          </a:pPr>
+          <a:r>
+            <a:rPr lang="en-US" sz="1800" kern="1200" dirty="0"/>
             <a:t>other, asset type specific components</a:t>
           </a:r>
         </a:p>
       </dsp:txBody>
       <dsp:txXfrm>
-        <a:off x="2939961" y="668909"/>
-        <a:ext cx="2575156" cy="3149887"/>
+        <a:off x="2939961" y="607127"/>
+        <a:ext cx="2575156" cy="4619834"/>
       </dsp:txXfrm>
     </dsp:sp>
     <dsp:sp modelId="{A97189DC-B62A-4226-BE84-683C8D0EEFD3}">
@@ -7932,8 +7998,8 @@
       </dsp:nvSpPr>
       <dsp:spPr>
         <a:xfrm>
-          <a:off x="5875640" y="236909"/>
-          <a:ext cx="2575156" cy="432000"/>
+          <a:off x="5875640" y="88727"/>
+          <a:ext cx="2575156" cy="518400"/>
         </a:xfrm>
         <a:prstGeom prst="rect">
           <a:avLst/>
@@ -7975,12 +8041,12 @@
         </a:fontRef>
       </dsp:style>
       <dsp:txBody>
-        <a:bodyPr spcFirstLastPara="0" vert="horz" wrap="square" lIns="106680" tIns="60960" rIns="106680" bIns="60960" numCol="1" spcCol="1270" anchor="ctr" anchorCtr="0">
+        <a:bodyPr spcFirstLastPara="0" vert="horz" wrap="square" lIns="128016" tIns="73152" rIns="128016" bIns="73152" numCol="1" spcCol="1270" anchor="ctr" anchorCtr="0">
           <a:noAutofit/>
         </a:bodyPr>
         <a:lstStyle/>
         <a:p>
-          <a:pPr marL="0" lvl="0" indent="0" algn="ctr" defTabSz="666750">
+          <a:pPr marL="0" lvl="0" indent="0" algn="ctr" defTabSz="800100">
             <a:lnSpc>
               <a:spcPct val="90000"/>
             </a:lnSpc>
@@ -7993,14 +8059,14 @@
             <a:buNone/>
           </a:pPr>
           <a:r>
-            <a:rPr lang="en-US" sz="1500" kern="1200" dirty="0"/>
+            <a:rPr lang="en-US" sz="1800" kern="1200" dirty="0"/>
             <a:t>Editor Asset</a:t>
           </a:r>
         </a:p>
       </dsp:txBody>
       <dsp:txXfrm>
-        <a:off x="5875640" y="236909"/>
-        <a:ext cx="2575156" cy="432000"/>
+        <a:off x="5875640" y="88727"/>
+        <a:ext cx="2575156" cy="518400"/>
       </dsp:txXfrm>
     </dsp:sp>
     <dsp:sp modelId="{2B7C4BE8-A646-4433-9446-B88A77065CA4}">
@@ -8010,8 +8076,8 @@
       </dsp:nvSpPr>
       <dsp:spPr>
         <a:xfrm>
-          <a:off x="5875640" y="668909"/>
-          <a:ext cx="2575156" cy="3149887"/>
+          <a:off x="5875640" y="607127"/>
+          <a:ext cx="2575156" cy="4619834"/>
         </a:xfrm>
         <a:prstGeom prst="rect">
           <a:avLst/>
@@ -8055,12 +8121,12 @@
         <a:fontRef idx="minor"/>
       </dsp:style>
       <dsp:txBody>
-        <a:bodyPr spcFirstLastPara="0" vert="horz" wrap="square" lIns="80010" tIns="80010" rIns="106680" bIns="120015" numCol="1" spcCol="1270" anchor="t" anchorCtr="0">
+        <a:bodyPr spcFirstLastPara="0" vert="horz" wrap="square" lIns="96012" tIns="96012" rIns="128016" bIns="144018" numCol="1" spcCol="1270" anchor="t" anchorCtr="0">
           <a:noAutofit/>
         </a:bodyPr>
         <a:lstStyle/>
         <a:p>
-          <a:pPr marL="114300" lvl="1" indent="-114300" algn="l" defTabSz="666750">
+          <a:pPr marL="171450" lvl="1" indent="-171450" algn="l" defTabSz="800100">
             <a:lnSpc>
               <a:spcPct val="90000"/>
             </a:lnSpc>
@@ -8073,12 +8139,12 @@
             <a:buChar char="•"/>
           </a:pPr>
           <a:r>
-            <a:rPr lang="en-US" sz="1500" kern="1200" dirty="0"/>
+            <a:rPr lang="en-US" sz="1800" kern="1200" dirty="0"/>
             <a:t>Assets used by only by editor (e.g. icons).</a:t>
           </a:r>
         </a:p>
         <a:p>
-          <a:pPr marL="114300" lvl="1" indent="-114300" algn="l" defTabSz="666750">
+          <a:pPr marL="171450" lvl="1" indent="-171450" algn="l" defTabSz="800100">
             <a:lnSpc>
               <a:spcPct val="90000"/>
             </a:lnSpc>
@@ -8091,12 +8157,12 @@
             <a:buChar char="•"/>
           </a:pPr>
           <a:r>
-            <a:rPr lang="en-US" sz="1500" kern="1200" dirty="0"/>
+            <a:rPr lang="en-US" sz="1800" kern="1200" dirty="0"/>
             <a:t>Components</a:t>
           </a:r>
         </a:p>
         <a:p>
-          <a:pPr marL="228600" lvl="2" indent="-114300" algn="l" defTabSz="666750">
+          <a:pPr marL="342900" lvl="2" indent="-171450" algn="l" defTabSz="800100">
             <a:lnSpc>
               <a:spcPct val="90000"/>
             </a:lnSpc>
@@ -8109,13 +8175,13 @@
             <a:buChar char="•"/>
           </a:pPr>
           <a:r>
-            <a:rPr lang="en-US" sz="1500" kern="1200" dirty="0" err="1"/>
+            <a:rPr lang="en-US" sz="1800" kern="1200" dirty="0" err="1"/>
             <a:t>ACAssetType</a:t>
           </a:r>
-          <a:endParaRPr lang="en-US" sz="1500" kern="1200" dirty="0"/>
+          <a:endParaRPr lang="en-US" sz="1800" kern="1200" dirty="0"/>
         </a:p>
         <a:p>
-          <a:pPr marL="228600" lvl="2" indent="-114300" algn="l" defTabSz="666750">
+          <a:pPr marL="342900" lvl="2" indent="-171450" algn="l" defTabSz="800100">
             <a:lnSpc>
               <a:spcPct val="90000"/>
             </a:lnSpc>
@@ -8128,13 +8194,13 @@
             <a:buChar char="•"/>
           </a:pPr>
           <a:r>
-            <a:rPr lang="en-US" sz="1500" kern="1200" dirty="0" err="1"/>
+            <a:rPr lang="en-US" sz="1800" kern="1200" dirty="0" err="1"/>
             <a:t>CoreComponent</a:t>
           </a:r>
-          <a:endParaRPr lang="en-US" sz="1500" kern="1200" dirty="0"/>
+          <a:endParaRPr lang="en-US" sz="1800" kern="1200" dirty="0"/>
         </a:p>
         <a:p>
-          <a:pPr marL="228600" lvl="2" indent="-114300" algn="l" defTabSz="666750">
+          <a:pPr marL="342900" lvl="2" indent="-171450" algn="l" defTabSz="800100">
             <a:lnSpc>
               <a:spcPct val="90000"/>
             </a:lnSpc>
@@ -8147,14 +8213,14 @@
             <a:buChar char="•"/>
           </a:pPr>
           <a:r>
-            <a:rPr lang="en-US" sz="1500" kern="1200" dirty="0"/>
+            <a:rPr lang="en-US" sz="1800" kern="1200" dirty="0"/>
             <a:t>other, asset type specific components</a:t>
           </a:r>
         </a:p>
       </dsp:txBody>
       <dsp:txXfrm>
-        <a:off x="5875640" y="668909"/>
-        <a:ext cx="2575156" cy="3149887"/>
+        <a:off x="5875640" y="607127"/>
+        <a:ext cx="2575156" cy="4619834"/>
       </dsp:txXfrm>
     </dsp:sp>
     <dsp:sp modelId="{18D4A536-73DC-492C-A34F-711BC80D73A7}">
@@ -8164,8 +8230,8 @@
       </dsp:nvSpPr>
       <dsp:spPr>
         <a:xfrm>
-          <a:off x="8811319" y="236909"/>
-          <a:ext cx="2575156" cy="432000"/>
+          <a:off x="8811319" y="88727"/>
+          <a:ext cx="2575156" cy="518400"/>
         </a:xfrm>
         <a:prstGeom prst="rect">
           <a:avLst/>
@@ -8207,12 +8273,12 @@
         </a:fontRef>
       </dsp:style>
       <dsp:txBody>
-        <a:bodyPr spcFirstLastPara="0" vert="horz" wrap="square" lIns="106680" tIns="60960" rIns="106680" bIns="60960" numCol="1" spcCol="1270" anchor="ctr" anchorCtr="0">
+        <a:bodyPr spcFirstLastPara="0" vert="horz" wrap="square" lIns="128016" tIns="73152" rIns="128016" bIns="73152" numCol="1" spcCol="1270" anchor="ctr" anchorCtr="0">
           <a:noAutofit/>
         </a:bodyPr>
         <a:lstStyle/>
         <a:p>
-          <a:pPr marL="0" lvl="0" indent="0" algn="ctr" defTabSz="666750">
+          <a:pPr marL="0" lvl="0" indent="0" algn="ctr" defTabSz="800100">
             <a:lnSpc>
               <a:spcPct val="90000"/>
             </a:lnSpc>
@@ -8225,14 +8291,14 @@
             <a:buNone/>
           </a:pPr>
           <a:r>
-            <a:rPr lang="en-US" sz="1500" kern="1200" dirty="0"/>
+            <a:rPr lang="en-US" sz="1800" kern="1200" dirty="0"/>
             <a:t>Base Asset</a:t>
           </a:r>
         </a:p>
       </dsp:txBody>
       <dsp:txXfrm>
-        <a:off x="8811319" y="236909"/>
-        <a:ext cx="2575156" cy="432000"/>
+        <a:off x="8811319" y="88727"/>
+        <a:ext cx="2575156" cy="518400"/>
       </dsp:txXfrm>
     </dsp:sp>
     <dsp:sp modelId="{7FD399BC-E510-491B-A043-67ACAEEF2E3C}">
@@ -8242,8 +8308,8 @@
       </dsp:nvSpPr>
       <dsp:spPr>
         <a:xfrm>
-          <a:off x="8811319" y="668909"/>
-          <a:ext cx="2575156" cy="3149887"/>
+          <a:off x="8811319" y="607127"/>
+          <a:ext cx="2575156" cy="4619834"/>
         </a:xfrm>
         <a:prstGeom prst="rect">
           <a:avLst/>
@@ -8287,12 +8353,12 @@
         <a:fontRef idx="minor"/>
       </dsp:style>
       <dsp:txBody>
-        <a:bodyPr spcFirstLastPara="0" vert="horz" wrap="square" lIns="80010" tIns="80010" rIns="106680" bIns="120015" numCol="1" spcCol="1270" anchor="t" anchorCtr="0">
+        <a:bodyPr spcFirstLastPara="0" vert="horz" wrap="square" lIns="96012" tIns="96012" rIns="128016" bIns="144018" numCol="1" spcCol="1270" anchor="t" anchorCtr="0">
           <a:noAutofit/>
         </a:bodyPr>
         <a:lstStyle/>
         <a:p>
-          <a:pPr marL="114300" lvl="1" indent="-114300" algn="l" defTabSz="666750">
+          <a:pPr marL="171450" lvl="1" indent="-171450" algn="l" defTabSz="800100">
             <a:lnSpc>
               <a:spcPct val="90000"/>
             </a:lnSpc>
@@ -8305,12 +8371,12 @@
             <a:buChar char="•"/>
           </a:pPr>
           <a:r>
-            <a:rPr lang="en-US" sz="1500" kern="1200" dirty="0"/>
+            <a:rPr lang="en-US" sz="1800" kern="1200" dirty="0"/>
             <a:t>Assets build-in to the engine used by default.</a:t>
           </a:r>
         </a:p>
         <a:p>
-          <a:pPr marL="114300" lvl="1" indent="-114300" algn="l" defTabSz="666750">
+          <a:pPr marL="171450" lvl="1" indent="-171450" algn="l" defTabSz="800100">
             <a:lnSpc>
               <a:spcPct val="90000"/>
             </a:lnSpc>
@@ -8323,12 +8389,12 @@
             <a:buChar char="•"/>
           </a:pPr>
           <a:r>
-            <a:rPr lang="en-US" sz="1500" kern="1200" dirty="0"/>
+            <a:rPr lang="en-US" sz="1800" kern="1200" dirty="0"/>
             <a:t>Components</a:t>
           </a:r>
         </a:p>
         <a:p>
-          <a:pPr marL="228600" lvl="2" indent="-114300" algn="l" defTabSz="666750">
+          <a:pPr marL="342900" lvl="2" indent="-171450" algn="l" defTabSz="800100">
             <a:lnSpc>
               <a:spcPct val="90000"/>
             </a:lnSpc>
@@ -8341,13 +8407,13 @@
             <a:buChar char="•"/>
           </a:pPr>
           <a:r>
-            <a:rPr lang="en-US" sz="1500" kern="1200" dirty="0" err="1"/>
+            <a:rPr lang="en-US" sz="1800" kern="1200" dirty="0" err="1"/>
             <a:t>ACAssetType</a:t>
           </a:r>
-          <a:endParaRPr lang="en-US" sz="1500" kern="1200" dirty="0"/>
+          <a:endParaRPr lang="en-US" sz="1800" kern="1200" dirty="0"/>
         </a:p>
         <a:p>
-          <a:pPr marL="228600" lvl="2" indent="-114300" algn="l" defTabSz="666750">
+          <a:pPr marL="342900" lvl="2" indent="-171450" algn="l" defTabSz="800100">
             <a:lnSpc>
               <a:spcPct val="90000"/>
             </a:lnSpc>
@@ -8360,12 +8426,12 @@
             <a:buChar char="•"/>
           </a:pPr>
           <a:r>
-            <a:rPr lang="en-US" sz="1500" kern="1200" dirty="0"/>
+            <a:rPr lang="en-US" sz="1800" kern="1200" dirty="0"/>
             <a:t>ACUUID</a:t>
           </a:r>
         </a:p>
         <a:p>
-          <a:pPr marL="228600" lvl="2" indent="-114300" algn="l" defTabSz="666750">
+          <a:pPr marL="342900" lvl="2" indent="-171450" algn="l" defTabSz="800100">
             <a:lnSpc>
               <a:spcPct val="90000"/>
             </a:lnSpc>
@@ -8378,13 +8444,13 @@
             <a:buChar char="•"/>
           </a:pPr>
           <a:r>
-            <a:rPr lang="en-US" sz="1500" kern="1200" dirty="0" err="1"/>
+            <a:rPr lang="en-US" sz="1800" kern="1200" dirty="0" err="1"/>
             <a:t>ACFilepath</a:t>
           </a:r>
-          <a:endParaRPr lang="en-US" sz="1500" kern="1200" dirty="0"/>
+          <a:endParaRPr lang="en-US" sz="1800" kern="1200" dirty="0"/>
         </a:p>
         <a:p>
-          <a:pPr marL="228600" lvl="2" indent="-114300" algn="l" defTabSz="666750">
+          <a:pPr marL="342900" lvl="2" indent="-171450" algn="l" defTabSz="800100">
             <a:lnSpc>
               <a:spcPct val="90000"/>
             </a:lnSpc>
@@ -8397,13 +8463,13 @@
             <a:buChar char="•"/>
           </a:pPr>
           <a:r>
-            <a:rPr lang="en-US" sz="1500" kern="1200" dirty="0" err="1"/>
+            <a:rPr lang="en-US" sz="1800" kern="1200" dirty="0" err="1"/>
             <a:t>CoreComponent</a:t>
           </a:r>
-          <a:endParaRPr lang="en-US" sz="1500" kern="1200" dirty="0"/>
+          <a:endParaRPr lang="en-US" sz="1800" kern="1200" dirty="0"/>
         </a:p>
         <a:p>
-          <a:pPr marL="228600" lvl="2" indent="-114300" algn="l" defTabSz="666750">
+          <a:pPr marL="342900" lvl="2" indent="-171450" algn="l" defTabSz="800100">
             <a:lnSpc>
               <a:spcPct val="90000"/>
             </a:lnSpc>
@@ -8416,14 +8482,14 @@
             <a:buChar char="•"/>
           </a:pPr>
           <a:r>
-            <a:rPr lang="en-US" sz="1500" kern="1200" dirty="0"/>
+            <a:rPr lang="en-US" sz="1800" kern="1200" dirty="0"/>
             <a:t>other, asset type specific components</a:t>
           </a:r>
         </a:p>
       </dsp:txBody>
       <dsp:txXfrm>
-        <a:off x="8811319" y="668909"/>
-        <a:ext cx="2575156" cy="3149887"/>
+        <a:off x="8811319" y="607127"/>
+        <a:ext cx="2575156" cy="4619834"/>
       </dsp:txXfrm>
     </dsp:sp>
   </dsp:spTree>
@@ -14550,7 +14616,7 @@
           <a:p>
             <a:fld id="{D0E2DD2C-27F7-4F93-96E8-CD28AD9267D9}" type="datetimeFigureOut">
               <a:rPr lang="en-US" smtClean="0"/>
-              <a:t>6/24/2025</a:t>
+              <a:t>6/27/2025</a:t>
             </a:fld>
             <a:endParaRPr lang="en-US"/>
           </a:p>
@@ -15373,7 +15439,7 @@
           <a:p>
             <a:fld id="{783DC7D5-4D76-4679-A391-31CBAFA90932}" type="datetimeFigureOut">
               <a:rPr lang="en-US" smtClean="0"/>
-              <a:t>6/24/2025</a:t>
+              <a:t>6/27/2025</a:t>
             </a:fld>
             <a:endParaRPr lang="en-US"/>
           </a:p>
@@ -15571,7 +15637,7 @@
           <a:p>
             <a:fld id="{783DC7D5-4D76-4679-A391-31CBAFA90932}" type="datetimeFigureOut">
               <a:rPr lang="en-US" smtClean="0"/>
-              <a:t>6/24/2025</a:t>
+              <a:t>6/27/2025</a:t>
             </a:fld>
             <a:endParaRPr lang="en-US"/>
           </a:p>
@@ -15779,7 +15845,7 @@
           <a:p>
             <a:fld id="{783DC7D5-4D76-4679-A391-31CBAFA90932}" type="datetimeFigureOut">
               <a:rPr lang="en-US" smtClean="0"/>
-              <a:t>6/24/2025</a:t>
+              <a:t>6/27/2025</a:t>
             </a:fld>
             <a:endParaRPr lang="en-US"/>
           </a:p>
@@ -15977,7 +16043,7 @@
           <a:p>
             <a:fld id="{783DC7D5-4D76-4679-A391-31CBAFA90932}" type="datetimeFigureOut">
               <a:rPr lang="en-US" smtClean="0"/>
-              <a:t>6/24/2025</a:t>
+              <a:t>6/27/2025</a:t>
             </a:fld>
             <a:endParaRPr lang="en-US"/>
           </a:p>
@@ -16252,7 +16318,7 @@
           <a:p>
             <a:fld id="{783DC7D5-4D76-4679-A391-31CBAFA90932}" type="datetimeFigureOut">
               <a:rPr lang="en-US" smtClean="0"/>
-              <a:t>6/24/2025</a:t>
+              <a:t>6/27/2025</a:t>
             </a:fld>
             <a:endParaRPr lang="en-US"/>
           </a:p>
@@ -16517,7 +16583,7 @@
           <a:p>
             <a:fld id="{783DC7D5-4D76-4679-A391-31CBAFA90932}" type="datetimeFigureOut">
               <a:rPr lang="en-US" smtClean="0"/>
-              <a:t>6/24/2025</a:t>
+              <a:t>6/27/2025</a:t>
             </a:fld>
             <a:endParaRPr lang="en-US"/>
           </a:p>
@@ -16929,7 +16995,7 @@
           <a:p>
             <a:fld id="{783DC7D5-4D76-4679-A391-31CBAFA90932}" type="datetimeFigureOut">
               <a:rPr lang="en-US" smtClean="0"/>
-              <a:t>6/24/2025</a:t>
+              <a:t>6/27/2025</a:t>
             </a:fld>
             <a:endParaRPr lang="en-US"/>
           </a:p>
@@ -17070,7 +17136,7 @@
           <a:p>
             <a:fld id="{783DC7D5-4D76-4679-A391-31CBAFA90932}" type="datetimeFigureOut">
               <a:rPr lang="en-US" smtClean="0"/>
-              <a:t>6/24/2025</a:t>
+              <a:t>6/27/2025</a:t>
             </a:fld>
             <a:endParaRPr lang="en-US"/>
           </a:p>
@@ -17183,7 +17249,7 @@
           <a:p>
             <a:fld id="{783DC7D5-4D76-4679-A391-31CBAFA90932}" type="datetimeFigureOut">
               <a:rPr lang="en-US" smtClean="0"/>
-              <a:t>6/24/2025</a:t>
+              <a:t>6/27/2025</a:t>
             </a:fld>
             <a:endParaRPr lang="en-US"/>
           </a:p>
@@ -17494,7 +17560,7 @@
           <a:p>
             <a:fld id="{783DC7D5-4D76-4679-A391-31CBAFA90932}" type="datetimeFigureOut">
               <a:rPr lang="en-US" smtClean="0"/>
-              <a:t>6/24/2025</a:t>
+              <a:t>6/27/2025</a:t>
             </a:fld>
             <a:endParaRPr lang="en-US"/>
           </a:p>
@@ -17782,7 +17848,7 @@
           <a:p>
             <a:fld id="{783DC7D5-4D76-4679-A391-31CBAFA90932}" type="datetimeFigureOut">
               <a:rPr lang="en-US" smtClean="0"/>
-              <a:t>6/24/2025</a:t>
+              <a:t>6/27/2025</a:t>
             </a:fld>
             <a:endParaRPr lang="en-US"/>
           </a:p>
@@ -18023,7 +18089,7 @@
           <a:p>
             <a:fld id="{783DC7D5-4D76-4679-A391-31CBAFA90932}" type="datetimeFigureOut">
               <a:rPr lang="en-US" smtClean="0"/>
-              <a:t>6/24/2025</a:t>
+              <a:t>6/27/2025</a:t>
             </a:fld>
             <a:endParaRPr lang="en-US"/>
           </a:p>
@@ -21141,14 +21207,14 @@
           <p:nvPr>
             <p:extLst>
               <p:ext uri="{D42A27DB-BD31-4B8C-83A1-F6EECF244321}">
-                <p14:modId xmlns:p14="http://schemas.microsoft.com/office/powerpoint/2010/main" val="4027418349"/>
+                <p14:modId xmlns:p14="http://schemas.microsoft.com/office/powerpoint/2010/main" val="2186092196"/>
               </p:ext>
             </p:extLst>
           </p:nvPr>
         </p:nvGraphicFramePr>
         <p:xfrm>
-          <a:off x="400620" y="1785257"/>
-          <a:ext cx="11390759" cy="4055706"/>
+          <a:off x="400620" y="1182255"/>
+          <a:ext cx="11390759" cy="5315690"/>
         </p:xfrm>
         <a:graphic>
           <a:graphicData uri="http://schemas.openxmlformats.org/drawingml/2006/diagram">
@@ -22683,8 +22749,8 @@
         </p:nvSpPr>
         <p:spPr>
           <a:xfrm>
-            <a:off x="765110" y="4037250"/>
-            <a:ext cx="10661780" cy="369332"/>
+            <a:off x="292963" y="4037250"/>
+            <a:ext cx="11606074" cy="369332"/>
           </a:xfrm>
           <a:prstGeom prst="rect">
             <a:avLst/>
@@ -22700,7 +22766,7 @@
             <a:pPr algn="ctr"/>
             <a:r>
               <a:rPr lang="en-US" dirty="0"/>
-              <a:t>They also have scene components “simulating” their existence – asset views. That allows for runtime dynamism.</a:t>
+              <a:t>They also have scene components “simulating” them – asset views. That allows for runtime dynamic composition.</a:t>
             </a:r>
           </a:p>
         </p:txBody>
@@ -22809,8 +22875,8 @@
         </p:nvSpPr>
         <p:spPr>
           <a:xfrm>
-            <a:off x="431008" y="1590588"/>
-            <a:ext cx="11318290" cy="1138773"/>
+            <a:off x="719091" y="1862198"/>
+            <a:ext cx="10742124" cy="3416320"/>
           </a:xfrm>
           <a:prstGeom prst="rect">
             <a:avLst/>
@@ -22825,148 +22891,63 @@
           <a:p>
             <a:pPr algn="just"/>
             <a:r>
-              <a:rPr lang="en-US" sz="2000" dirty="0"/>
-              <a:t>Centralized streaming:</a:t>
+              <a:rPr lang="en-US" dirty="0"/>
+              <a:t>You can never assume an asset is loaded and there is no explicit asset loading request possibility.</a:t>
             </a:r>
           </a:p>
           <a:p>
             <a:pPr algn="just"/>
             <a:r>
-              <a:rPr lang="en-US" sz="1600" dirty="0"/>
-              <a:t>You can never assume an asset is loaded and there is no explicit asset loading request possibility. Instead, a handle to the asset has a loading priority value - </a:t>
+              <a:rPr lang="en-US" dirty="0"/>
+              <a:t>Instead, a handle to the asset has a loading priority value - </a:t>
             </a:r>
             <a:r>
-              <a:rPr lang="en-US" sz="1600" dirty="0" err="1"/>
+              <a:rPr lang="en-US" dirty="0" err="1"/>
               <a:t>enum</a:t>
             </a:r>
             <a:r>
-              <a:rPr lang="en-US" sz="1600" dirty="0"/>
-              <a:t>. Asset handles of each loading priority are atomically counted in a component of that asset (reference counting). Asset Manager uses those counts to decide centrally which assets to load and unload:</a:t>
+              <a:rPr lang="en-US" dirty="0"/>
+              <a:t>.</a:t>
             </a:r>
           </a:p>
-        </p:txBody>
-      </p:sp>
-      <p:pic>
-        <p:nvPicPr>
-          <p:cNvPr id="13" name="Obraz 12">
-            <a:extLst>
-              <a:ext uri="{FF2B5EF4-FFF2-40B4-BE49-F238E27FC236}">
-                <a16:creationId xmlns:a16="http://schemas.microsoft.com/office/drawing/2014/main" id="{AD2F7317-A225-74F6-A24D-D9A75BD890A2}"/>
-              </a:ext>
-            </a:extLst>
-          </p:cNvPr>
-          <p:cNvPicPr>
-            <a:picLocks noChangeAspect="1"/>
-          </p:cNvPicPr>
-          <p:nvPr/>
-        </p:nvPicPr>
-        <p:blipFill>
-          <a:blip r:embed="rId3"/>
-          <a:stretch>
-            <a:fillRect/>
-          </a:stretch>
-        </p:blipFill>
-        <p:spPr>
-          <a:xfrm>
-            <a:off x="8921619" y="3929834"/>
-            <a:ext cx="2709325" cy="1377753"/>
-          </a:xfrm>
-          <a:prstGeom prst="rect">
-            <a:avLst/>
-          </a:prstGeom>
-        </p:spPr>
-      </p:pic>
-      <p:sp>
-        <p:nvSpPr>
-          <p:cNvPr id="14" name="TextBox 174">
-            <a:extLst>
-              <a:ext uri="{FF2B5EF4-FFF2-40B4-BE49-F238E27FC236}">
-                <a16:creationId xmlns:a16="http://schemas.microsoft.com/office/drawing/2014/main" id="{FC3B3CC7-1C9E-A7B9-E246-AF24F12BB258}"/>
-              </a:ext>
-            </a:extLst>
-          </p:cNvPr>
-          <p:cNvSpPr txBox="1"/>
-          <p:nvPr/>
-        </p:nvSpPr>
-        <p:spPr>
-          <a:xfrm>
-            <a:off x="431008" y="4618710"/>
-            <a:ext cx="7821696" cy="1323439"/>
-          </a:xfrm>
-          <a:prstGeom prst="rect">
-            <a:avLst/>
-          </a:prstGeom>
-          <a:noFill/>
-        </p:spPr>
-        <p:txBody>
-          <a:bodyPr wrap="square" rtlCol="0">
-            <a:spAutoFit/>
-          </a:bodyPr>
-          <a:lstStyle/>
+          <a:p>
+            <a:pPr algn="just"/>
+            <a:endParaRPr lang="en-US" dirty="0"/>
+          </a:p>
           <a:p>
             <a:pPr algn="just"/>
             <a:r>
-              <a:rPr lang="en-US" sz="1600" dirty="0"/>
-              <a:t>Asset loading/unloading and score calculation/sorting runs in an asynchronous loop, but in a foreground (structured concurrency). This makes dynamic adaptive asset loading management much easier and safer (e.g. preloading assets for next level simply by setting their handles from None to Low). There is no need for the user to write asynchronous multithreaded code and still get it’s benefits.</a:t>
-            </a:r>
-          </a:p>
-        </p:txBody>
-      </p:sp>
-      <p:sp>
-        <p:nvSpPr>
-          <p:cNvPr id="15" name="TextBox 174">
-            <a:extLst>
-              <a:ext uri="{FF2B5EF4-FFF2-40B4-BE49-F238E27FC236}">
-                <a16:creationId xmlns:a16="http://schemas.microsoft.com/office/drawing/2014/main" id="{067B7CED-B707-54A5-6971-56978590A6DF}"/>
-              </a:ext>
-            </a:extLst>
-          </p:cNvPr>
-          <p:cNvSpPr txBox="1"/>
-          <p:nvPr/>
-        </p:nvSpPr>
-        <p:spPr>
-          <a:xfrm>
-            <a:off x="369804" y="3043024"/>
-            <a:ext cx="7729167" cy="1077218"/>
-          </a:xfrm>
-          <a:prstGeom prst="rect">
-            <a:avLst/>
-          </a:prstGeom>
-          <a:noFill/>
-        </p:spPr>
-        <p:txBody>
-          <a:bodyPr wrap="square" rtlCol="0">
-            <a:spAutoFit/>
-          </a:bodyPr>
-          <a:lstStyle/>
-          <a:p>
-            <a:pPr marL="342900" indent="-342900" algn="just">
-              <a:buFont typeface="+mj-lt"/>
-              <a:buAutoNum type="arabicPeriod"/>
-            </a:pPr>
-            <a:r>
-              <a:rPr lang="en-US" sz="1600" dirty="0"/>
-              <a:t>Calculates score of each asset as ∑ of count*priority</a:t>
+              <a:rPr lang="en-US" dirty="0"/>
+              <a:t>Asset handles of each loading priority are atomically counted in a component of that asset (reference counting).</a:t>
             </a:r>
           </a:p>
           <a:p>
-            <a:pPr marL="342900" indent="-342900" algn="just">
-              <a:buFont typeface="+mj-lt"/>
-              <a:buAutoNum type="arabicPeriod"/>
-            </a:pPr>
+            <a:pPr algn="just"/>
             <a:r>
-              <a:rPr lang="en-US" sz="1600" dirty="0"/>
-              <a:t>Sorts assets based on those scores</a:t>
+              <a:rPr lang="en-US" dirty="0"/>
+              <a:t>List of assets to load for given loading priority is maintained continuously by adding/removing empty component corresponding to given loading priority when reference count changes from/to 0.</a:t>
             </a:r>
           </a:p>
           <a:p>
-            <a:pPr marL="342900" indent="-342900" algn="just">
-              <a:buFont typeface="+mj-lt"/>
-              <a:buAutoNum type="arabicPeriod"/>
-            </a:pPr>
+            <a:pPr algn="just"/>
+            <a:endParaRPr lang="en-US" dirty="0"/>
+          </a:p>
+          <a:p>
+            <a:pPr algn="just"/>
             <a:r>
-              <a:rPr lang="en-US" sz="1600" dirty="0"/>
-              <a:t>Loads as many assets as much memory is available going from the highest score down (and unloading going from lowest score up)</a:t>
+              <a:rPr lang="en-US" dirty="0"/>
+              <a:t>Asset loading/unloading runs in an asynchronous loop, but in a foreground (structured concurrency).</a:t>
+            </a:r>
+          </a:p>
+          <a:p>
+            <a:pPr algn="just"/>
+            <a:endParaRPr lang="en-US" dirty="0"/>
+          </a:p>
+          <a:p>
+            <a:pPr algn="just"/>
+            <a:r>
+              <a:rPr lang="en-US" dirty="0"/>
+              <a:t>This makes dynamic adaptive asset loading management much easier and safer (e.g. preloading assets for next level simply by setting their handles from None to Low). There is no need for the user to write asynchronous multithreaded code and still get it’s benefits.</a:t>
             </a:r>
           </a:p>
         </p:txBody>

</xml_diff>

<commit_message>
Model serialization and bug fixing in model import and shading models specifications
</commit_message>
<xml_diff>
--- a/Documentation/Asset Pipeline.pptx
+++ b/Documentation/Asset Pipeline.pptx
@@ -5582,7 +5582,7 @@
           </a:r>
           <a:r>
             <a:rPr lang="en-US" dirty="0"/>
-            <a:t> (ref back to Project / Internal Asset)</a:t>
+            <a:t> (ref back to Project Asset)</a:t>
           </a:r>
         </a:p>
       </dgm:t>
@@ -9096,7 +9096,7 @@
       </dsp:nvSpPr>
       <dsp:spPr>
         <a:xfrm>
-          <a:off x="4282" y="146875"/>
+          <a:off x="4282" y="269371"/>
           <a:ext cx="2575156" cy="489600"/>
         </a:xfrm>
         <a:prstGeom prst="rect">
@@ -9163,7 +9163,7 @@
         </a:p>
       </dsp:txBody>
       <dsp:txXfrm>
-        <a:off x="4282" y="146875"/>
+        <a:off x="4282" y="269371"/>
         <a:ext cx="2575156" cy="489600"/>
       </dsp:txXfrm>
     </dsp:sp>
@@ -9174,8 +9174,8 @@
       </dsp:nvSpPr>
       <dsp:spPr>
         <a:xfrm>
-          <a:off x="4282" y="636475"/>
-          <a:ext cx="2575156" cy="4532338"/>
+          <a:off x="4282" y="758971"/>
+          <a:ext cx="2575156" cy="4287346"/>
         </a:xfrm>
         <a:prstGeom prst="rect">
           <a:avLst/>
@@ -9429,8 +9429,8 @@
         </a:p>
       </dsp:txBody>
       <dsp:txXfrm>
-        <a:off x="4282" y="636475"/>
-        <a:ext cx="2575156" cy="4532338"/>
+        <a:off x="4282" y="758971"/>
+        <a:ext cx="2575156" cy="4287346"/>
       </dsp:txXfrm>
     </dsp:sp>
     <dsp:sp modelId="{E09129F2-95E6-4C8B-BC91-BBC3BDA85498}">
@@ -9440,7 +9440,7 @@
       </dsp:nvSpPr>
       <dsp:spPr>
         <a:xfrm>
-          <a:off x="2939961" y="146875"/>
+          <a:off x="2939961" y="269371"/>
           <a:ext cx="2575156" cy="489600"/>
         </a:xfrm>
         <a:prstGeom prst="rect">
@@ -9507,7 +9507,7 @@
         </a:p>
       </dsp:txBody>
       <dsp:txXfrm>
-        <a:off x="2939961" y="146875"/>
+        <a:off x="2939961" y="269371"/>
         <a:ext cx="2575156" cy="489600"/>
       </dsp:txXfrm>
     </dsp:sp>
@@ -9518,8 +9518,8 @@
       </dsp:nvSpPr>
       <dsp:spPr>
         <a:xfrm>
-          <a:off x="2939961" y="636475"/>
-          <a:ext cx="2575156" cy="4532338"/>
+          <a:off x="2939961" y="758971"/>
+          <a:ext cx="2575156" cy="4287346"/>
         </a:xfrm>
         <a:prstGeom prst="rect">
           <a:avLst/>
@@ -9668,7 +9668,7 @@
           </a:r>
           <a:r>
             <a:rPr lang="en-US" sz="1700" kern="1200" dirty="0"/>
-            <a:t> (ref back to Project / Internal Asset)</a:t>
+            <a:t> (ref back to Project Asset)</a:t>
           </a:r>
         </a:p>
         <a:p>
@@ -9710,8 +9710,8 @@
         </a:p>
       </dsp:txBody>
       <dsp:txXfrm>
-        <a:off x="2939961" y="636475"/>
-        <a:ext cx="2575156" cy="4532338"/>
+        <a:off x="2939961" y="758971"/>
+        <a:ext cx="2575156" cy="4287346"/>
       </dsp:txXfrm>
     </dsp:sp>
     <dsp:sp modelId="{A97189DC-B62A-4226-BE84-683C8D0EEFD3}">
@@ -9721,7 +9721,7 @@
       </dsp:nvSpPr>
       <dsp:spPr>
         <a:xfrm>
-          <a:off x="5875640" y="146875"/>
+          <a:off x="5875640" y="269371"/>
           <a:ext cx="2575156" cy="489600"/>
         </a:xfrm>
         <a:prstGeom prst="rect">
@@ -9788,7 +9788,7 @@
         </a:p>
       </dsp:txBody>
       <dsp:txXfrm>
-        <a:off x="5875640" y="146875"/>
+        <a:off x="5875640" y="269371"/>
         <a:ext cx="2575156" cy="489600"/>
       </dsp:txXfrm>
     </dsp:sp>
@@ -9799,8 +9799,8 @@
       </dsp:nvSpPr>
       <dsp:spPr>
         <a:xfrm>
-          <a:off x="5875640" y="636475"/>
-          <a:ext cx="2575156" cy="4532338"/>
+          <a:off x="5875640" y="758971"/>
+          <a:ext cx="2575156" cy="4287346"/>
         </a:xfrm>
         <a:prstGeom prst="rect">
           <a:avLst/>
@@ -9942,8 +9942,8 @@
         </a:p>
       </dsp:txBody>
       <dsp:txXfrm>
-        <a:off x="5875640" y="636475"/>
-        <a:ext cx="2575156" cy="4532338"/>
+        <a:off x="5875640" y="758971"/>
+        <a:ext cx="2575156" cy="4287346"/>
       </dsp:txXfrm>
     </dsp:sp>
     <dsp:sp modelId="{18D4A536-73DC-492C-A34F-711BC80D73A7}">
@@ -9953,7 +9953,7 @@
       </dsp:nvSpPr>
       <dsp:spPr>
         <a:xfrm>
-          <a:off x="8811319" y="146875"/>
+          <a:off x="8811319" y="269371"/>
           <a:ext cx="2575156" cy="489600"/>
         </a:xfrm>
         <a:prstGeom prst="rect">
@@ -10020,7 +10020,7 @@
         </a:p>
       </dsp:txBody>
       <dsp:txXfrm>
-        <a:off x="8811319" y="146875"/>
+        <a:off x="8811319" y="269371"/>
         <a:ext cx="2575156" cy="489600"/>
       </dsp:txXfrm>
     </dsp:sp>
@@ -10031,8 +10031,8 @@
       </dsp:nvSpPr>
       <dsp:spPr>
         <a:xfrm>
-          <a:off x="8811319" y="636475"/>
-          <a:ext cx="2575156" cy="4532338"/>
+          <a:off x="8811319" y="758971"/>
+          <a:ext cx="2575156" cy="4287346"/>
         </a:xfrm>
         <a:prstGeom prst="rect">
           <a:avLst/>
@@ -10211,8 +10211,8 @@
         </a:p>
       </dsp:txBody>
       <dsp:txXfrm>
-        <a:off x="8811319" y="636475"/>
-        <a:ext cx="2575156" cy="4532338"/>
+        <a:off x="8811319" y="758971"/>
+        <a:ext cx="2575156" cy="4287346"/>
       </dsp:txXfrm>
     </dsp:sp>
   </dsp:spTree>
@@ -19453,7 +19453,7 @@
           <a:p>
             <a:fld id="{D0E2DD2C-27F7-4F93-96E8-CD28AD9267D9}" type="datetimeFigureOut">
               <a:rPr lang="en-US" smtClean="0"/>
-              <a:t>7/27/2025</a:t>
+              <a:t>8/27/2025</a:t>
             </a:fld>
             <a:endParaRPr lang="en-US"/>
           </a:p>
@@ -20468,7 +20468,7 @@
           <a:p>
             <a:fld id="{783DC7D5-4D76-4679-A391-31CBAFA90932}" type="datetimeFigureOut">
               <a:rPr lang="en-US" smtClean="0"/>
-              <a:t>7/27/2025</a:t>
+              <a:t>8/27/2025</a:t>
             </a:fld>
             <a:endParaRPr lang="en-US"/>
           </a:p>
@@ -20666,7 +20666,7 @@
           <a:p>
             <a:fld id="{783DC7D5-4D76-4679-A391-31CBAFA90932}" type="datetimeFigureOut">
               <a:rPr lang="en-US" smtClean="0"/>
-              <a:t>7/27/2025</a:t>
+              <a:t>8/27/2025</a:t>
             </a:fld>
             <a:endParaRPr lang="en-US"/>
           </a:p>
@@ -20874,7 +20874,7 @@
           <a:p>
             <a:fld id="{783DC7D5-4D76-4679-A391-31CBAFA90932}" type="datetimeFigureOut">
               <a:rPr lang="en-US" smtClean="0"/>
-              <a:t>7/27/2025</a:t>
+              <a:t>8/27/2025</a:t>
             </a:fld>
             <a:endParaRPr lang="en-US"/>
           </a:p>
@@ -21072,7 +21072,7 @@
           <a:p>
             <a:fld id="{783DC7D5-4D76-4679-A391-31CBAFA90932}" type="datetimeFigureOut">
               <a:rPr lang="en-US" smtClean="0"/>
-              <a:t>7/27/2025</a:t>
+              <a:t>8/27/2025</a:t>
             </a:fld>
             <a:endParaRPr lang="en-US"/>
           </a:p>
@@ -21347,7 +21347,7 @@
           <a:p>
             <a:fld id="{783DC7D5-4D76-4679-A391-31CBAFA90932}" type="datetimeFigureOut">
               <a:rPr lang="en-US" smtClean="0"/>
-              <a:t>7/27/2025</a:t>
+              <a:t>8/27/2025</a:t>
             </a:fld>
             <a:endParaRPr lang="en-US"/>
           </a:p>
@@ -21612,7 +21612,7 @@
           <a:p>
             <a:fld id="{783DC7D5-4D76-4679-A391-31CBAFA90932}" type="datetimeFigureOut">
               <a:rPr lang="en-US" smtClean="0"/>
-              <a:t>7/27/2025</a:t>
+              <a:t>8/27/2025</a:t>
             </a:fld>
             <a:endParaRPr lang="en-US"/>
           </a:p>
@@ -22024,7 +22024,7 @@
           <a:p>
             <a:fld id="{783DC7D5-4D76-4679-A391-31CBAFA90932}" type="datetimeFigureOut">
               <a:rPr lang="en-US" smtClean="0"/>
-              <a:t>7/27/2025</a:t>
+              <a:t>8/27/2025</a:t>
             </a:fld>
             <a:endParaRPr lang="en-US"/>
           </a:p>
@@ -22165,7 +22165,7 @@
           <a:p>
             <a:fld id="{783DC7D5-4D76-4679-A391-31CBAFA90932}" type="datetimeFigureOut">
               <a:rPr lang="en-US" smtClean="0"/>
-              <a:t>7/27/2025</a:t>
+              <a:t>8/27/2025</a:t>
             </a:fld>
             <a:endParaRPr lang="en-US"/>
           </a:p>
@@ -22278,7 +22278,7 @@
           <a:p>
             <a:fld id="{783DC7D5-4D76-4679-A391-31CBAFA90932}" type="datetimeFigureOut">
               <a:rPr lang="en-US" smtClean="0"/>
-              <a:t>7/27/2025</a:t>
+              <a:t>8/27/2025</a:t>
             </a:fld>
             <a:endParaRPr lang="en-US"/>
           </a:p>
@@ -22589,7 +22589,7 @@
           <a:p>
             <a:fld id="{783DC7D5-4D76-4679-A391-31CBAFA90932}" type="datetimeFigureOut">
               <a:rPr lang="en-US" smtClean="0"/>
-              <a:t>7/27/2025</a:t>
+              <a:t>8/27/2025</a:t>
             </a:fld>
             <a:endParaRPr lang="en-US"/>
           </a:p>
@@ -22877,7 +22877,7 @@
           <a:p>
             <a:fld id="{783DC7D5-4D76-4679-A391-31CBAFA90932}" type="datetimeFigureOut">
               <a:rPr lang="en-US" smtClean="0"/>
-              <a:t>7/27/2025</a:t>
+              <a:t>8/27/2025</a:t>
             </a:fld>
             <a:endParaRPr lang="en-US"/>
           </a:p>
@@ -23118,7 +23118,7 @@
           <a:p>
             <a:fld id="{783DC7D5-4D76-4679-A391-31CBAFA90932}" type="datetimeFigureOut">
               <a:rPr lang="en-US" smtClean="0"/>
-              <a:t>7/27/2025</a:t>
+              <a:t>8/27/2025</a:t>
             </a:fld>
             <a:endParaRPr lang="en-US"/>
           </a:p>
@@ -29723,7 +29723,7 @@
           <p:nvPr>
             <p:extLst>
               <p:ext uri="{D42A27DB-BD31-4B8C-83A1-F6EECF244321}">
-                <p14:modId xmlns:p14="http://schemas.microsoft.com/office/powerpoint/2010/main" val="860972783"/>
+                <p14:modId xmlns:p14="http://schemas.microsoft.com/office/powerpoint/2010/main" val="2810766526"/>
               </p:ext>
             </p:extLst>
           </p:nvPr>
@@ -31357,8 +31357,13 @@
             <a:pPr algn="ctr"/>
             <a:r>
               <a:rPr lang="en-US" sz="1050" dirty="0"/>
-              <a:t>Asset Handle</a:t>
+              <a:t>Asset</a:t>
             </a:r>
+            <a:r>
+              <a:rPr lang="pl-PL" sz="1050" dirty="0"/>
+              <a:t>ID</a:t>
+            </a:r>
+            <a:endParaRPr lang="en-US" sz="1050" dirty="0"/>
           </a:p>
         </p:txBody>
       </p:sp>
@@ -31622,7 +31627,15 @@
             <a:pPr algn="ctr"/>
             <a:r>
               <a:rPr lang="en-US" dirty="0"/>
-              <a:t>They also have scene components “simulating” them – asset views. That allows for runtime dynamic composition.</a:t>
+              <a:t>They also have scene components “simulating” them – asset views. </a:t>
+            </a:r>
+            <a:r>
+              <a:rPr lang="pl-PL" dirty="0" err="1"/>
+              <a:t>This</a:t>
+            </a:r>
+            <a:r>
+              <a:rPr lang="en-US" dirty="0"/>
+              <a:t> allows for runtime dynamic composition.</a:t>
             </a:r>
           </a:p>
         </p:txBody>

</xml_diff>

<commit_message>
Work on serializing internal assets
</commit_message>
<xml_diff>
--- a/Documentation/Asset Pipeline.pptx
+++ b/Documentation/Asset Pipeline.pptx
@@ -19453,7 +19453,7 @@
           <a:p>
             <a:fld id="{D0E2DD2C-27F7-4F93-96E8-CD28AD9267D9}" type="datetimeFigureOut">
               <a:rPr lang="en-US" smtClean="0"/>
-              <a:t>8/27/2025</a:t>
+              <a:t>11/11/2025</a:t>
             </a:fld>
             <a:endParaRPr lang="en-US"/>
           </a:p>
@@ -20468,7 +20468,7 @@
           <a:p>
             <a:fld id="{783DC7D5-4D76-4679-A391-31CBAFA90932}" type="datetimeFigureOut">
               <a:rPr lang="en-US" smtClean="0"/>
-              <a:t>8/27/2025</a:t>
+              <a:t>11/11/2025</a:t>
             </a:fld>
             <a:endParaRPr lang="en-US"/>
           </a:p>
@@ -20666,7 +20666,7 @@
           <a:p>
             <a:fld id="{783DC7D5-4D76-4679-A391-31CBAFA90932}" type="datetimeFigureOut">
               <a:rPr lang="en-US" smtClean="0"/>
-              <a:t>8/27/2025</a:t>
+              <a:t>11/11/2025</a:t>
             </a:fld>
             <a:endParaRPr lang="en-US"/>
           </a:p>
@@ -20874,7 +20874,7 @@
           <a:p>
             <a:fld id="{783DC7D5-4D76-4679-A391-31CBAFA90932}" type="datetimeFigureOut">
               <a:rPr lang="en-US" smtClean="0"/>
-              <a:t>8/27/2025</a:t>
+              <a:t>11/11/2025</a:t>
             </a:fld>
             <a:endParaRPr lang="en-US"/>
           </a:p>
@@ -21072,7 +21072,7 @@
           <a:p>
             <a:fld id="{783DC7D5-4D76-4679-A391-31CBAFA90932}" type="datetimeFigureOut">
               <a:rPr lang="en-US" smtClean="0"/>
-              <a:t>8/27/2025</a:t>
+              <a:t>11/11/2025</a:t>
             </a:fld>
             <a:endParaRPr lang="en-US"/>
           </a:p>
@@ -21347,7 +21347,7 @@
           <a:p>
             <a:fld id="{783DC7D5-4D76-4679-A391-31CBAFA90932}" type="datetimeFigureOut">
               <a:rPr lang="en-US" smtClean="0"/>
-              <a:t>8/27/2025</a:t>
+              <a:t>11/11/2025</a:t>
             </a:fld>
             <a:endParaRPr lang="en-US"/>
           </a:p>
@@ -21612,7 +21612,7 @@
           <a:p>
             <a:fld id="{783DC7D5-4D76-4679-A391-31CBAFA90932}" type="datetimeFigureOut">
               <a:rPr lang="en-US" smtClean="0"/>
-              <a:t>8/27/2025</a:t>
+              <a:t>11/11/2025</a:t>
             </a:fld>
             <a:endParaRPr lang="en-US"/>
           </a:p>
@@ -22024,7 +22024,7 @@
           <a:p>
             <a:fld id="{783DC7D5-4D76-4679-A391-31CBAFA90932}" type="datetimeFigureOut">
               <a:rPr lang="en-US" smtClean="0"/>
-              <a:t>8/27/2025</a:t>
+              <a:t>11/11/2025</a:t>
             </a:fld>
             <a:endParaRPr lang="en-US"/>
           </a:p>
@@ -22165,7 +22165,7 @@
           <a:p>
             <a:fld id="{783DC7D5-4D76-4679-A391-31CBAFA90932}" type="datetimeFigureOut">
               <a:rPr lang="en-US" smtClean="0"/>
-              <a:t>8/27/2025</a:t>
+              <a:t>11/11/2025</a:t>
             </a:fld>
             <a:endParaRPr lang="en-US"/>
           </a:p>
@@ -22278,7 +22278,7 @@
           <a:p>
             <a:fld id="{783DC7D5-4D76-4679-A391-31CBAFA90932}" type="datetimeFigureOut">
               <a:rPr lang="en-US" smtClean="0"/>
-              <a:t>8/27/2025</a:t>
+              <a:t>11/11/2025</a:t>
             </a:fld>
             <a:endParaRPr lang="en-US"/>
           </a:p>
@@ -22589,7 +22589,7 @@
           <a:p>
             <a:fld id="{783DC7D5-4D76-4679-A391-31CBAFA90932}" type="datetimeFigureOut">
               <a:rPr lang="en-US" smtClean="0"/>
-              <a:t>8/27/2025</a:t>
+              <a:t>11/11/2025</a:t>
             </a:fld>
             <a:endParaRPr lang="en-US"/>
           </a:p>
@@ -22877,7 +22877,7 @@
           <a:p>
             <a:fld id="{783DC7D5-4D76-4679-A391-31CBAFA90932}" type="datetimeFigureOut">
               <a:rPr lang="en-US" smtClean="0"/>
-              <a:t>8/27/2025</a:t>
+              <a:t>11/11/2025</a:t>
             </a:fld>
             <a:endParaRPr lang="en-US"/>
           </a:p>
@@ -23118,7 +23118,7 @@
           <a:p>
             <a:fld id="{783DC7D5-4D76-4679-A391-31CBAFA90932}" type="datetimeFigureOut">
               <a:rPr lang="en-US" smtClean="0"/>
-              <a:t>8/27/2025</a:t>
+              <a:t>11/11/2025</a:t>
             </a:fld>
             <a:endParaRPr lang="en-US"/>
           </a:p>
@@ -24262,8 +24262,8 @@
         </p:nvSpPr>
         <p:spPr>
           <a:xfrm>
-            <a:off x="1990625" y="2675868"/>
-            <a:ext cx="2143616" cy="360747"/>
+            <a:off x="1224640" y="3028036"/>
+            <a:ext cx="3171963" cy="360747"/>
           </a:xfrm>
           <a:prstGeom prst="roundRect">
             <a:avLst/>
@@ -24309,7 +24309,7 @@
         </p:nvSpPr>
         <p:spPr>
           <a:xfrm>
-            <a:off x="2166706" y="4019274"/>
+            <a:off x="2166706" y="4371442"/>
             <a:ext cx="1851784" cy="360747"/>
           </a:xfrm>
           <a:prstGeom prst="roundRect">
@@ -24356,7 +24356,7 @@
         </p:nvSpPr>
         <p:spPr>
           <a:xfrm>
-            <a:off x="1111251" y="5819065"/>
+            <a:off x="1111251" y="6171233"/>
             <a:ext cx="4124162" cy="360747"/>
           </a:xfrm>
           <a:prstGeom prst="roundRect">
@@ -24383,8 +24383,16 @@
           <a:p>
             <a:pPr algn="ctr"/>
             <a:r>
+              <a:rPr lang="pl-PL" dirty="0" err="1"/>
+              <a:t>Atomic</a:t>
+            </a:r>
+            <a:r>
+              <a:rPr lang="pl-PL" dirty="0"/>
+              <a:t> </a:t>
+            </a:r>
+            <a:r>
               <a:rPr lang="en-US" dirty="0"/>
-              <a:t>Atomic Observers Count</a:t>
+              <a:t>Observers Count</a:t>
             </a:r>
           </a:p>
         </p:txBody>
@@ -24404,7 +24412,7 @@
           <p:nvPr>
             <p:extLst>
               <p:ext uri="{D42A27DB-BD31-4B8C-83A1-F6EECF244321}">
-                <p14:modId xmlns:p14="http://schemas.microsoft.com/office/powerpoint/2010/main" val="1259015543"/>
+                <p14:modId xmlns:p14="http://schemas.microsoft.com/office/powerpoint/2010/main" val="2971708937"/>
               </p:ext>
             </p:extLst>
           </p:nvPr>
@@ -24601,6 +24609,7 @@
                         <a:rPr lang="en-US" sz="1400" dirty="0"/>
                         <a:t>Unlock Mutex B</a:t>
                       </a:r>
+                      <a:endParaRPr lang="pl-PL" sz="1400" dirty="0"/>
                     </a:p>
                   </a:txBody>
                   <a:tcPr/>
@@ -24667,7 +24676,7 @@
         </p:nvSpPr>
         <p:spPr>
           <a:xfrm>
-            <a:off x="489839" y="1373579"/>
+            <a:off x="257258" y="1142986"/>
             <a:ext cx="1366795" cy="655684"/>
           </a:xfrm>
           <a:prstGeom prst="roundRect">
@@ -24715,50 +24724,9 @@
           <p:nvPr/>
         </p:nvCxnSpPr>
         <p:spPr>
-          <a:xfrm>
-            <a:off x="1813615" y="2008768"/>
-            <a:ext cx="367198" cy="665793"/>
-          </a:xfrm>
-          <a:prstGeom prst="straightConnector1">
-            <a:avLst/>
-          </a:prstGeom>
-          <a:ln>
-            <a:tailEnd type="triangle"/>
-          </a:ln>
-        </p:spPr>
-        <p:style>
-          <a:lnRef idx="3">
-            <a:schemeClr val="accent6"/>
-          </a:lnRef>
-          <a:fillRef idx="0">
-            <a:schemeClr val="accent6"/>
-          </a:fillRef>
-          <a:effectRef idx="2">
-            <a:schemeClr val="accent6"/>
-          </a:effectRef>
-          <a:fontRef idx="minor">
-            <a:schemeClr val="tx1"/>
-          </a:fontRef>
-        </p:style>
-      </p:cxnSp>
-      <p:cxnSp>
-        <p:nvCxnSpPr>
-          <p:cNvPr id="11" name="Łącznik prosty ze strzałką 10">
-            <a:extLst>
-              <a:ext uri="{FF2B5EF4-FFF2-40B4-BE49-F238E27FC236}">
-                <a16:creationId xmlns:a16="http://schemas.microsoft.com/office/drawing/2014/main" id="{EF78121E-16CB-1E5E-068D-36E8A889E726}"/>
-              </a:ext>
-            </a:extLst>
-          </p:cNvPr>
-          <p:cNvCxnSpPr>
-            <a:cxnSpLocks/>
-          </p:cNvCxnSpPr>
-          <p:nvPr/>
-        </p:nvCxnSpPr>
-        <p:spPr>
           <a:xfrm flipH="1">
-            <a:off x="1263931" y="3035961"/>
-            <a:ext cx="902775" cy="1163686"/>
+            <a:off x="1468328" y="1798670"/>
+            <a:ext cx="42493" cy="1228059"/>
           </a:xfrm>
           <a:prstGeom prst="straightConnector1">
             <a:avLst/>
@@ -24797,9 +24765,9 @@
           <p:nvPr/>
         </p:nvCxnSpPr>
         <p:spPr>
-          <a:xfrm>
-            <a:off x="1263931" y="4200565"/>
-            <a:ext cx="0" cy="1618500"/>
+          <a:xfrm flipH="1">
+            <a:off x="1263931" y="3384988"/>
+            <a:ext cx="165708" cy="2786245"/>
           </a:xfrm>
           <a:prstGeom prst="straightConnector1">
             <a:avLst/>
@@ -24839,7 +24807,7 @@
         </p:nvCxnSpPr>
         <p:spPr>
           <a:xfrm flipV="1">
-            <a:off x="1361221" y="5130125"/>
+            <a:off x="1361221" y="5482293"/>
             <a:ext cx="672543" cy="678042"/>
           </a:xfrm>
           <a:prstGeom prst="straightConnector1">
@@ -24880,7 +24848,7 @@
         </p:nvCxnSpPr>
         <p:spPr>
           <a:xfrm flipH="1" flipV="1">
-            <a:off x="1811593" y="4199647"/>
+            <a:off x="1811593" y="4551815"/>
             <a:ext cx="225131" cy="930478"/>
           </a:xfrm>
           <a:prstGeom prst="straightConnector1">
@@ -24921,8 +24889,8 @@
         </p:nvCxnSpPr>
         <p:spPr>
           <a:xfrm flipV="1">
-            <a:off x="1811593" y="3596481"/>
-            <a:ext cx="622045" cy="603166"/>
+            <a:off x="1811593" y="3904735"/>
+            <a:ext cx="287925" cy="647080"/>
           </a:xfrm>
           <a:prstGeom prst="straightConnector1">
             <a:avLst/>
@@ -24955,13 +24923,15 @@
               </a:ext>
             </a:extLst>
           </p:cNvPr>
-          <p:cNvCxnSpPr/>
+          <p:cNvCxnSpPr>
+            <a:cxnSpLocks/>
+          </p:cNvCxnSpPr>
           <p:nvPr/>
         </p:nvCxnSpPr>
         <p:spPr>
           <a:xfrm flipV="1">
-            <a:off x="2450786" y="3035961"/>
-            <a:ext cx="0" cy="529003"/>
+            <a:off x="2099518" y="3384988"/>
+            <a:ext cx="0" cy="519747"/>
           </a:xfrm>
           <a:prstGeom prst="straightConnector1">
             <a:avLst/>
@@ -25001,7 +24971,7 @@
         </p:nvCxnSpPr>
         <p:spPr>
           <a:xfrm flipV="1">
-            <a:off x="2053873" y="4380021"/>
+            <a:off x="2053873" y="4732189"/>
             <a:ext cx="396913" cy="719522"/>
           </a:xfrm>
           <a:prstGeom prst="straightConnector1">
@@ -25042,9 +25012,9 @@
           <p:nvPr/>
         </p:nvCxnSpPr>
         <p:spPr>
-          <a:xfrm flipV="1">
-            <a:off x="2450786" y="3596481"/>
-            <a:ext cx="0" cy="422793"/>
+          <a:xfrm flipH="1" flipV="1">
+            <a:off x="2099518" y="3904735"/>
+            <a:ext cx="351268" cy="466707"/>
           </a:xfrm>
           <a:prstGeom prst="straightConnector1">
             <a:avLst/>
@@ -25083,8 +25053,8 @@
         </p:nvSpPr>
         <p:spPr>
           <a:xfrm>
-            <a:off x="2255097" y="1416543"/>
-            <a:ext cx="2335181" cy="403767"/>
+            <a:off x="1826001" y="1222669"/>
+            <a:ext cx="3326909" cy="403767"/>
           </a:xfrm>
           <a:prstGeom prst="roundRect">
             <a:avLst/>
@@ -25131,50 +25101,9 @@
           <p:nvPr/>
         </p:nvCxnSpPr>
         <p:spPr>
-          <a:xfrm flipV="1">
-            <a:off x="2456822" y="1826660"/>
-            <a:ext cx="0" cy="837328"/>
-          </a:xfrm>
-          <a:prstGeom prst="straightConnector1">
-            <a:avLst/>
-          </a:prstGeom>
-          <a:ln>
-            <a:tailEnd type="triangle"/>
-          </a:ln>
-        </p:spPr>
-        <p:style>
-          <a:lnRef idx="3">
-            <a:schemeClr val="accent6"/>
-          </a:lnRef>
-          <a:fillRef idx="0">
-            <a:schemeClr val="accent6"/>
-          </a:fillRef>
-          <a:effectRef idx="2">
-            <a:schemeClr val="accent6"/>
-          </a:effectRef>
-          <a:fontRef idx="minor">
-            <a:schemeClr val="tx1"/>
-          </a:fontRef>
-        </p:style>
-      </p:cxnSp>
-      <p:cxnSp>
-        <p:nvCxnSpPr>
-          <p:cNvPr id="91" name="Łącznik prosty ze strzałką 90">
-            <a:extLst>
-              <a:ext uri="{FF2B5EF4-FFF2-40B4-BE49-F238E27FC236}">
-                <a16:creationId xmlns:a16="http://schemas.microsoft.com/office/drawing/2014/main" id="{4DCC9B42-3178-C128-1853-37C9471EB5D3}"/>
-              </a:ext>
-            </a:extLst>
-          </p:cNvPr>
-          <p:cNvCxnSpPr>
-            <a:cxnSpLocks/>
-          </p:cNvCxnSpPr>
-          <p:nvPr/>
-        </p:nvCxnSpPr>
-        <p:spPr>
-          <a:xfrm>
-            <a:off x="5085283" y="4153420"/>
-            <a:ext cx="0" cy="1655267"/>
+          <a:xfrm flipH="1" flipV="1">
+            <a:off x="2067471" y="1612904"/>
+            <a:ext cx="6036" cy="1391221"/>
           </a:xfrm>
           <a:prstGeom prst="straightConnector1">
             <a:avLst/>
@@ -25214,8 +25143,8 @@
         </p:nvCxnSpPr>
         <p:spPr>
           <a:xfrm flipH="1" flipV="1">
-            <a:off x="4330700" y="5182306"/>
-            <a:ext cx="638312" cy="625861"/>
+            <a:off x="4330700" y="5534474"/>
+            <a:ext cx="603231" cy="636759"/>
           </a:xfrm>
           <a:prstGeom prst="straightConnector1">
             <a:avLst/>
@@ -25254,9 +25183,9 @@
           <p:nvPr/>
         </p:nvCxnSpPr>
         <p:spPr>
-          <a:xfrm flipV="1">
-            <a:off x="4362840" y="4238423"/>
-            <a:ext cx="172266" cy="943883"/>
+          <a:xfrm flipH="1" flipV="1">
+            <a:off x="4345526" y="4546579"/>
+            <a:ext cx="17314" cy="987895"/>
           </a:xfrm>
           <a:prstGeom prst="straightConnector1">
             <a:avLst/>
@@ -25297,8 +25226,8 @@
         </p:nvCxnSpPr>
         <p:spPr>
           <a:xfrm flipH="1" flipV="1">
-            <a:off x="4120277" y="3698847"/>
-            <a:ext cx="414829" cy="539576"/>
+            <a:off x="4165134" y="4008183"/>
+            <a:ext cx="177859" cy="540535"/>
           </a:xfrm>
           <a:prstGeom prst="straightConnector1">
             <a:avLst/>
@@ -25338,7 +25267,7 @@
         </p:nvCxnSpPr>
         <p:spPr>
           <a:xfrm flipH="1" flipV="1">
-            <a:off x="3832240" y="4390919"/>
+            <a:off x="3832240" y="4743087"/>
             <a:ext cx="498460" cy="791387"/>
           </a:xfrm>
           <a:prstGeom prst="straightConnector1">
@@ -25381,8 +25310,8 @@
         </p:nvCxnSpPr>
         <p:spPr>
           <a:xfrm flipV="1">
-            <a:off x="3832240" y="3698847"/>
-            <a:ext cx="288037" cy="331325"/>
+            <a:off x="3831014" y="4008183"/>
+            <a:ext cx="334120" cy="363259"/>
           </a:xfrm>
           <a:prstGeom prst="straightConnector1">
             <a:avLst/>
@@ -25421,7 +25350,7 @@
         </p:nvSpPr>
         <p:spPr>
           <a:xfrm>
-            <a:off x="3796622" y="3295080"/>
+            <a:off x="3841479" y="3604416"/>
             <a:ext cx="647309" cy="403767"/>
           </a:xfrm>
           <a:prstGeom prst="roundRect">
@@ -25468,7 +25397,7 @@
         </p:nvSpPr>
         <p:spPr>
           <a:xfrm>
-            <a:off x="4797211" y="1407280"/>
+            <a:off x="2258798" y="1853179"/>
             <a:ext cx="1343237" cy="655684"/>
           </a:xfrm>
           <a:prstGeom prst="roundRect">
@@ -25516,9 +25445,9 @@
           <p:nvPr/>
         </p:nvCxnSpPr>
         <p:spPr>
-          <a:xfrm flipH="1">
-            <a:off x="2783183" y="1984985"/>
-            <a:ext cx="2014029" cy="673336"/>
+          <a:xfrm>
+            <a:off x="2783183" y="2525491"/>
+            <a:ext cx="0" cy="484998"/>
           </a:xfrm>
           <a:prstGeom prst="straightConnector1">
             <a:avLst/>
@@ -25558,7 +25487,7 @@
         </p:nvCxnSpPr>
         <p:spPr>
           <a:xfrm>
-            <a:off x="2775290" y="3034813"/>
+            <a:off x="2775290" y="3386981"/>
             <a:ext cx="7893" cy="973563"/>
           </a:xfrm>
           <a:prstGeom prst="straightConnector1">
@@ -25597,7 +25526,7 @@
         </p:nvSpPr>
         <p:spPr>
           <a:xfrm>
-            <a:off x="2720087" y="5037690"/>
+            <a:off x="2720087" y="5389858"/>
             <a:ext cx="784275" cy="403767"/>
           </a:xfrm>
           <a:prstGeom prst="roundRect">
@@ -25647,7 +25576,7 @@
         </p:nvCxnSpPr>
         <p:spPr>
           <a:xfrm>
-            <a:off x="2767397" y="4371975"/>
+            <a:off x="2767397" y="4724143"/>
             <a:ext cx="344828" cy="665715"/>
           </a:xfrm>
           <a:prstGeom prst="straightConnector1">
@@ -25689,7 +25618,7 @@
         </p:nvCxnSpPr>
         <p:spPr>
           <a:xfrm flipV="1">
-            <a:off x="3112225" y="4390919"/>
+            <a:off x="3112225" y="4743087"/>
             <a:ext cx="177075" cy="646771"/>
           </a:xfrm>
           <a:prstGeom prst="straightConnector1">
@@ -25730,7 +25659,7 @@
         </p:nvCxnSpPr>
         <p:spPr>
           <a:xfrm flipV="1">
-            <a:off x="3289300" y="3032820"/>
+            <a:off x="3289300" y="3384988"/>
             <a:ext cx="289263" cy="980491"/>
           </a:xfrm>
           <a:prstGeom prst="straightConnector1">
@@ -25766,13 +25695,14 @@
           </p:cNvPr>
           <p:cNvCxnSpPr>
             <a:cxnSpLocks/>
+            <a:endCxn id="140" idx="2"/>
           </p:cNvCxnSpPr>
           <p:nvPr/>
         </p:nvCxnSpPr>
         <p:spPr>
           <a:xfrm flipV="1">
-            <a:off x="3626765" y="2437463"/>
-            <a:ext cx="1246929" cy="214555"/>
+            <a:off x="3574958" y="2416942"/>
+            <a:ext cx="607073" cy="600196"/>
           </a:xfrm>
           <a:prstGeom prst="straightConnector1">
             <a:avLst/>
@@ -25810,7 +25740,7 @@
         </p:nvSpPr>
         <p:spPr>
           <a:xfrm>
-            <a:off x="4882433" y="2280861"/>
+            <a:off x="3858376" y="2013175"/>
             <a:ext cx="647309" cy="403767"/>
           </a:xfrm>
           <a:prstGeom prst="roundRect">
@@ -25857,7 +25787,7 @@
         </p:nvSpPr>
         <p:spPr>
           <a:xfrm>
-            <a:off x="2053872" y="4865638"/>
+            <a:off x="2053872" y="5217806"/>
             <a:ext cx="704913" cy="230832"/>
           </a:xfrm>
           <a:prstGeom prst="rect">
@@ -25897,7 +25827,7 @@
         </p:nvSpPr>
         <p:spPr>
           <a:xfrm>
-            <a:off x="1361376" y="4868711"/>
+            <a:off x="1361376" y="5220879"/>
             <a:ext cx="704913" cy="230832"/>
           </a:xfrm>
           <a:prstGeom prst="rect">
@@ -25939,8 +25869,8 @@
         </p:nvCxnSpPr>
         <p:spPr>
           <a:xfrm>
-            <a:off x="4386783" y="1826660"/>
-            <a:ext cx="704970" cy="2292095"/>
+            <a:off x="4946224" y="1635196"/>
+            <a:ext cx="46625" cy="4536037"/>
           </a:xfrm>
           <a:prstGeom prst="straightConnector1">
             <a:avLst/>
@@ -25978,7 +25908,7 @@
         </p:nvSpPr>
         <p:spPr>
           <a:xfrm>
-            <a:off x="3555683" y="4876015"/>
+            <a:off x="3555683" y="5228183"/>
             <a:ext cx="704913" cy="230832"/>
           </a:xfrm>
           <a:prstGeom prst="rect">
@@ -26018,7 +25948,7 @@
         </p:nvSpPr>
         <p:spPr>
           <a:xfrm>
-            <a:off x="4305567" y="4884688"/>
+            <a:off x="4248833" y="5168118"/>
             <a:ext cx="704913" cy="230832"/>
           </a:xfrm>
           <a:prstGeom prst="rect">

</xml_diff>

<commit_message>
A lot of various stuff mostly rendering
</commit_message>
<xml_diff>
--- a/Documentation/Asset Pipeline.pptx
+++ b/Documentation/Asset Pipeline.pptx
@@ -4035,10 +4035,9 @@
         <a:lstStyle/>
         <a:p>
           <a:r>
-            <a:rPr lang="en-US" dirty="0" err="1"/>
+            <a:rPr lang="en-US" dirty="0"/>
             <a:t>ShadingModel</a:t>
           </a:r>
-          <a:endParaRPr lang="en-US" dirty="0"/>
         </a:p>
       </dgm:t>
     </dgm:pt>
@@ -4189,10 +4188,9 @@
         <a:lstStyle/>
         <a:p>
           <a:r>
-            <a:rPr lang="en-US" dirty="0" err="1"/>
+            <a:rPr lang="en-US" dirty="0"/>
             <a:t>RenderMesh</a:t>
           </a:r>
-          <a:endParaRPr lang="en-US" dirty="0"/>
         </a:p>
       </dgm:t>
     </dgm:pt>
@@ -4343,10 +4341,9 @@
         <a:lstStyle/>
         <a:p>
           <a:r>
-            <a:rPr lang="en-US" dirty="0" err="1"/>
+            <a:rPr lang="en-US" dirty="0"/>
             <a:t>SkinnedModel</a:t>
           </a:r>
-          <a:endParaRPr lang="en-US" dirty="0"/>
         </a:p>
       </dgm:t>
     </dgm:pt>
@@ -4913,7 +4910,7 @@
         <a:p>
           <a:r>
             <a:rPr lang="en-US" dirty="0"/>
-            <a:t>Internal Asset</a:t>
+            <a:t>Unit Asset</a:t>
           </a:r>
         </a:p>
       </dgm:t>
@@ -4949,7 +4946,7 @@
         <a:p>
           <a:r>
             <a:rPr lang="en-US" dirty="0"/>
-            <a:t>Internal Assets are only ever referenced by other asset</a:t>
+            <a:t>Unit Assets are only ever referenced by other asset</a:t>
           </a:r>
           <a:r>
             <a:rPr lang="en-US" noProof="0" dirty="0"/>
@@ -5577,12 +5574,9 @@
         <a:p>
           <a:r>
             <a:rPr lang="en-US" dirty="0" err="1"/>
-            <a:t>ACMasterAsset</a:t>
+            <a:t>ACProjectAsset</a:t>
           </a:r>
-          <a:r>
-            <a:rPr lang="en-US" dirty="0"/>
-            <a:t> (ref back to Project Asset)</a:t>
-          </a:r>
+          <a:endParaRPr lang="en-US" dirty="0"/>
         </a:p>
       </dgm:t>
     </dgm:pt>
@@ -5608,7 +5602,80 @@
         </a:p>
       </dgm:t>
     </dgm:pt>
-    <dgm:pt modelId="{03978623-FE6E-4F91-B2D0-9F9AABA0040F}">
+    <dgm:pt modelId="{D91083A4-A3FF-46EE-B215-B4E06D455191}">
+      <dgm:prSet/>
+      <dgm:spPr/>
+      <dgm:t>
+        <a:bodyPr/>
+        <a:lstStyle/>
+        <a:p>
+          <a:r>
+            <a:rPr lang="en-US" dirty="0"/>
+            <a:t>other, asset type specific, components</a:t>
+          </a:r>
+        </a:p>
+      </dgm:t>
+    </dgm:pt>
+    <dgm:pt modelId="{8C4A6C73-96FC-43DA-AE13-5EFF209D857E}" type="parTrans" cxnId="{1DB81CF8-B2F1-46DD-B5D2-5D611CC7759F}">
+      <dgm:prSet/>
+      <dgm:spPr/>
+      <dgm:t>
+        <a:bodyPr/>
+        <a:lstStyle/>
+        <a:p>
+          <a:endParaRPr lang="en-US"/>
+        </a:p>
+      </dgm:t>
+    </dgm:pt>
+    <dgm:pt modelId="{37DC180E-FB6D-4850-B951-2448CD6BA1EB}" type="sibTrans" cxnId="{1DB81CF8-B2F1-46DD-B5D2-5D611CC7759F}">
+      <dgm:prSet/>
+      <dgm:spPr/>
+      <dgm:t>
+        <a:bodyPr/>
+        <a:lstStyle/>
+        <a:p>
+          <a:endParaRPr lang="en-US"/>
+        </a:p>
+      </dgm:t>
+    </dgm:pt>
+    <dgm:pt modelId="{496EB545-0894-4B0F-8936-291577F9915D}">
+      <dgm:prSet/>
+      <dgm:spPr/>
+      <dgm:t>
+        <a:bodyPr/>
+        <a:lstStyle/>
+        <a:p>
+          <a:r>
+            <a:rPr lang="en-US" dirty="0" err="1"/>
+            <a:t>ACAssetType</a:t>
+          </a:r>
+          <a:endParaRPr lang="en-US" dirty="0"/>
+        </a:p>
+      </dgm:t>
+    </dgm:pt>
+    <dgm:pt modelId="{EF545D9D-E807-485E-998A-0A5634E6EAEC}" type="parTrans" cxnId="{CAC14864-0BA6-4CDB-A88E-772833859E4A}">
+      <dgm:prSet/>
+      <dgm:spPr/>
+      <dgm:t>
+        <a:bodyPr/>
+        <a:lstStyle/>
+        <a:p>
+          <a:endParaRPr lang="en-US"/>
+        </a:p>
+      </dgm:t>
+    </dgm:pt>
+    <dgm:pt modelId="{476CAC9E-4E5A-4010-AC78-FFD0504BEC2F}" type="sibTrans" cxnId="{CAC14864-0BA6-4CDB-A88E-772833859E4A}">
+      <dgm:prSet/>
+      <dgm:spPr/>
+      <dgm:t>
+        <a:bodyPr/>
+        <a:lstStyle/>
+        <a:p>
+          <a:endParaRPr lang="en-US"/>
+        </a:p>
+      </dgm:t>
+    </dgm:pt>
+    <dgm:pt modelId="{A521DE87-592D-424F-B359-261E6644A127}">
       <dgm:prSet/>
       <dgm:spPr/>
       <dgm:t>
@@ -5623,7 +5690,7 @@
         </a:p>
       </dgm:t>
     </dgm:pt>
-    <dgm:pt modelId="{4DA5677F-34FD-461D-B56A-634BB0616E93}" type="parTrans" cxnId="{A73A9D2C-C596-4800-8F79-27791977C162}">
+    <dgm:pt modelId="{CA54F6F4-9A2D-411E-9F6F-89E21AE72543}" type="parTrans" cxnId="{186979F7-750C-4DBE-ACBE-77F29D9A6BBA}">
       <dgm:prSet/>
       <dgm:spPr/>
       <dgm:t>
@@ -5634,7 +5701,7 @@
         </a:p>
       </dgm:t>
     </dgm:pt>
-    <dgm:pt modelId="{4FAE4290-A6D8-461D-A11A-BBD725BE9157}" type="sibTrans" cxnId="{A73A9D2C-C596-4800-8F79-27791977C162}">
+    <dgm:pt modelId="{5137215B-3E61-40D9-BA44-3ED87150D71D}" type="sibTrans" cxnId="{186979F7-750C-4DBE-ACBE-77F29D9A6BBA}">
       <dgm:prSet/>
       <dgm:spPr/>
       <dgm:t>
@@ -5645,7 +5712,7 @@
         </a:p>
       </dgm:t>
     </dgm:pt>
-    <dgm:pt modelId="{D91083A4-A3FF-46EE-B215-B4E06D455191}">
+    <dgm:pt modelId="{829080E2-2793-47D4-8AB2-3E71A7C02F83}">
       <dgm:prSet/>
       <dgm:spPr/>
       <dgm:t>
@@ -5659,7 +5726,7 @@
         </a:p>
       </dgm:t>
     </dgm:pt>
-    <dgm:pt modelId="{8C4A6C73-96FC-43DA-AE13-5EFF209D857E}" type="parTrans" cxnId="{1DB81CF8-B2F1-46DD-B5D2-5D611CC7759F}">
+    <dgm:pt modelId="{17717102-DC23-4339-A4BD-626C0DBCE9E7}" type="parTrans" cxnId="{621C7697-1F0B-40BB-B63B-B262ED275C28}">
       <dgm:prSet/>
       <dgm:spPr/>
       <dgm:t>
@@ -5670,7 +5737,7 @@
         </a:p>
       </dgm:t>
     </dgm:pt>
-    <dgm:pt modelId="{37DC180E-FB6D-4850-B951-2448CD6BA1EB}" type="sibTrans" cxnId="{1DB81CF8-B2F1-46DD-B5D2-5D611CC7759F}">
+    <dgm:pt modelId="{E9E0E638-0E46-452D-A812-122B1603FC93}" type="sibTrans" cxnId="{621C7697-1F0B-40BB-B63B-B262ED275C28}">
       <dgm:prSet/>
       <dgm:spPr/>
       <dgm:t>
@@ -5681,7 +5748,79 @@
         </a:p>
       </dgm:t>
     </dgm:pt>
-    <dgm:pt modelId="{496EB545-0894-4B0F-8936-291577F9915D}">
+    <dgm:pt modelId="{7CB9B775-851A-4061-A9DF-E60947B13BE6}">
+      <dgm:prSet/>
+      <dgm:spPr/>
+      <dgm:t>
+        <a:bodyPr/>
+        <a:lstStyle/>
+        <a:p>
+          <a:r>
+            <a:rPr lang="en-US" dirty="0"/>
+            <a:t>Components</a:t>
+          </a:r>
+        </a:p>
+      </dgm:t>
+    </dgm:pt>
+    <dgm:pt modelId="{D780929A-2D37-4C25-BF8A-9A0E8157996A}" type="parTrans" cxnId="{503C8454-F428-4243-AECB-265FA4B8D9BA}">
+      <dgm:prSet/>
+      <dgm:spPr/>
+      <dgm:t>
+        <a:bodyPr/>
+        <a:lstStyle/>
+        <a:p>
+          <a:endParaRPr lang="en-US"/>
+        </a:p>
+      </dgm:t>
+    </dgm:pt>
+    <dgm:pt modelId="{88D8659E-869C-4503-8503-4E5AACA8FA3E}" type="sibTrans" cxnId="{503C8454-F428-4243-AECB-265FA4B8D9BA}">
+      <dgm:prSet/>
+      <dgm:spPr/>
+      <dgm:t>
+        <a:bodyPr/>
+        <a:lstStyle/>
+        <a:p>
+          <a:endParaRPr lang="en-US"/>
+        </a:p>
+      </dgm:t>
+    </dgm:pt>
+    <dgm:pt modelId="{90460D4B-7138-4725-ADD6-E6EC2A7BF7EC}">
+      <dgm:prSet/>
+      <dgm:spPr/>
+      <dgm:t>
+        <a:bodyPr/>
+        <a:lstStyle/>
+        <a:p>
+          <a:r>
+            <a:rPr lang="en-US" dirty="0"/>
+            <a:t>Components</a:t>
+          </a:r>
+        </a:p>
+      </dgm:t>
+    </dgm:pt>
+    <dgm:pt modelId="{5CAE3443-D2EC-438E-BAA1-5E5A5619E4B8}" type="parTrans" cxnId="{C963DE92-9FFA-416E-9CBB-F1D96E4F23A2}">
+      <dgm:prSet/>
+      <dgm:spPr/>
+      <dgm:t>
+        <a:bodyPr/>
+        <a:lstStyle/>
+        <a:p>
+          <a:endParaRPr lang="en-US"/>
+        </a:p>
+      </dgm:t>
+    </dgm:pt>
+    <dgm:pt modelId="{023AE1A4-1C73-440E-8E5B-82164B5EE816}" type="sibTrans" cxnId="{C963DE92-9FFA-416E-9CBB-F1D96E4F23A2}">
+      <dgm:prSet/>
+      <dgm:spPr/>
+      <dgm:t>
+        <a:bodyPr/>
+        <a:lstStyle/>
+        <a:p>
+          <a:endParaRPr lang="en-US"/>
+        </a:p>
+      </dgm:t>
+    </dgm:pt>
+    <dgm:pt modelId="{C55CDAA4-0A7B-4072-9CD3-6D7896772C6F}">
       <dgm:prSet/>
       <dgm:spPr/>
       <dgm:t>
@@ -5696,7 +5835,7 @@
         </a:p>
       </dgm:t>
     </dgm:pt>
-    <dgm:pt modelId="{EF545D9D-E807-485E-998A-0A5634E6EAEC}" type="parTrans" cxnId="{CAC14864-0BA6-4CDB-A88E-772833859E4A}">
+    <dgm:pt modelId="{CDF5DCCF-2E2A-4296-AD6C-ABE6E27E5F15}" type="parTrans" cxnId="{E1EA81ED-FE5B-4917-880A-0CA09B45A253}">
       <dgm:prSet/>
       <dgm:spPr/>
       <dgm:t>
@@ -5707,7 +5846,7 @@
         </a:p>
       </dgm:t>
     </dgm:pt>
-    <dgm:pt modelId="{476CAC9E-4E5A-4010-AC78-FFD0504BEC2F}" type="sibTrans" cxnId="{CAC14864-0BA6-4CDB-A88E-772833859E4A}">
+    <dgm:pt modelId="{12918B51-1EE7-4110-A777-AFBA2DE18C29}" type="sibTrans" cxnId="{E1EA81ED-FE5B-4917-880A-0CA09B45A253}">
       <dgm:prSet/>
       <dgm:spPr/>
       <dgm:t>
@@ -5718,7 +5857,7 @@
         </a:p>
       </dgm:t>
     </dgm:pt>
-    <dgm:pt modelId="{A521DE87-592D-424F-B359-261E6644A127}">
+    <dgm:pt modelId="{6503583A-94E3-47C8-8A37-17DCFD2C1B40}">
       <dgm:prSet/>
       <dgm:spPr/>
       <dgm:t>
@@ -5733,7 +5872,7 @@
         </a:p>
       </dgm:t>
     </dgm:pt>
-    <dgm:pt modelId="{CA54F6F4-9A2D-411E-9F6F-89E21AE72543}" type="parTrans" cxnId="{186979F7-750C-4DBE-ACBE-77F29D9A6BBA}">
+    <dgm:pt modelId="{C160F51E-FCFD-4661-9B7C-39FB92B88A36}" type="parTrans" cxnId="{A4154A6D-056D-4EE4-A395-C0CF04701971}">
       <dgm:prSet/>
       <dgm:spPr/>
       <dgm:t>
@@ -5744,7 +5883,7 @@
         </a:p>
       </dgm:t>
     </dgm:pt>
-    <dgm:pt modelId="{5137215B-3E61-40D9-BA44-3ED87150D71D}" type="sibTrans" cxnId="{186979F7-750C-4DBE-ACBE-77F29D9A6BBA}">
+    <dgm:pt modelId="{7D0024F7-DB83-4DAB-8350-82F13C69336B}" type="sibTrans" cxnId="{A4154A6D-056D-4EE4-A395-C0CF04701971}">
       <dgm:prSet/>
       <dgm:spPr/>
       <dgm:t>
@@ -5755,7 +5894,7 @@
         </a:p>
       </dgm:t>
     </dgm:pt>
-    <dgm:pt modelId="{829080E2-2793-47D4-8AB2-3E71A7C02F83}">
+    <dgm:pt modelId="{65F19840-B0C0-478D-8303-0247D09C817A}">
       <dgm:prSet/>
       <dgm:spPr/>
       <dgm:t>
@@ -5769,7 +5908,7 @@
         </a:p>
       </dgm:t>
     </dgm:pt>
-    <dgm:pt modelId="{17717102-DC23-4339-A4BD-626C0DBCE9E7}" type="parTrans" cxnId="{621C7697-1F0B-40BB-B63B-B262ED275C28}">
+    <dgm:pt modelId="{F56F0E06-DB59-4373-BCD3-1E620BE207A3}" type="parTrans" cxnId="{F0CA5A45-C6DF-48B3-8B03-B35309CE3725}">
       <dgm:prSet/>
       <dgm:spPr/>
       <dgm:t>
@@ -5780,7 +5919,7 @@
         </a:p>
       </dgm:t>
     </dgm:pt>
-    <dgm:pt modelId="{E9E0E638-0E46-452D-A812-122B1603FC93}" type="sibTrans" cxnId="{621C7697-1F0B-40BB-B63B-B262ED275C28}">
+    <dgm:pt modelId="{1A56BC5E-3F05-4F0F-A1D0-BB1EED387864}" type="sibTrans" cxnId="{F0CA5A45-C6DF-48B3-8B03-B35309CE3725}">
       <dgm:prSet/>
       <dgm:spPr/>
       <dgm:t>
@@ -5791,7 +5930,7 @@
         </a:p>
       </dgm:t>
     </dgm:pt>
-    <dgm:pt modelId="{7CB9B775-851A-4061-A9DF-E60947B13BE6}">
+    <dgm:pt modelId="{78F88E26-8B8C-4948-BF99-63EA46AFCFA3}">
       <dgm:prSet/>
       <dgm:spPr/>
       <dgm:t>
@@ -5800,12 +5939,12 @@
         <a:p>
           <a:r>
             <a:rPr lang="en-US" dirty="0"/>
-            <a:t>Components</a:t>
+            <a:t>ACUUID</a:t>
           </a:r>
         </a:p>
       </dgm:t>
     </dgm:pt>
-    <dgm:pt modelId="{D780929A-2D37-4C25-BF8A-9A0E8157996A}" type="parTrans" cxnId="{503C8454-F428-4243-AECB-265FA4B8D9BA}">
+    <dgm:pt modelId="{98D5557D-40C2-4744-8D4F-EFF73CDEC0DD}" type="parTrans" cxnId="{B52F73A8-5A20-405E-BFC7-51B34FC95885}">
       <dgm:prSet/>
       <dgm:spPr/>
       <dgm:t>
@@ -5816,7 +5955,7 @@
         </a:p>
       </dgm:t>
     </dgm:pt>
-    <dgm:pt modelId="{88D8659E-869C-4503-8503-4E5AACA8FA3E}" type="sibTrans" cxnId="{503C8454-F428-4243-AECB-265FA4B8D9BA}">
+    <dgm:pt modelId="{5271797F-73B1-4CF2-8588-CD56DF1624E8}" type="sibTrans" cxnId="{B52F73A8-5A20-405E-BFC7-51B34FC95885}">
       <dgm:prSet/>
       <dgm:spPr/>
       <dgm:t>
@@ -5827,7 +5966,7 @@
         </a:p>
       </dgm:t>
     </dgm:pt>
-    <dgm:pt modelId="{90460D4B-7138-4725-ADD6-E6EC2A7BF7EC}">
+    <dgm:pt modelId="{F3AD5EC2-8CFC-44B4-84FC-1EC4053D23F7}">
       <dgm:prSet/>
       <dgm:spPr/>
       <dgm:t>
@@ -5835,13 +5974,14 @@
         <a:lstStyle/>
         <a:p>
           <a:r>
-            <a:rPr lang="en-US" dirty="0"/>
-            <a:t>Components</a:t>
+            <a:rPr lang="en-US" dirty="0" err="1"/>
+            <a:t>ACFilepath</a:t>
           </a:r>
+          <a:endParaRPr lang="en-US" dirty="0"/>
         </a:p>
       </dgm:t>
     </dgm:pt>
-    <dgm:pt modelId="{5CAE3443-D2EC-438E-BAA1-5E5A5619E4B8}" type="parTrans" cxnId="{C963DE92-9FFA-416E-9CBB-F1D96E4F23A2}">
+    <dgm:pt modelId="{26F917EA-AD29-4A3B-B14D-422A7F30E6CB}" type="parTrans" cxnId="{CED242C2-2AE2-4C7E-9544-F89712FBA7FF}">
       <dgm:prSet/>
       <dgm:spPr/>
       <dgm:t>
@@ -5852,7 +5992,7 @@
         </a:p>
       </dgm:t>
     </dgm:pt>
-    <dgm:pt modelId="{023AE1A4-1C73-440E-8E5B-82164B5EE816}" type="sibTrans" cxnId="{C963DE92-9FFA-416E-9CBB-F1D96E4F23A2}">
+    <dgm:pt modelId="{C33D2425-7930-4A96-95D5-06CBB2794C4E}" type="sibTrans" cxnId="{CED242C2-2AE2-4C7E-9544-F89712FBA7FF}">
       <dgm:prSet/>
       <dgm:spPr/>
       <dgm:t>
@@ -5863,44 +6003,7 @@
         </a:p>
       </dgm:t>
     </dgm:pt>
-    <dgm:pt modelId="{C55CDAA4-0A7B-4072-9CD3-6D7896772C6F}">
-      <dgm:prSet/>
-      <dgm:spPr/>
-      <dgm:t>
-        <a:bodyPr/>
-        <a:lstStyle/>
-        <a:p>
-          <a:r>
-            <a:rPr lang="en-US" dirty="0" err="1"/>
-            <a:t>ACAssetType</a:t>
-          </a:r>
-          <a:endParaRPr lang="en-US" dirty="0"/>
-        </a:p>
-      </dgm:t>
-    </dgm:pt>
-    <dgm:pt modelId="{CDF5DCCF-2E2A-4296-AD6C-ABE6E27E5F15}" type="parTrans" cxnId="{E1EA81ED-FE5B-4917-880A-0CA09B45A253}">
-      <dgm:prSet/>
-      <dgm:spPr/>
-      <dgm:t>
-        <a:bodyPr/>
-        <a:lstStyle/>
-        <a:p>
-          <a:endParaRPr lang="en-US"/>
-        </a:p>
-      </dgm:t>
-    </dgm:pt>
-    <dgm:pt modelId="{12918B51-1EE7-4110-A777-AFBA2DE18C29}" type="sibTrans" cxnId="{E1EA81ED-FE5B-4917-880A-0CA09B45A253}">
-      <dgm:prSet/>
-      <dgm:spPr/>
-      <dgm:t>
-        <a:bodyPr/>
-        <a:lstStyle/>
-        <a:p>
-          <a:endParaRPr lang="en-US"/>
-        </a:p>
-      </dgm:t>
-    </dgm:pt>
-    <dgm:pt modelId="{6503583A-94E3-47C8-8A37-17DCFD2C1B40}">
+    <dgm:pt modelId="{F1916642-2267-4C34-90D4-9A328C4E1DB5}">
       <dgm:prSet/>
       <dgm:spPr/>
       <dgm:t>
@@ -5915,7 +6018,7 @@
         </a:p>
       </dgm:t>
     </dgm:pt>
-    <dgm:pt modelId="{C160F51E-FCFD-4661-9B7C-39FB92B88A36}" type="parTrans" cxnId="{A4154A6D-056D-4EE4-A395-C0CF04701971}">
+    <dgm:pt modelId="{5A761C89-37C0-42E1-A17A-FE065BB21FE8}" type="parTrans" cxnId="{2A7B9036-7743-428D-970C-221D33B3A32A}">
       <dgm:prSet/>
       <dgm:spPr/>
       <dgm:t>
@@ -5926,116 +6029,7 @@
         </a:p>
       </dgm:t>
     </dgm:pt>
-    <dgm:pt modelId="{7D0024F7-DB83-4DAB-8350-82F13C69336B}" type="sibTrans" cxnId="{A4154A6D-056D-4EE4-A395-C0CF04701971}">
-      <dgm:prSet/>
-      <dgm:spPr/>
-      <dgm:t>
-        <a:bodyPr/>
-        <a:lstStyle/>
-        <a:p>
-          <a:endParaRPr lang="en-US"/>
-        </a:p>
-      </dgm:t>
-    </dgm:pt>
-    <dgm:pt modelId="{65F19840-B0C0-478D-8303-0247D09C817A}">
-      <dgm:prSet/>
-      <dgm:spPr/>
-      <dgm:t>
-        <a:bodyPr/>
-        <a:lstStyle/>
-        <a:p>
-          <a:r>
-            <a:rPr lang="en-US" dirty="0"/>
-            <a:t>other, asset type specific components</a:t>
-          </a:r>
-        </a:p>
-      </dgm:t>
-    </dgm:pt>
-    <dgm:pt modelId="{F56F0E06-DB59-4373-BCD3-1E620BE207A3}" type="parTrans" cxnId="{F0CA5A45-C6DF-48B3-8B03-B35309CE3725}">
-      <dgm:prSet/>
-      <dgm:spPr/>
-      <dgm:t>
-        <a:bodyPr/>
-        <a:lstStyle/>
-        <a:p>
-          <a:endParaRPr lang="en-US"/>
-        </a:p>
-      </dgm:t>
-    </dgm:pt>
-    <dgm:pt modelId="{1A56BC5E-3F05-4F0F-A1D0-BB1EED387864}" type="sibTrans" cxnId="{F0CA5A45-C6DF-48B3-8B03-B35309CE3725}">
-      <dgm:prSet/>
-      <dgm:spPr/>
-      <dgm:t>
-        <a:bodyPr/>
-        <a:lstStyle/>
-        <a:p>
-          <a:endParaRPr lang="en-US"/>
-        </a:p>
-      </dgm:t>
-    </dgm:pt>
-    <dgm:pt modelId="{78F88E26-8B8C-4948-BF99-63EA46AFCFA3}">
-      <dgm:prSet/>
-      <dgm:spPr/>
-      <dgm:t>
-        <a:bodyPr/>
-        <a:lstStyle/>
-        <a:p>
-          <a:r>
-            <a:rPr lang="en-US" dirty="0"/>
-            <a:t>ACUUID</a:t>
-          </a:r>
-        </a:p>
-      </dgm:t>
-    </dgm:pt>
-    <dgm:pt modelId="{98D5557D-40C2-4744-8D4F-EFF73CDEC0DD}" type="parTrans" cxnId="{B52F73A8-5A20-405E-BFC7-51B34FC95885}">
-      <dgm:prSet/>
-      <dgm:spPr/>
-      <dgm:t>
-        <a:bodyPr/>
-        <a:lstStyle/>
-        <a:p>
-          <a:endParaRPr lang="en-US"/>
-        </a:p>
-      </dgm:t>
-    </dgm:pt>
-    <dgm:pt modelId="{5271797F-73B1-4CF2-8588-CD56DF1624E8}" type="sibTrans" cxnId="{B52F73A8-5A20-405E-BFC7-51B34FC95885}">
-      <dgm:prSet/>
-      <dgm:spPr/>
-      <dgm:t>
-        <a:bodyPr/>
-        <a:lstStyle/>
-        <a:p>
-          <a:endParaRPr lang="en-US"/>
-        </a:p>
-      </dgm:t>
-    </dgm:pt>
-    <dgm:pt modelId="{F3AD5EC2-8CFC-44B4-84FC-1EC4053D23F7}">
-      <dgm:prSet/>
-      <dgm:spPr/>
-      <dgm:t>
-        <a:bodyPr/>
-        <a:lstStyle/>
-        <a:p>
-          <a:r>
-            <a:rPr lang="en-US" dirty="0" err="1"/>
-            <a:t>ACFilepath</a:t>
-          </a:r>
-          <a:endParaRPr lang="en-US" dirty="0"/>
-        </a:p>
-      </dgm:t>
-    </dgm:pt>
-    <dgm:pt modelId="{26F917EA-AD29-4A3B-B14D-422A7F30E6CB}" type="parTrans" cxnId="{CED242C2-2AE2-4C7E-9544-F89712FBA7FF}">
-      <dgm:prSet/>
-      <dgm:spPr/>
-      <dgm:t>
-        <a:bodyPr/>
-        <a:lstStyle/>
-        <a:p>
-          <a:endParaRPr lang="en-US"/>
-        </a:p>
-      </dgm:t>
-    </dgm:pt>
-    <dgm:pt modelId="{C33D2425-7930-4A96-95D5-06CBB2794C4E}" type="sibTrans" cxnId="{CED242C2-2AE2-4C7E-9544-F89712FBA7FF}">
+    <dgm:pt modelId="{6E912344-E919-4CD4-B977-60C503C302CF}" type="sibTrans" cxnId="{2A7B9036-7743-428D-970C-221D33B3A32A}">
       <dgm:prSet/>
       <dgm:spPr/>
       <dgm:t>
@@ -6160,6 +6154,7 @@
   <dgm:cxnLst>
     <dgm:cxn modelId="{9E736601-1061-461E-A7C6-CA854179FFC7}" type="presOf" srcId="{6992C787-FC19-4B56-B86B-85751586ED68}" destId="{3116BB5E-4752-4A55-AB69-BB802C942660}" srcOrd="0" destOrd="6" presId="urn:microsoft.com/office/officeart/2005/8/layout/hList1"/>
     <dgm:cxn modelId="{7FC7E906-E056-4E64-859A-8476EDCD4365}" type="presOf" srcId="{7CB9B775-851A-4061-A9DF-E60947B13BE6}" destId="{2B7C4BE8-A646-4433-9446-B88A77065CA4}" srcOrd="0" destOrd="1" presId="urn:microsoft.com/office/officeart/2005/8/layout/hList1"/>
+    <dgm:cxn modelId="{1F82A507-91AD-4AE9-87E6-CD8150F15D1A}" type="presOf" srcId="{F1916642-2267-4C34-90D4-9A328C4E1DB5}" destId="{6418F341-AB79-40AC-B83F-0228C41F0524}" srcOrd="0" destOrd="5" presId="urn:microsoft.com/office/officeart/2005/8/layout/hList1"/>
     <dgm:cxn modelId="{1E78A00D-9FF8-4862-A084-AC01618389EA}" srcId="{80A0FD3E-C6A0-4AC0-BEE3-F3D680FFDAD0}" destId="{6659A7E7-8158-4A6E-A471-DA323965CCE9}" srcOrd="1" destOrd="0" parTransId="{0651B8AE-3C39-4FE7-BB50-305118B07273}" sibTransId="{6D812D89-DC62-4CF9-8AB3-702740139B84}"/>
     <dgm:cxn modelId="{F463DB0E-8EA0-4B3E-BF98-6DCCC8E81944}" type="presOf" srcId="{80A0FD3E-C6A0-4AC0-BEE3-F3D680FFDAD0}" destId="{80F7A185-5624-45A8-89B6-2DD3BEF2A364}" srcOrd="0" destOrd="0" presId="urn:microsoft.com/office/officeart/2005/8/layout/hList1"/>
     <dgm:cxn modelId="{D43EE20F-EE3E-4A3B-BB12-9F8DE43FDAED}" type="presOf" srcId="{D2C01B18-E3FB-474F-95E7-05455D92D4B8}" destId="{6418F341-AB79-40AC-B83F-0228C41F0524}" srcOrd="0" destOrd="2" presId="urn:microsoft.com/office/officeart/2005/8/layout/hList1"/>
@@ -6167,16 +6162,15 @@
     <dgm:cxn modelId="{1144D218-690B-4503-979B-D44F63A28C40}" type="presOf" srcId="{6503583A-94E3-47C8-8A37-17DCFD2C1B40}" destId="{7FD399BC-E510-491B-A043-67ACAEEF2E3C}" srcOrd="0" destOrd="5" presId="urn:microsoft.com/office/officeart/2005/8/layout/hList1"/>
     <dgm:cxn modelId="{4E60AC19-DD0A-4536-B185-C694DBC110F7}" type="presOf" srcId="{BA1FBE3B-C182-4377-8E40-0B3C0C1956CA}" destId="{18D4A536-73DC-492C-A34F-711BC80D73A7}" srcOrd="0" destOrd="0" presId="urn:microsoft.com/office/officeart/2005/8/layout/hList1"/>
     <dgm:cxn modelId="{A6F8D720-AE9E-45A3-A002-FD66255E424E}" type="presOf" srcId="{CD488F8F-4BCF-4E6E-AB7E-52B6F7DE107C}" destId="{3116BB5E-4752-4A55-AB69-BB802C942660}" srcOrd="0" destOrd="0" presId="urn:microsoft.com/office/officeart/2005/8/layout/hList1"/>
-    <dgm:cxn modelId="{B4FB6B21-7771-467F-B99A-310F26F093AF}" type="presOf" srcId="{03978623-FE6E-4F91-B2D0-9F9AABA0040F}" destId="{6418F341-AB79-40AC-B83F-0228C41F0524}" srcOrd="0" destOrd="5" presId="urn:microsoft.com/office/officeart/2005/8/layout/hList1"/>
     <dgm:cxn modelId="{CA6C1B26-FBB7-4342-85C7-F5442404911A}" type="presOf" srcId="{F3AD5EC2-8CFC-44B4-84FC-1EC4053D23F7}" destId="{7FD399BC-E510-491B-A043-67ACAEEF2E3C}" srcOrd="0" destOrd="4" presId="urn:microsoft.com/office/officeart/2005/8/layout/hList1"/>
     <dgm:cxn modelId="{67253B26-93D2-4227-A902-6B76F8FE4290}" type="presOf" srcId="{2F3812DE-64E3-4474-B1D5-9435A23ED917}" destId="{2B7C4BE8-A646-4433-9446-B88A77065CA4}" srcOrd="0" destOrd="0" presId="urn:microsoft.com/office/officeart/2005/8/layout/hList1"/>
     <dgm:cxn modelId="{8D88D927-A102-426C-AA83-0B2B913EB7BF}" type="presOf" srcId="{90460D4B-7138-4725-ADD6-E6EC2A7BF7EC}" destId="{7FD399BC-E510-491B-A043-67ACAEEF2E3C}" srcOrd="0" destOrd="1" presId="urn:microsoft.com/office/officeart/2005/8/layout/hList1"/>
     <dgm:cxn modelId="{F1C3F229-E489-4B5E-8D0C-E831A502C0EF}" srcId="{6659A7E7-8158-4A6E-A471-DA323965CCE9}" destId="{F8E01428-B033-4EC5-88F3-B8113EC519CA}" srcOrd="2" destOrd="0" parTransId="{457C380B-CE0C-4872-9D79-E197AC5F6652}" sibTransId="{970C36A2-E083-4459-AF8D-EAF96CA16898}"/>
     <dgm:cxn modelId="{C304B02A-9CC1-4BD3-9A9D-36F02B10F04E}" type="presOf" srcId="{829080E2-2793-47D4-8AB2-3E71A7C02F83}" destId="{2B7C4BE8-A646-4433-9446-B88A77065CA4}" srcOrd="0" destOrd="4" presId="urn:microsoft.com/office/officeart/2005/8/layout/hList1"/>
     <dgm:cxn modelId="{51D6F12A-550C-46D0-B0B3-1CAEADD95635}" type="presOf" srcId="{A83B04DA-1E85-46F7-A926-B1713D140BCE}" destId="{7FD399BC-E510-491B-A043-67ACAEEF2E3C}" srcOrd="0" destOrd="0" presId="urn:microsoft.com/office/officeart/2005/8/layout/hList1"/>
-    <dgm:cxn modelId="{A73A9D2C-C596-4800-8F79-27791977C162}" srcId="{007B146B-7043-4DA4-9872-F19B6C46FDB4}" destId="{03978623-FE6E-4F91-B2D0-9F9AABA0040F}" srcOrd="3" destOrd="0" parTransId="{4DA5677F-34FD-461D-B56A-634BB0616E93}" sibTransId="{4FAE4290-A6D8-461D-A11A-BBD725BE9157}"/>
     <dgm:cxn modelId="{E19B1832-913A-4E22-9C28-629DB7F93C5B}" type="presOf" srcId="{F8E01428-B033-4EC5-88F3-B8113EC519CA}" destId="{3116BB5E-4752-4A55-AB69-BB802C942660}" srcOrd="0" destOrd="4" presId="urn:microsoft.com/office/officeart/2005/8/layout/hList1"/>
     <dgm:cxn modelId="{A0A59932-CE58-4460-8CD0-6FB7805F17AF}" srcId="{7039D912-74EB-4508-A920-7B182744F6DB}" destId="{BA1FBE3B-C182-4377-8E40-0B3C0C1956CA}" srcOrd="3" destOrd="0" parTransId="{E30795FF-31C8-476E-809D-96D9B56B0077}" sibTransId="{597A5E4D-60FA-4710-927D-4F0900372DD4}"/>
+    <dgm:cxn modelId="{2A7B9036-7743-428D-970C-221D33B3A32A}" srcId="{007B146B-7043-4DA4-9872-F19B6C46FDB4}" destId="{F1916642-2267-4C34-90D4-9A328C4E1DB5}" srcOrd="3" destOrd="0" parTransId="{5A761C89-37C0-42E1-A17A-FE065BB21FE8}" sibTransId="{6E912344-E919-4CD4-B977-60C503C302CF}"/>
     <dgm:cxn modelId="{8252BB38-8E22-41E9-B65D-14D24DB38772}" type="presOf" srcId="{8118D722-B82D-4483-BDDC-1B53D47D868F}" destId="{6418F341-AB79-40AC-B83F-0228C41F0524}" srcOrd="0" destOrd="0" presId="urn:microsoft.com/office/officeart/2005/8/layout/hList1"/>
     <dgm:cxn modelId="{5150B839-1C83-47F0-B34B-4EE10AD1A6B7}" type="presOf" srcId="{D91083A4-A3FF-46EE-B215-B4E06D455191}" destId="{6418F341-AB79-40AC-B83F-0228C41F0524}" srcOrd="0" destOrd="6" presId="urn:microsoft.com/office/officeart/2005/8/layout/hList1"/>
     <dgm:cxn modelId="{D20A803E-6938-4D68-A359-982984092BEE}" type="presOf" srcId="{C070E80E-8CCB-43DE-89B8-CF105FAAA75A}" destId="{3116BB5E-4752-4A55-AB69-BB802C942660}" srcOrd="0" destOrd="5" presId="urn:microsoft.com/office/officeart/2005/8/layout/hList1"/>
@@ -6286,10 +6280,9 @@
         <a:lstStyle/>
         <a:p>
           <a:r>
-            <a:rPr lang="en-US" dirty="0" err="1"/>
+            <a:rPr lang="en-US" dirty="0"/>
             <a:t>SkinnedModel</a:t>
           </a:r>
-          <a:endParaRPr lang="en-US" dirty="0"/>
         </a:p>
       </dgm:t>
     </dgm:pt>
@@ -6389,10 +6382,9 @@
         <a:lstStyle/>
         <a:p>
           <a:r>
-            <a:rPr lang="en-US" dirty="0" err="1"/>
+            <a:rPr lang="en-US" dirty="0"/>
             <a:t>RenderMesh</a:t>
           </a:r>
-          <a:endParaRPr lang="en-US" dirty="0"/>
         </a:p>
       </dgm:t>
     </dgm:pt>
@@ -6595,7 +6587,7 @@
         <a:p>
           <a:r>
             <a:rPr lang="en-US" dirty="0"/>
-            <a:t>Texture</a:t>
+            <a:t>Texture2D</a:t>
           </a:r>
         </a:p>
       </dgm:t>
@@ -6645,10 +6637,9 @@
         <a:lstStyle/>
         <a:p>
           <a:r>
-            <a:rPr lang="en-US" dirty="0" err="1"/>
+            <a:rPr lang="en-US" dirty="0"/>
             <a:t>ShadingModel</a:t>
           </a:r>
-          <a:endParaRPr lang="en-US" dirty="0"/>
         </a:p>
       </dgm:t>
     </dgm:pt>
@@ -7262,15 +7253,7 @@
           </a:r>
           <a:r>
             <a:rPr lang="en-US" dirty="0"/>
-            <a:t>&lt;</a:t>
-          </a:r>
-          <a:r>
-            <a:rPr lang="en-US" dirty="0" err="1"/>
-            <a:t>RenderMesh</a:t>
-          </a:r>
-          <a:r>
-            <a:rPr lang="en-US" dirty="0"/>
-            <a:t>&gt;</a:t>
+            <a:t>&lt;RenderMesh&gt;</a:t>
           </a:r>
         </a:p>
       </dgm:t>
@@ -7424,15 +7407,7 @@
           </a:r>
           <a:r>
             <a:rPr lang="en-US" dirty="0"/>
-            <a:t>&lt;</a:t>
-          </a:r>
-          <a:r>
-            <a:rPr lang="en-US" dirty="0" err="1"/>
-            <a:t>SkinnedModel</a:t>
-          </a:r>
-          <a:r>
-            <a:rPr lang="en-US" dirty="0"/>
-            <a:t>&gt;</a:t>
+            <a:t>&lt;SkinnedModel&gt;</a:t>
           </a:r>
         </a:p>
       </dgm:t>
@@ -7725,15 +7700,7 @@
           </a:r>
           <a:r>
             <a:rPr lang="en-US" dirty="0"/>
-            <a:t>&lt;</a:t>
-          </a:r>
-          <a:r>
-            <a:rPr lang="en-US" dirty="0" err="1"/>
-            <a:t>RenderMesh</a:t>
-          </a:r>
-          <a:r>
-            <a:rPr lang="en-US" dirty="0"/>
-            <a:t>&gt;&gt;</a:t>
+            <a:t>&lt;RenderMesh&gt;&gt;</a:t>
           </a:r>
         </a:p>
       </dgm:t>
@@ -7930,15 +7897,7 @@
           </a:r>
           <a:r>
             <a:rPr lang="en-US" dirty="0"/>
-            <a:t>&lt;</a:t>
-          </a:r>
-          <a:r>
-            <a:rPr lang="en-US" dirty="0" err="1"/>
-            <a:t>RenderMesh</a:t>
-          </a:r>
-          <a:r>
-            <a:rPr lang="en-US" dirty="0"/>
-            <a:t>&gt;&gt;</a:t>
+            <a:t>&lt;RenderMesh&gt;&gt;</a:t>
           </a:r>
         </a:p>
       </dgm:t>
@@ -8383,10 +8342,9 @@
             <a:buNone/>
           </a:pPr>
           <a:r>
-            <a:rPr lang="en-US" sz="2500" kern="1200" dirty="0" err="1"/>
+            <a:rPr lang="en-US" sz="2500" kern="1200" dirty="0"/>
             <a:t>ShadingModel</a:t>
           </a:r>
-          <a:endParaRPr lang="en-US" sz="2500" kern="1200" dirty="0"/>
         </a:p>
       </dsp:txBody>
       <dsp:txXfrm>
@@ -8588,10 +8546,9 @@
             <a:buNone/>
           </a:pPr>
           <a:r>
-            <a:rPr lang="en-US" sz="2500" kern="1200" dirty="0" err="1"/>
+            <a:rPr lang="en-US" sz="2500" kern="1200" dirty="0"/>
             <a:t>RenderMesh</a:t>
           </a:r>
-          <a:endParaRPr lang="en-US" sz="2500" kern="1200" dirty="0"/>
         </a:p>
       </dsp:txBody>
       <dsp:txXfrm>
@@ -8793,10 +8750,9 @@
             <a:buNone/>
           </a:pPr>
           <a:r>
-            <a:rPr lang="en-US" sz="2500" kern="1200" dirty="0" err="1"/>
+            <a:rPr lang="en-US" sz="2500" kern="1200" dirty="0"/>
             <a:t>SkinnedModel</a:t>
           </a:r>
-          <a:endParaRPr lang="en-US" sz="2500" kern="1200" dirty="0"/>
         </a:p>
       </dsp:txBody>
       <dsp:txXfrm>
@@ -9095,8 +9051,8 @@
       </dsp:nvSpPr>
       <dsp:spPr>
         <a:xfrm>
-          <a:off x="4282" y="269371"/>
-          <a:ext cx="2575156" cy="489600"/>
+          <a:off x="4282" y="128873"/>
+          <a:ext cx="2575156" cy="518400"/>
         </a:xfrm>
         <a:prstGeom prst="rect">
           <a:avLst/>
@@ -9138,12 +9094,12 @@
         </a:fontRef>
       </dsp:style>
       <dsp:txBody>
-        <a:bodyPr spcFirstLastPara="0" vert="horz" wrap="square" lIns="120904" tIns="69088" rIns="120904" bIns="69088" numCol="1" spcCol="1270" anchor="ctr" anchorCtr="0">
+        <a:bodyPr spcFirstLastPara="0" vert="horz" wrap="square" lIns="128016" tIns="73152" rIns="128016" bIns="73152" numCol="1" spcCol="1270" anchor="ctr" anchorCtr="0">
           <a:noAutofit/>
         </a:bodyPr>
         <a:lstStyle/>
         <a:p>
-          <a:pPr marL="0" lvl="0" indent="0" algn="ctr" defTabSz="755650">
+          <a:pPr marL="0" lvl="0" indent="0" algn="ctr" defTabSz="800100">
             <a:lnSpc>
               <a:spcPct val="90000"/>
             </a:lnSpc>
@@ -9156,14 +9112,14 @@
             <a:buNone/>
           </a:pPr>
           <a:r>
-            <a:rPr lang="en-US" sz="1700" kern="1200" dirty="0"/>
+            <a:rPr lang="en-US" sz="1800" kern="1200" dirty="0"/>
             <a:t>Project Asset</a:t>
           </a:r>
         </a:p>
       </dsp:txBody>
       <dsp:txXfrm>
-        <a:off x="4282" y="269371"/>
-        <a:ext cx="2575156" cy="489600"/>
+        <a:off x="4282" y="128873"/>
+        <a:ext cx="2575156" cy="518400"/>
       </dsp:txXfrm>
     </dsp:sp>
     <dsp:sp modelId="{3116BB5E-4752-4A55-AB69-BB802C942660}">
@@ -9173,8 +9129,8 @@
       </dsp:nvSpPr>
       <dsp:spPr>
         <a:xfrm>
-          <a:off x="4282" y="758971"/>
-          <a:ext cx="2575156" cy="4287346"/>
+          <a:off x="4282" y="647273"/>
+          <a:ext cx="2575156" cy="4539543"/>
         </a:xfrm>
         <a:prstGeom prst="rect">
           <a:avLst/>
@@ -9218,12 +9174,12 @@
         <a:fontRef idx="minor"/>
       </dsp:style>
       <dsp:txBody>
-        <a:bodyPr spcFirstLastPara="0" vert="horz" wrap="square" lIns="90678" tIns="90678" rIns="120904" bIns="136017" numCol="1" spcCol="1270" anchor="t" anchorCtr="0">
+        <a:bodyPr spcFirstLastPara="0" vert="horz" wrap="square" lIns="96012" tIns="96012" rIns="128016" bIns="144018" numCol="1" spcCol="1270" anchor="t" anchorCtr="0">
           <a:noAutofit/>
         </a:bodyPr>
         <a:lstStyle/>
         <a:p>
-          <a:pPr marL="171450" lvl="1" indent="-171450" algn="l" defTabSz="755650">
+          <a:pPr marL="171450" lvl="1" indent="-171450" algn="l" defTabSz="800100">
             <a:lnSpc>
               <a:spcPct val="90000"/>
             </a:lnSpc>
@@ -9236,12 +9192,12 @@
             <a:buChar char="•"/>
           </a:pPr>
           <a:r>
-            <a:rPr lang="en-US" sz="1700" kern="1200" dirty="0"/>
+            <a:rPr lang="en-US" sz="1800" kern="1200" dirty="0"/>
             <a:t>Assets that the game developer operates on.</a:t>
           </a:r>
         </a:p>
         <a:p>
-          <a:pPr marL="171450" lvl="1" indent="-171450" algn="l" defTabSz="755650">
+          <a:pPr marL="171450" lvl="1" indent="-171450" algn="l" defTabSz="800100">
             <a:lnSpc>
               <a:spcPct val="90000"/>
             </a:lnSpc>
@@ -9254,12 +9210,12 @@
             <a:buChar char="•"/>
           </a:pPr>
           <a:r>
-            <a:rPr lang="en-US" sz="1700" kern="1200" dirty="0"/>
+            <a:rPr lang="en-US" sz="1800" kern="1200" dirty="0"/>
             <a:t>Components:</a:t>
           </a:r>
         </a:p>
         <a:p>
-          <a:pPr marL="342900" lvl="2" indent="-171450" algn="l" defTabSz="755650">
+          <a:pPr marL="342900" lvl="2" indent="-171450" algn="l" defTabSz="800100">
             <a:lnSpc>
               <a:spcPct val="90000"/>
             </a:lnSpc>
@@ -9272,13 +9228,13 @@
             <a:buChar char="•"/>
           </a:pPr>
           <a:r>
-            <a:rPr lang="en-US" sz="1700" kern="1200" dirty="0" err="1"/>
+            <a:rPr lang="en-US" sz="1800" kern="1200" dirty="0" err="1"/>
             <a:t>ACAssetType</a:t>
           </a:r>
-          <a:endParaRPr lang="en-US" sz="1700" kern="1200" dirty="0"/>
+          <a:endParaRPr lang="en-US" sz="1800" kern="1200" dirty="0"/>
         </a:p>
         <a:p>
-          <a:pPr marL="342900" lvl="2" indent="-171450" algn="l" defTabSz="755650">
+          <a:pPr marL="342900" lvl="2" indent="-171450" algn="l" defTabSz="800100">
             <a:lnSpc>
               <a:spcPct val="90000"/>
             </a:lnSpc>
@@ -9291,12 +9247,12 @@
             <a:buChar char="•"/>
           </a:pPr>
           <a:r>
-            <a:rPr lang="en-US" sz="1700" kern="1200" dirty="0"/>
+            <a:rPr lang="en-US" sz="1800" kern="1200" dirty="0"/>
             <a:t>ACUUID</a:t>
           </a:r>
         </a:p>
         <a:p>
-          <a:pPr marL="342900" lvl="2" indent="-171450" algn="l" defTabSz="755650">
+          <a:pPr marL="342900" lvl="2" indent="-171450" algn="l" defTabSz="800100">
             <a:lnSpc>
               <a:spcPct val="90000"/>
             </a:lnSpc>
@@ -9309,13 +9265,13 @@
             <a:buChar char="•"/>
           </a:pPr>
           <a:r>
-            <a:rPr lang="en-US" sz="1700" kern="1200" dirty="0" err="1"/>
+            <a:rPr lang="en-US" sz="1800" kern="1200" dirty="0" err="1"/>
             <a:t>ACFilepath</a:t>
           </a:r>
-          <a:endParaRPr lang="en-US" sz="1700" kern="1200" dirty="0"/>
+          <a:endParaRPr lang="en-US" sz="1800" kern="1200" dirty="0"/>
         </a:p>
         <a:p>
-          <a:pPr marL="342900" lvl="2" indent="-171450" algn="l" defTabSz="755650">
+          <a:pPr marL="342900" lvl="2" indent="-171450" algn="l" defTabSz="800100">
             <a:lnSpc>
               <a:spcPct val="90000"/>
             </a:lnSpc>
@@ -9328,36 +9284,36 @@
             <a:buChar char="•"/>
           </a:pPr>
           <a:r>
-            <a:rPr lang="en-US" sz="1700" kern="1200" dirty="0" err="1"/>
+            <a:rPr lang="en-US" sz="1800" kern="1200" dirty="0" err="1"/>
             <a:t>ACSourceFilepath</a:t>
           </a:r>
           <a:br>
-            <a:rPr lang="pl-PL" sz="1700" kern="1200" dirty="0"/>
+            <a:rPr lang="pl-PL" sz="1800" kern="1200" dirty="0"/>
           </a:br>
           <a:r>
-            <a:rPr lang="pl-PL" sz="1700" kern="1200" dirty="0"/>
+            <a:rPr lang="pl-PL" sz="1800" kern="1200" dirty="0"/>
             <a:t>(</a:t>
           </a:r>
           <a:r>
-            <a:rPr lang="pl-PL" sz="1700" kern="1200" dirty="0" err="1"/>
+            <a:rPr lang="pl-PL" sz="1800" kern="1200" dirty="0" err="1"/>
             <a:t>if</a:t>
           </a:r>
           <a:r>
-            <a:rPr lang="pl-PL" sz="1700" kern="1200" dirty="0"/>
+            <a:rPr lang="pl-PL" sz="1800" kern="1200" dirty="0"/>
             <a:t> </a:t>
           </a:r>
           <a:r>
-            <a:rPr lang="pl-PL" sz="1700" kern="1200" dirty="0" err="1"/>
+            <a:rPr lang="pl-PL" sz="1800" kern="1200" dirty="0" err="1"/>
             <a:t>needed</a:t>
           </a:r>
           <a:r>
-            <a:rPr lang="pl-PL" sz="1700" kern="1200" dirty="0"/>
+            <a:rPr lang="pl-PL" sz="1800" kern="1200" dirty="0"/>
             <a:t>)</a:t>
           </a:r>
-          <a:endParaRPr lang="en-US" sz="1700" kern="1200" dirty="0"/>
+          <a:endParaRPr lang="en-US" sz="1800" kern="1200" dirty="0"/>
         </a:p>
         <a:p>
-          <a:pPr marL="342900" lvl="2" indent="-171450" algn="l" defTabSz="755650">
+          <a:pPr marL="342900" lvl="2" indent="-171450" algn="l" defTabSz="800100">
             <a:lnSpc>
               <a:spcPct val="90000"/>
             </a:lnSpc>
@@ -9370,13 +9326,13 @@
             <a:buChar char="•"/>
           </a:pPr>
           <a:r>
-            <a:rPr lang="en-US" sz="1700" kern="1200" dirty="0" err="1"/>
+            <a:rPr lang="en-US" sz="1800" kern="1200" dirty="0" err="1"/>
             <a:t>ACRefsCounters</a:t>
           </a:r>
-          <a:endParaRPr lang="en-US" sz="1700" kern="1200" dirty="0"/>
+          <a:endParaRPr lang="en-US" sz="1800" kern="1200" dirty="0"/>
         </a:p>
         <a:p>
-          <a:pPr marL="342900" lvl="2" indent="-171450" algn="l" defTabSz="755650">
+          <a:pPr marL="342900" lvl="2" indent="-171450" algn="l" defTabSz="800100">
             <a:lnSpc>
               <a:spcPct val="90000"/>
             </a:lnSpc>
@@ -9389,27 +9345,27 @@
             <a:buChar char="•"/>
           </a:pPr>
           <a:r>
-            <a:rPr lang="en-US" sz="1700" kern="1200" dirty="0" err="1"/>
+            <a:rPr lang="en-US" sz="1800" kern="1200" dirty="0" err="1"/>
             <a:t>CoreComponent</a:t>
           </a:r>
           <a:br>
-            <a:rPr lang="en-US" sz="1700" kern="1200" dirty="0"/>
+            <a:rPr lang="en-US" sz="1800" kern="1200" dirty="0"/>
           </a:br>
           <a:r>
-            <a:rPr lang="en-US" sz="1700" kern="1200" dirty="0"/>
+            <a:rPr lang="en-US" sz="1800" kern="1200" dirty="0"/>
             <a:t>(asset’s meta data and </a:t>
           </a:r>
           <a:r>
-            <a:rPr lang="en-US" sz="1700" kern="1200" dirty="0" err="1"/>
+            <a:rPr lang="en-US" sz="1800" kern="1200" dirty="0" err="1"/>
             <a:t>ptrs</a:t>
           </a:r>
           <a:r>
-            <a:rPr lang="en-US" sz="1700" kern="1200" dirty="0"/>
+            <a:rPr lang="en-US" sz="1800" kern="1200" dirty="0"/>
             <a:t> to data)</a:t>
           </a:r>
         </a:p>
         <a:p>
-          <a:pPr marL="342900" lvl="2" indent="-171450" algn="l" defTabSz="755650">
+          <a:pPr marL="342900" lvl="2" indent="-171450" algn="l" defTabSz="800100">
             <a:lnSpc>
               <a:spcPct val="90000"/>
             </a:lnSpc>
@@ -9422,14 +9378,14 @@
             <a:buChar char="•"/>
           </a:pPr>
           <a:r>
-            <a:rPr lang="en-US" sz="1700" kern="1200" dirty="0"/>
+            <a:rPr lang="en-US" sz="1800" kern="1200" dirty="0"/>
             <a:t>other, asset type specific components</a:t>
           </a:r>
         </a:p>
       </dsp:txBody>
       <dsp:txXfrm>
-        <a:off x="4282" y="758971"/>
-        <a:ext cx="2575156" cy="4287346"/>
+        <a:off x="4282" y="647273"/>
+        <a:ext cx="2575156" cy="4539543"/>
       </dsp:txXfrm>
     </dsp:sp>
     <dsp:sp modelId="{E09129F2-95E6-4C8B-BC91-BBC3BDA85498}">
@@ -9439,8 +9395,8 @@
       </dsp:nvSpPr>
       <dsp:spPr>
         <a:xfrm>
-          <a:off x="2939961" y="269371"/>
-          <a:ext cx="2575156" cy="489600"/>
+          <a:off x="2939961" y="128873"/>
+          <a:ext cx="2575156" cy="518400"/>
         </a:xfrm>
         <a:prstGeom prst="rect">
           <a:avLst/>
@@ -9482,12 +9438,12 @@
         </a:fontRef>
       </dsp:style>
       <dsp:txBody>
-        <a:bodyPr spcFirstLastPara="0" vert="horz" wrap="square" lIns="120904" tIns="69088" rIns="120904" bIns="69088" numCol="1" spcCol="1270" anchor="ctr" anchorCtr="0">
+        <a:bodyPr spcFirstLastPara="0" vert="horz" wrap="square" lIns="128016" tIns="73152" rIns="128016" bIns="73152" numCol="1" spcCol="1270" anchor="ctr" anchorCtr="0">
           <a:noAutofit/>
         </a:bodyPr>
         <a:lstStyle/>
         <a:p>
-          <a:pPr marL="0" lvl="0" indent="0" algn="ctr" defTabSz="755650">
+          <a:pPr marL="0" lvl="0" indent="0" algn="ctr" defTabSz="800100">
             <a:lnSpc>
               <a:spcPct val="90000"/>
             </a:lnSpc>
@@ -9500,14 +9456,14 @@
             <a:buNone/>
           </a:pPr>
           <a:r>
-            <a:rPr lang="en-US" sz="1700" kern="1200" dirty="0"/>
-            <a:t>Internal Asset</a:t>
+            <a:rPr lang="en-US" sz="1800" kern="1200" dirty="0"/>
+            <a:t>Unit Asset</a:t>
           </a:r>
         </a:p>
       </dsp:txBody>
       <dsp:txXfrm>
-        <a:off x="2939961" y="269371"/>
-        <a:ext cx="2575156" cy="489600"/>
+        <a:off x="2939961" y="128873"/>
+        <a:ext cx="2575156" cy="518400"/>
       </dsp:txXfrm>
     </dsp:sp>
     <dsp:sp modelId="{6418F341-AB79-40AC-B83F-0228C41F0524}">
@@ -9517,8 +9473,8 @@
       </dsp:nvSpPr>
       <dsp:spPr>
         <a:xfrm>
-          <a:off x="2939961" y="758971"/>
-          <a:ext cx="2575156" cy="4287346"/>
+          <a:off x="2939961" y="647273"/>
+          <a:ext cx="2575156" cy="4539543"/>
         </a:xfrm>
         <a:prstGeom prst="rect">
           <a:avLst/>
@@ -9562,12 +9518,12 @@
         <a:fontRef idx="minor"/>
       </dsp:style>
       <dsp:txBody>
-        <a:bodyPr spcFirstLastPara="0" vert="horz" wrap="square" lIns="90678" tIns="90678" rIns="120904" bIns="136017" numCol="1" spcCol="1270" anchor="t" anchorCtr="0">
+        <a:bodyPr spcFirstLastPara="0" vert="horz" wrap="square" lIns="96012" tIns="96012" rIns="128016" bIns="144018" numCol="1" spcCol="1270" anchor="t" anchorCtr="0">
           <a:noAutofit/>
         </a:bodyPr>
         <a:lstStyle/>
         <a:p>
-          <a:pPr marL="171450" lvl="1" indent="-171450" algn="l" defTabSz="755650">
+          <a:pPr marL="171450" lvl="1" indent="-171450" algn="l" defTabSz="800100">
             <a:lnSpc>
               <a:spcPct val="90000"/>
             </a:lnSpc>
@@ -9580,21 +9536,21 @@
             <a:buChar char="•"/>
           </a:pPr>
           <a:r>
-            <a:rPr lang="en-US" sz="1700" kern="1200" dirty="0"/>
-            <a:t>Internal Assets are only ever referenced by other asset</a:t>
+            <a:rPr lang="en-US" sz="1800" kern="1200" dirty="0"/>
+            <a:t>Unit Assets are only ever referenced by other asset</a:t>
           </a:r>
           <a:r>
-            <a:rPr lang="en-US" sz="1700" kern="1200" noProof="0" dirty="0"/>
+            <a:rPr lang="en-US" sz="1800" kern="1200" noProof="0" dirty="0"/>
             <a:t>s. They are conceptually parts of Project Assets and they get imported and loaded together. They are fully</a:t>
           </a:r>
           <a:r>
-            <a:rPr lang="en-US" sz="1700" kern="1200" dirty="0"/>
+            <a:rPr lang="en-US" sz="1800" kern="1200" dirty="0"/>
             <a:t> hidden from the user.</a:t>
           </a:r>
-          <a:endParaRPr lang="en-US" sz="1700" kern="1200" noProof="0" dirty="0"/>
+          <a:endParaRPr lang="en-US" sz="1800" kern="1200" noProof="0" dirty="0"/>
         </a:p>
         <a:p>
-          <a:pPr marL="171450" lvl="1" indent="-171450" algn="l" defTabSz="755650">
+          <a:pPr marL="171450" lvl="1" indent="-171450" algn="l" defTabSz="800100">
             <a:lnSpc>
               <a:spcPct val="90000"/>
             </a:lnSpc>
@@ -9607,12 +9563,12 @@
             <a:buChar char="•"/>
           </a:pPr>
           <a:r>
-            <a:rPr lang="en-US" sz="1700" kern="1200" dirty="0"/>
+            <a:rPr lang="en-US" sz="1800" kern="1200" dirty="0"/>
             <a:t>Components:</a:t>
           </a:r>
         </a:p>
         <a:p>
-          <a:pPr marL="342900" lvl="2" indent="-171450" algn="l" defTabSz="755650">
+          <a:pPr marL="342900" lvl="2" indent="-171450" algn="l" defTabSz="800100">
             <a:lnSpc>
               <a:spcPct val="90000"/>
             </a:lnSpc>
@@ -9625,13 +9581,13 @@
             <a:buChar char="•"/>
           </a:pPr>
           <a:r>
-            <a:rPr lang="en-US" sz="1700" kern="1200" dirty="0" err="1"/>
+            <a:rPr lang="en-US" sz="1800" kern="1200" dirty="0" err="1"/>
             <a:t>ACAssetType</a:t>
           </a:r>
-          <a:endParaRPr lang="en-US" sz="1700" kern="1200" dirty="0"/>
+          <a:endParaRPr lang="en-US" sz="1800" kern="1200" dirty="0"/>
         </a:p>
         <a:p>
-          <a:pPr marL="342900" lvl="2" indent="-171450" algn="l" defTabSz="755650">
+          <a:pPr marL="342900" lvl="2" indent="-171450" algn="l" defTabSz="800100">
             <a:lnSpc>
               <a:spcPct val="90000"/>
             </a:lnSpc>
@@ -9644,12 +9600,12 @@
             <a:buChar char="•"/>
           </a:pPr>
           <a:r>
-            <a:rPr lang="en-US" sz="1700" kern="1200" dirty="0"/>
+            <a:rPr lang="en-US" sz="1800" kern="1200" dirty="0"/>
             <a:t>ACUUID</a:t>
           </a:r>
         </a:p>
         <a:p>
-          <a:pPr marL="342900" lvl="2" indent="-171450" algn="l" defTabSz="755650">
+          <a:pPr marL="342900" lvl="2" indent="-171450" algn="l" defTabSz="800100">
             <a:lnSpc>
               <a:spcPct val="90000"/>
             </a:lnSpc>
@@ -9662,16 +9618,13 @@
             <a:buChar char="•"/>
           </a:pPr>
           <a:r>
-            <a:rPr lang="en-US" sz="1700" kern="1200" dirty="0" err="1"/>
-            <a:t>ACMasterAsset</a:t>
+            <a:rPr lang="en-US" sz="1800" kern="1200" dirty="0" err="1"/>
+            <a:t>ACProjectAsset</a:t>
           </a:r>
-          <a:r>
-            <a:rPr lang="en-US" sz="1700" kern="1200" dirty="0"/>
-            <a:t> (ref back to Project Asset)</a:t>
-          </a:r>
+          <a:endParaRPr lang="en-US" sz="1800" kern="1200" dirty="0"/>
         </a:p>
         <a:p>
-          <a:pPr marL="342900" lvl="2" indent="-171450" algn="l" defTabSz="755650">
+          <a:pPr marL="342900" lvl="2" indent="-171450" algn="l" defTabSz="800100">
             <a:lnSpc>
               <a:spcPct val="90000"/>
             </a:lnSpc>
@@ -9684,13 +9637,13 @@
             <a:buChar char="•"/>
           </a:pPr>
           <a:r>
-            <a:rPr lang="en-US" sz="1700" kern="1200" dirty="0" err="1"/>
+            <a:rPr lang="en-US" sz="1800" kern="1200" dirty="0" err="1"/>
             <a:t>CoreComponent</a:t>
           </a:r>
-          <a:endParaRPr lang="en-US" sz="1700" kern="1200" dirty="0"/>
+          <a:endParaRPr lang="en-US" sz="1800" kern="1200" dirty="0"/>
         </a:p>
         <a:p>
-          <a:pPr marL="342900" lvl="2" indent="-171450" algn="l" defTabSz="755650">
+          <a:pPr marL="342900" lvl="2" indent="-171450" algn="l" defTabSz="800100">
             <a:lnSpc>
               <a:spcPct val="90000"/>
             </a:lnSpc>
@@ -9703,14 +9656,14 @@
             <a:buChar char="•"/>
           </a:pPr>
           <a:r>
-            <a:rPr lang="en-US" sz="1700" kern="1200" dirty="0"/>
-            <a:t>other, asset type specific components</a:t>
+            <a:rPr lang="en-US" sz="1800" kern="1200" dirty="0"/>
+            <a:t>other, asset type specific, components</a:t>
           </a:r>
         </a:p>
       </dsp:txBody>
       <dsp:txXfrm>
-        <a:off x="2939961" y="758971"/>
-        <a:ext cx="2575156" cy="4287346"/>
+        <a:off x="2939961" y="647273"/>
+        <a:ext cx="2575156" cy="4539543"/>
       </dsp:txXfrm>
     </dsp:sp>
     <dsp:sp modelId="{A97189DC-B62A-4226-BE84-683C8D0EEFD3}">
@@ -9720,8 +9673,8 @@
       </dsp:nvSpPr>
       <dsp:spPr>
         <a:xfrm>
-          <a:off x="5875640" y="269371"/>
-          <a:ext cx="2575156" cy="489600"/>
+          <a:off x="5875640" y="128873"/>
+          <a:ext cx="2575156" cy="518400"/>
         </a:xfrm>
         <a:prstGeom prst="rect">
           <a:avLst/>
@@ -9763,12 +9716,12 @@
         </a:fontRef>
       </dsp:style>
       <dsp:txBody>
-        <a:bodyPr spcFirstLastPara="0" vert="horz" wrap="square" lIns="120904" tIns="69088" rIns="120904" bIns="69088" numCol="1" spcCol="1270" anchor="ctr" anchorCtr="0">
+        <a:bodyPr spcFirstLastPara="0" vert="horz" wrap="square" lIns="128016" tIns="73152" rIns="128016" bIns="73152" numCol="1" spcCol="1270" anchor="ctr" anchorCtr="0">
           <a:noAutofit/>
         </a:bodyPr>
         <a:lstStyle/>
         <a:p>
-          <a:pPr marL="0" lvl="0" indent="0" algn="ctr" defTabSz="755650">
+          <a:pPr marL="0" lvl="0" indent="0" algn="ctr" defTabSz="800100">
             <a:lnSpc>
               <a:spcPct val="90000"/>
             </a:lnSpc>
@@ -9781,14 +9734,14 @@
             <a:buNone/>
           </a:pPr>
           <a:r>
-            <a:rPr lang="en-US" sz="1700" kern="1200" dirty="0"/>
+            <a:rPr lang="en-US" sz="1800" kern="1200" dirty="0"/>
             <a:t>Editor Asset</a:t>
           </a:r>
         </a:p>
       </dsp:txBody>
       <dsp:txXfrm>
-        <a:off x="5875640" y="269371"/>
-        <a:ext cx="2575156" cy="489600"/>
+        <a:off x="5875640" y="128873"/>
+        <a:ext cx="2575156" cy="518400"/>
       </dsp:txXfrm>
     </dsp:sp>
     <dsp:sp modelId="{2B7C4BE8-A646-4433-9446-B88A77065CA4}">
@@ -9798,8 +9751,8 @@
       </dsp:nvSpPr>
       <dsp:spPr>
         <a:xfrm>
-          <a:off x="5875640" y="758971"/>
-          <a:ext cx="2575156" cy="4287346"/>
+          <a:off x="5875640" y="647273"/>
+          <a:ext cx="2575156" cy="4539543"/>
         </a:xfrm>
         <a:prstGeom prst="rect">
           <a:avLst/>
@@ -9843,12 +9796,12 @@
         <a:fontRef idx="minor"/>
       </dsp:style>
       <dsp:txBody>
-        <a:bodyPr spcFirstLastPara="0" vert="horz" wrap="square" lIns="90678" tIns="90678" rIns="120904" bIns="136017" numCol="1" spcCol="1270" anchor="t" anchorCtr="0">
+        <a:bodyPr spcFirstLastPara="0" vert="horz" wrap="square" lIns="96012" tIns="96012" rIns="128016" bIns="144018" numCol="1" spcCol="1270" anchor="t" anchorCtr="0">
           <a:noAutofit/>
         </a:bodyPr>
         <a:lstStyle/>
         <a:p>
-          <a:pPr marL="171450" lvl="1" indent="-171450" algn="l" defTabSz="755650">
+          <a:pPr marL="171450" lvl="1" indent="-171450" algn="l" defTabSz="800100">
             <a:lnSpc>
               <a:spcPct val="90000"/>
             </a:lnSpc>
@@ -9861,12 +9814,12 @@
             <a:buChar char="•"/>
           </a:pPr>
           <a:r>
-            <a:rPr lang="en-US" sz="1700" kern="1200" dirty="0"/>
+            <a:rPr lang="en-US" sz="1800" kern="1200" dirty="0"/>
             <a:t>Assets used by only by editor (e.g. icons).</a:t>
           </a:r>
         </a:p>
         <a:p>
-          <a:pPr marL="171450" lvl="1" indent="-171450" algn="l" defTabSz="755650">
+          <a:pPr marL="171450" lvl="1" indent="-171450" algn="l" defTabSz="800100">
             <a:lnSpc>
               <a:spcPct val="90000"/>
             </a:lnSpc>
@@ -9879,12 +9832,12 @@
             <a:buChar char="•"/>
           </a:pPr>
           <a:r>
-            <a:rPr lang="en-US" sz="1700" kern="1200" dirty="0"/>
+            <a:rPr lang="en-US" sz="1800" kern="1200" dirty="0"/>
             <a:t>Components</a:t>
           </a:r>
         </a:p>
         <a:p>
-          <a:pPr marL="342900" lvl="2" indent="-171450" algn="l" defTabSz="755650">
+          <a:pPr marL="342900" lvl="2" indent="-171450" algn="l" defTabSz="800100">
             <a:lnSpc>
               <a:spcPct val="90000"/>
             </a:lnSpc>
@@ -9897,13 +9850,13 @@
             <a:buChar char="•"/>
           </a:pPr>
           <a:r>
-            <a:rPr lang="en-US" sz="1700" kern="1200" dirty="0" err="1"/>
+            <a:rPr lang="en-US" sz="1800" kern="1200" dirty="0" err="1"/>
             <a:t>ACAssetType</a:t>
           </a:r>
-          <a:endParaRPr lang="en-US" sz="1700" kern="1200" dirty="0"/>
+          <a:endParaRPr lang="en-US" sz="1800" kern="1200" dirty="0"/>
         </a:p>
         <a:p>
-          <a:pPr marL="342900" lvl="2" indent="-171450" algn="l" defTabSz="755650">
+          <a:pPr marL="342900" lvl="2" indent="-171450" algn="l" defTabSz="800100">
             <a:lnSpc>
               <a:spcPct val="90000"/>
             </a:lnSpc>
@@ -9916,13 +9869,13 @@
             <a:buChar char="•"/>
           </a:pPr>
           <a:r>
-            <a:rPr lang="en-US" sz="1700" kern="1200" dirty="0" err="1"/>
+            <a:rPr lang="en-US" sz="1800" kern="1200" dirty="0" err="1"/>
             <a:t>CoreComponent</a:t>
           </a:r>
-          <a:endParaRPr lang="en-US" sz="1700" kern="1200" dirty="0"/>
+          <a:endParaRPr lang="en-US" sz="1800" kern="1200" dirty="0"/>
         </a:p>
         <a:p>
-          <a:pPr marL="342900" lvl="2" indent="-171450" algn="l" defTabSz="755650">
+          <a:pPr marL="342900" lvl="2" indent="-171450" algn="l" defTabSz="800100">
             <a:lnSpc>
               <a:spcPct val="90000"/>
             </a:lnSpc>
@@ -9935,14 +9888,14 @@
             <a:buChar char="•"/>
           </a:pPr>
           <a:r>
-            <a:rPr lang="en-US" sz="1700" kern="1200" dirty="0"/>
+            <a:rPr lang="en-US" sz="1800" kern="1200" dirty="0"/>
             <a:t>other, asset type specific components</a:t>
           </a:r>
         </a:p>
       </dsp:txBody>
       <dsp:txXfrm>
-        <a:off x="5875640" y="758971"/>
-        <a:ext cx="2575156" cy="4287346"/>
+        <a:off x="5875640" y="647273"/>
+        <a:ext cx="2575156" cy="4539543"/>
       </dsp:txXfrm>
     </dsp:sp>
     <dsp:sp modelId="{18D4A536-73DC-492C-A34F-711BC80D73A7}">
@@ -9952,8 +9905,8 @@
       </dsp:nvSpPr>
       <dsp:spPr>
         <a:xfrm>
-          <a:off x="8811319" y="269371"/>
-          <a:ext cx="2575156" cy="489600"/>
+          <a:off x="8811319" y="128873"/>
+          <a:ext cx="2575156" cy="518400"/>
         </a:xfrm>
         <a:prstGeom prst="rect">
           <a:avLst/>
@@ -9995,12 +9948,12 @@
         </a:fontRef>
       </dsp:style>
       <dsp:txBody>
-        <a:bodyPr spcFirstLastPara="0" vert="horz" wrap="square" lIns="120904" tIns="69088" rIns="120904" bIns="69088" numCol="1" spcCol="1270" anchor="ctr" anchorCtr="0">
+        <a:bodyPr spcFirstLastPara="0" vert="horz" wrap="square" lIns="128016" tIns="73152" rIns="128016" bIns="73152" numCol="1" spcCol="1270" anchor="ctr" anchorCtr="0">
           <a:noAutofit/>
         </a:bodyPr>
         <a:lstStyle/>
         <a:p>
-          <a:pPr marL="0" lvl="0" indent="0" algn="ctr" defTabSz="755650">
+          <a:pPr marL="0" lvl="0" indent="0" algn="ctr" defTabSz="800100">
             <a:lnSpc>
               <a:spcPct val="90000"/>
             </a:lnSpc>
@@ -10013,14 +9966,14 @@
             <a:buNone/>
           </a:pPr>
           <a:r>
-            <a:rPr lang="en-US" sz="1700" kern="1200" dirty="0"/>
+            <a:rPr lang="en-US" sz="1800" kern="1200" dirty="0"/>
             <a:t>Base Asset</a:t>
           </a:r>
         </a:p>
       </dsp:txBody>
       <dsp:txXfrm>
-        <a:off x="8811319" y="269371"/>
-        <a:ext cx="2575156" cy="489600"/>
+        <a:off x="8811319" y="128873"/>
+        <a:ext cx="2575156" cy="518400"/>
       </dsp:txXfrm>
     </dsp:sp>
     <dsp:sp modelId="{7FD399BC-E510-491B-A043-67ACAEEF2E3C}">
@@ -10030,8 +9983,8 @@
       </dsp:nvSpPr>
       <dsp:spPr>
         <a:xfrm>
-          <a:off x="8811319" y="758971"/>
-          <a:ext cx="2575156" cy="4287346"/>
+          <a:off x="8811319" y="647273"/>
+          <a:ext cx="2575156" cy="4539543"/>
         </a:xfrm>
         <a:prstGeom prst="rect">
           <a:avLst/>
@@ -10075,12 +10028,12 @@
         <a:fontRef idx="minor"/>
       </dsp:style>
       <dsp:txBody>
-        <a:bodyPr spcFirstLastPara="0" vert="horz" wrap="square" lIns="90678" tIns="90678" rIns="120904" bIns="136017" numCol="1" spcCol="1270" anchor="t" anchorCtr="0">
+        <a:bodyPr spcFirstLastPara="0" vert="horz" wrap="square" lIns="96012" tIns="96012" rIns="128016" bIns="144018" numCol="1" spcCol="1270" anchor="t" anchorCtr="0">
           <a:noAutofit/>
         </a:bodyPr>
         <a:lstStyle/>
         <a:p>
-          <a:pPr marL="171450" lvl="1" indent="-171450" algn="l" defTabSz="755650">
+          <a:pPr marL="171450" lvl="1" indent="-171450" algn="l" defTabSz="800100">
             <a:lnSpc>
               <a:spcPct val="90000"/>
             </a:lnSpc>
@@ -10093,12 +10046,12 @@
             <a:buChar char="•"/>
           </a:pPr>
           <a:r>
-            <a:rPr lang="en-US" sz="1700" kern="1200" dirty="0"/>
+            <a:rPr lang="en-US" sz="1800" kern="1200" dirty="0"/>
             <a:t>Assets build-in to the engine used by default.</a:t>
           </a:r>
         </a:p>
         <a:p>
-          <a:pPr marL="171450" lvl="1" indent="-171450" algn="l" defTabSz="755650">
+          <a:pPr marL="171450" lvl="1" indent="-171450" algn="l" defTabSz="800100">
             <a:lnSpc>
               <a:spcPct val="90000"/>
             </a:lnSpc>
@@ -10111,12 +10064,12 @@
             <a:buChar char="•"/>
           </a:pPr>
           <a:r>
-            <a:rPr lang="en-US" sz="1700" kern="1200" dirty="0"/>
+            <a:rPr lang="en-US" sz="1800" kern="1200" dirty="0"/>
             <a:t>Components</a:t>
           </a:r>
         </a:p>
         <a:p>
-          <a:pPr marL="342900" lvl="2" indent="-171450" algn="l" defTabSz="755650">
+          <a:pPr marL="342900" lvl="2" indent="-171450" algn="l" defTabSz="800100">
             <a:lnSpc>
               <a:spcPct val="90000"/>
             </a:lnSpc>
@@ -10129,13 +10082,13 @@
             <a:buChar char="•"/>
           </a:pPr>
           <a:r>
-            <a:rPr lang="en-US" sz="1700" kern="1200" dirty="0" err="1"/>
+            <a:rPr lang="en-US" sz="1800" kern="1200" dirty="0" err="1"/>
             <a:t>ACAssetType</a:t>
           </a:r>
-          <a:endParaRPr lang="en-US" sz="1700" kern="1200" dirty="0"/>
+          <a:endParaRPr lang="en-US" sz="1800" kern="1200" dirty="0"/>
         </a:p>
         <a:p>
-          <a:pPr marL="342900" lvl="2" indent="-171450" algn="l" defTabSz="755650">
+          <a:pPr marL="342900" lvl="2" indent="-171450" algn="l" defTabSz="800100">
             <a:lnSpc>
               <a:spcPct val="90000"/>
             </a:lnSpc>
@@ -10148,12 +10101,12 @@
             <a:buChar char="•"/>
           </a:pPr>
           <a:r>
-            <a:rPr lang="en-US" sz="1700" kern="1200" dirty="0"/>
+            <a:rPr lang="en-US" sz="1800" kern="1200" dirty="0"/>
             <a:t>ACUUID</a:t>
           </a:r>
         </a:p>
         <a:p>
-          <a:pPr marL="342900" lvl="2" indent="-171450" algn="l" defTabSz="755650">
+          <a:pPr marL="342900" lvl="2" indent="-171450" algn="l" defTabSz="800100">
             <a:lnSpc>
               <a:spcPct val="90000"/>
             </a:lnSpc>
@@ -10166,13 +10119,13 @@
             <a:buChar char="•"/>
           </a:pPr>
           <a:r>
-            <a:rPr lang="en-US" sz="1700" kern="1200" dirty="0" err="1"/>
+            <a:rPr lang="en-US" sz="1800" kern="1200" dirty="0" err="1"/>
             <a:t>ACFilepath</a:t>
           </a:r>
-          <a:endParaRPr lang="en-US" sz="1700" kern="1200" dirty="0"/>
+          <a:endParaRPr lang="en-US" sz="1800" kern="1200" dirty="0"/>
         </a:p>
         <a:p>
-          <a:pPr marL="342900" lvl="2" indent="-171450" algn="l" defTabSz="755650">
+          <a:pPr marL="342900" lvl="2" indent="-171450" algn="l" defTabSz="800100">
             <a:lnSpc>
               <a:spcPct val="90000"/>
             </a:lnSpc>
@@ -10185,13 +10138,13 @@
             <a:buChar char="•"/>
           </a:pPr>
           <a:r>
-            <a:rPr lang="en-US" sz="1700" kern="1200" dirty="0" err="1"/>
+            <a:rPr lang="en-US" sz="1800" kern="1200" dirty="0" err="1"/>
             <a:t>CoreComponent</a:t>
           </a:r>
-          <a:endParaRPr lang="en-US" sz="1700" kern="1200" dirty="0"/>
+          <a:endParaRPr lang="en-US" sz="1800" kern="1200" dirty="0"/>
         </a:p>
         <a:p>
-          <a:pPr marL="342900" lvl="2" indent="-171450" algn="l" defTabSz="755650">
+          <a:pPr marL="342900" lvl="2" indent="-171450" algn="l" defTabSz="800100">
             <a:lnSpc>
               <a:spcPct val="90000"/>
             </a:lnSpc>
@@ -10204,14 +10157,14 @@
             <a:buChar char="•"/>
           </a:pPr>
           <a:r>
-            <a:rPr lang="en-US" sz="1700" kern="1200" dirty="0"/>
+            <a:rPr lang="en-US" sz="1800" kern="1200" dirty="0"/>
             <a:t>other, asset type specific components</a:t>
           </a:r>
         </a:p>
       </dsp:txBody>
       <dsp:txXfrm>
-        <a:off x="8811319" y="758971"/>
-        <a:ext cx="2575156" cy="4287346"/>
+        <a:off x="8811319" y="647273"/>
+        <a:ext cx="2575156" cy="4539543"/>
       </dsp:txXfrm>
     </dsp:sp>
   </dsp:spTree>
@@ -10812,10 +10765,9 @@
             <a:buNone/>
           </a:pPr>
           <a:r>
-            <a:rPr lang="en-US" sz="1200" kern="1200" dirty="0" err="1"/>
+            <a:rPr lang="en-US" sz="1200" kern="1200" dirty="0"/>
             <a:t>SkinnedModel</a:t>
           </a:r>
-          <a:endParaRPr lang="en-US" sz="1200" kern="1200" dirty="0"/>
         </a:p>
       </dsp:txBody>
       <dsp:txXfrm>
@@ -11037,10 +10989,9 @@
             <a:buNone/>
           </a:pPr>
           <a:r>
-            <a:rPr lang="en-US" sz="1200" kern="1200" dirty="0" err="1"/>
+            <a:rPr lang="en-US" sz="1200" kern="1200" dirty="0"/>
             <a:t>RenderMesh</a:t>
           </a:r>
-          <a:endParaRPr lang="en-US" sz="1200" kern="1200" dirty="0"/>
         </a:p>
       </dsp:txBody>
       <dsp:txXfrm>
@@ -11385,7 +11336,7 @@
           </a:pPr>
           <a:r>
             <a:rPr lang="en-US" sz="1200" kern="1200" dirty="0"/>
-            <a:t>Texture</a:t>
+            <a:t>Texture2D</a:t>
           </a:r>
         </a:p>
       </dsp:txBody>
@@ -11496,10 +11447,9 @@
             <a:buNone/>
           </a:pPr>
           <a:r>
-            <a:rPr lang="en-US" sz="1200" kern="1200" dirty="0" err="1"/>
+            <a:rPr lang="en-US" sz="1200" kern="1200" dirty="0"/>
             <a:t>ShadingModel</a:t>
           </a:r>
-          <a:endParaRPr lang="en-US" sz="1200" kern="1200" dirty="0"/>
         </a:p>
       </dsp:txBody>
       <dsp:txXfrm>
@@ -11897,15 +11847,7 @@
           </a:r>
           <a:r>
             <a:rPr lang="en-US" sz="1900" kern="1200" dirty="0"/>
-            <a:t>&lt;</a:t>
-          </a:r>
-          <a:r>
-            <a:rPr lang="en-US" sz="1900" kern="1200" dirty="0" err="1"/>
-            <a:t>RenderMesh</a:t>
-          </a:r>
-          <a:r>
-            <a:rPr lang="en-US" sz="1900" kern="1200" dirty="0"/>
-            <a:t>&gt;</a:t>
+            <a:t>&lt;RenderMesh&gt;</a:t>
           </a:r>
         </a:p>
       </dsp:txBody>
@@ -12231,15 +12173,7 @@
           </a:r>
           <a:r>
             <a:rPr lang="en-US" sz="1900" kern="1200" dirty="0"/>
-            <a:t>&lt;</a:t>
-          </a:r>
-          <a:r>
-            <a:rPr lang="en-US" sz="1900" kern="1200" dirty="0" err="1"/>
-            <a:t>SkinnedModel</a:t>
-          </a:r>
-          <a:r>
-            <a:rPr lang="en-US" sz="1900" kern="1200" dirty="0"/>
-            <a:t>&gt;</a:t>
+            <a:t>&lt;SkinnedModel&gt;</a:t>
           </a:r>
         </a:p>
       </dsp:txBody>
@@ -12603,15 +12537,7 @@
           </a:r>
           <a:r>
             <a:rPr lang="en-US" sz="1600" kern="1200" dirty="0"/>
-            <a:t>&lt;</a:t>
-          </a:r>
-          <a:r>
-            <a:rPr lang="en-US" sz="1600" kern="1200" dirty="0" err="1"/>
-            <a:t>RenderMesh</a:t>
-          </a:r>
-          <a:r>
-            <a:rPr lang="en-US" sz="1600" kern="1200" dirty="0"/>
-            <a:t>&gt;&gt;</a:t>
+            <a:t>&lt;RenderMesh&gt;&gt;</a:t>
           </a:r>
         </a:p>
       </dsp:txBody>
@@ -12800,15 +12726,7 @@
           </a:r>
           <a:r>
             <a:rPr lang="en-US" sz="1600" kern="1200" dirty="0"/>
-            <a:t>&lt;</a:t>
-          </a:r>
-          <a:r>
-            <a:rPr lang="en-US" sz="1600" kern="1200" dirty="0" err="1"/>
-            <a:t>RenderMesh</a:t>
-          </a:r>
-          <a:r>
-            <a:rPr lang="en-US" sz="1600" kern="1200" dirty="0"/>
-            <a:t>&gt;&gt;</a:t>
+            <a:t>&lt;RenderMesh&gt;&gt;</a:t>
           </a:r>
         </a:p>
         <a:p>
@@ -19452,7 +19370,7 @@
           <a:p>
             <a:fld id="{D0E2DD2C-27F7-4F93-96E8-CD28AD9267D9}" type="datetimeFigureOut">
               <a:rPr lang="en-US" smtClean="0"/>
-              <a:t>11/15/2025</a:t>
+              <a:t>4/5/2026</a:t>
             </a:fld>
             <a:endParaRPr lang="en-US"/>
           </a:p>
@@ -19760,6 +19678,13 @@
           </p:nvPr>
         </p:nvSpPr>
         <p:spPr/>
+        <p:txBody>
+          <a:bodyPr/>
+          <a:lstStyle/>
+          <a:p>
+            <a:endParaRPr lang="en-US"/>
+          </a:p>
+        </p:txBody>
       </p:sp>
       <p:sp>
         <p:nvSpPr>
@@ -19868,6 +19793,13 @@
           </p:nvPr>
         </p:nvSpPr>
         <p:spPr/>
+        <p:txBody>
+          <a:bodyPr/>
+          <a:lstStyle/>
+          <a:p>
+            <a:endParaRPr lang="en-US"/>
+          </a:p>
+        </p:txBody>
       </p:sp>
       <p:sp>
         <p:nvSpPr>
@@ -19964,6 +19896,13 @@
           </p:nvPr>
         </p:nvSpPr>
         <p:spPr/>
+        <p:txBody>
+          <a:bodyPr/>
+          <a:lstStyle/>
+          <a:p>
+            <a:endParaRPr lang="en-US"/>
+          </a:p>
+        </p:txBody>
       </p:sp>
       <p:sp>
         <p:nvSpPr>
@@ -20060,6 +19999,13 @@
           </p:nvPr>
         </p:nvSpPr>
         <p:spPr/>
+        <p:txBody>
+          <a:bodyPr/>
+          <a:lstStyle/>
+          <a:p>
+            <a:endParaRPr lang="en-US"/>
+          </a:p>
+        </p:txBody>
       </p:sp>
       <p:sp>
         <p:nvSpPr>
@@ -20156,6 +20102,13 @@
           </p:nvPr>
         </p:nvSpPr>
         <p:spPr/>
+        <p:txBody>
+          <a:bodyPr/>
+          <a:lstStyle/>
+          <a:p>
+            <a:endParaRPr lang="en-US"/>
+          </a:p>
+        </p:txBody>
       </p:sp>
       <p:sp>
         <p:nvSpPr>
@@ -20252,6 +20205,13 @@
           </p:nvPr>
         </p:nvSpPr>
         <p:spPr/>
+        <p:txBody>
+          <a:bodyPr/>
+          <a:lstStyle/>
+          <a:p>
+            <a:endParaRPr lang="en-US"/>
+          </a:p>
+        </p:txBody>
       </p:sp>
       <p:sp>
         <p:nvSpPr>
@@ -20467,7 +20427,7 @@
           <a:p>
             <a:fld id="{783DC7D5-4D76-4679-A391-31CBAFA90932}" type="datetimeFigureOut">
               <a:rPr lang="en-US" smtClean="0"/>
-              <a:t>11/15/2025</a:t>
+              <a:t>4/5/2026</a:t>
             </a:fld>
             <a:endParaRPr lang="en-US"/>
           </a:p>
@@ -20665,7 +20625,7 @@
           <a:p>
             <a:fld id="{783DC7D5-4D76-4679-A391-31CBAFA90932}" type="datetimeFigureOut">
               <a:rPr lang="en-US" smtClean="0"/>
-              <a:t>11/15/2025</a:t>
+              <a:t>4/5/2026</a:t>
             </a:fld>
             <a:endParaRPr lang="en-US"/>
           </a:p>
@@ -20873,7 +20833,7 @@
           <a:p>
             <a:fld id="{783DC7D5-4D76-4679-A391-31CBAFA90932}" type="datetimeFigureOut">
               <a:rPr lang="en-US" smtClean="0"/>
-              <a:t>11/15/2025</a:t>
+              <a:t>4/5/2026</a:t>
             </a:fld>
             <a:endParaRPr lang="en-US"/>
           </a:p>
@@ -21071,7 +21031,7 @@
           <a:p>
             <a:fld id="{783DC7D5-4D76-4679-A391-31CBAFA90932}" type="datetimeFigureOut">
               <a:rPr lang="en-US" smtClean="0"/>
-              <a:t>11/15/2025</a:t>
+              <a:t>4/5/2026</a:t>
             </a:fld>
             <a:endParaRPr lang="en-US"/>
           </a:p>
@@ -21346,7 +21306,7 @@
           <a:p>
             <a:fld id="{783DC7D5-4D76-4679-A391-31CBAFA90932}" type="datetimeFigureOut">
               <a:rPr lang="en-US" smtClean="0"/>
-              <a:t>11/15/2025</a:t>
+              <a:t>4/5/2026</a:t>
             </a:fld>
             <a:endParaRPr lang="en-US"/>
           </a:p>
@@ -21611,7 +21571,7 @@
           <a:p>
             <a:fld id="{783DC7D5-4D76-4679-A391-31CBAFA90932}" type="datetimeFigureOut">
               <a:rPr lang="en-US" smtClean="0"/>
-              <a:t>11/15/2025</a:t>
+              <a:t>4/5/2026</a:t>
             </a:fld>
             <a:endParaRPr lang="en-US"/>
           </a:p>
@@ -22023,7 +21983,7 @@
           <a:p>
             <a:fld id="{783DC7D5-4D76-4679-A391-31CBAFA90932}" type="datetimeFigureOut">
               <a:rPr lang="en-US" smtClean="0"/>
-              <a:t>11/15/2025</a:t>
+              <a:t>4/5/2026</a:t>
             </a:fld>
             <a:endParaRPr lang="en-US"/>
           </a:p>
@@ -22164,7 +22124,7 @@
           <a:p>
             <a:fld id="{783DC7D5-4D76-4679-A391-31CBAFA90932}" type="datetimeFigureOut">
               <a:rPr lang="en-US" smtClean="0"/>
-              <a:t>11/15/2025</a:t>
+              <a:t>4/5/2026</a:t>
             </a:fld>
             <a:endParaRPr lang="en-US"/>
           </a:p>
@@ -22277,7 +22237,7 @@
           <a:p>
             <a:fld id="{783DC7D5-4D76-4679-A391-31CBAFA90932}" type="datetimeFigureOut">
               <a:rPr lang="en-US" smtClean="0"/>
-              <a:t>11/15/2025</a:t>
+              <a:t>4/5/2026</a:t>
             </a:fld>
             <a:endParaRPr lang="en-US"/>
           </a:p>
@@ -22588,7 +22548,7 @@
           <a:p>
             <a:fld id="{783DC7D5-4D76-4679-A391-31CBAFA90932}" type="datetimeFigureOut">
               <a:rPr lang="en-US" smtClean="0"/>
-              <a:t>11/15/2025</a:t>
+              <a:t>4/5/2026</a:t>
             </a:fld>
             <a:endParaRPr lang="en-US"/>
           </a:p>
@@ -22876,7 +22836,7 @@
           <a:p>
             <a:fld id="{783DC7D5-4D76-4679-A391-31CBAFA90932}" type="datetimeFigureOut">
               <a:rPr lang="en-US" smtClean="0"/>
-              <a:t>11/15/2025</a:t>
+              <a:t>4/5/2026</a:t>
             </a:fld>
             <a:endParaRPr lang="en-US"/>
           </a:p>
@@ -23117,7 +23077,7 @@
           <a:p>
             <a:fld id="{783DC7D5-4D76-4679-A391-31CBAFA90932}" type="datetimeFigureOut">
               <a:rPr lang="en-US" smtClean="0"/>
-              <a:t>11/15/2025</a:t>
+              <a:t>4/5/2026</a:t>
             </a:fld>
             <a:endParaRPr lang="en-US"/>
           </a:p>
@@ -24734,15 +24694,7 @@
             </a:r>
             <a:r>
               <a:rPr lang="en-US" sz="1600" noProof="0" dirty="0"/>
-              <a:t> have only Asset files and no Asset Source files (</a:t>
-            </a:r>
-            <a:r>
-              <a:rPr lang="en-US" sz="1600" noProof="0" dirty="0" err="1"/>
-              <a:t>eg.</a:t>
-            </a:r>
-            <a:r>
-              <a:rPr lang="en-US" sz="1600" noProof="0" dirty="0"/>
-              <a:t> Materials).</a:t>
+              <a:t> have only Asset files and no Asset Source files (e.g. Materials).</a:t>
             </a:r>
           </a:p>
         </p:txBody>
@@ -27064,7 +27016,7 @@
         <p:spPr>
           <a:xfrm>
             <a:off x="522740" y="1763982"/>
-            <a:ext cx="6686158" cy="4031873"/>
+            <a:ext cx="6686158" cy="3785652"/>
           </a:xfrm>
           <a:prstGeom prst="rect">
             <a:avLst/>
@@ -27157,17 +27109,6 @@
             <a:r>
               <a:rPr lang="en-US" sz="1600" dirty="0" err="1"/>
               <a:t>ACSourceFilepath</a:t>
-            </a:r>
-            <a:endParaRPr lang="en-US" sz="1600" dirty="0"/>
-          </a:p>
-          <a:p>
-            <a:pPr marL="285750" indent="-285750" algn="just">
-              <a:buFont typeface="Arial" panose="020B0604020202020204" pitchFamily="34" charset="0"/>
-              <a:buChar char="•"/>
-            </a:pPr>
-            <a:r>
-              <a:rPr lang="en-US" sz="1600" dirty="0" err="1"/>
-              <a:t>ACMasterAsset</a:t>
             </a:r>
             <a:endParaRPr lang="en-US" sz="1600" dirty="0"/>
           </a:p>
@@ -27328,7 +27269,7 @@
           <p:nvPr>
             <p:extLst>
               <p:ext uri="{D42A27DB-BD31-4B8C-83A1-F6EECF244321}">
-                <p14:modId xmlns:p14="http://schemas.microsoft.com/office/powerpoint/2010/main" val="2810766526"/>
+                <p14:modId xmlns:p14="http://schemas.microsoft.com/office/powerpoint/2010/main" val="3033458005"/>
               </p:ext>
             </p:extLst>
           </p:nvPr>
@@ -27481,8 +27422,8 @@
         </p:nvSpPr>
         <p:spPr>
           <a:xfrm>
-            <a:off x="4312821" y="318532"/>
-            <a:ext cx="3566358" cy="582346"/>
+            <a:off x="4660161" y="318532"/>
+            <a:ext cx="2871678" cy="582346"/>
           </a:xfrm>
           <a:prstGeom prst="roundRect">
             <a:avLst/>
@@ -27509,7 +27450,7 @@
             <a:pPr algn="ctr"/>
             <a:r>
               <a:rPr lang="en-US" dirty="0"/>
-              <a:t>Rendering Assets</a:t>
+              <a:t>Composition structure of Rendering Assets</a:t>
             </a:r>
           </a:p>
         </p:txBody>
@@ -27870,13 +27811,8 @@
             <a:pPr algn="ctr"/>
             <a:r>
               <a:rPr lang="en-US" dirty="0"/>
-              <a:t>N × </a:t>
+              <a:t>N × RenderMesh</a:t>
             </a:r>
-            <a:r>
-              <a:rPr lang="en-US" dirty="0" err="1"/>
-              <a:t>RenderMesh</a:t>
-            </a:r>
-            <a:endParaRPr lang="en-US" dirty="0"/>
           </a:p>
         </p:txBody>
       </p:sp>
@@ -28059,10 +27995,9 @@
           <a:p>
             <a:pPr algn="ctr"/>
             <a:r>
-              <a:rPr lang="en-US" dirty="0" err="1"/>
+              <a:rPr lang="en-US" dirty="0"/>
               <a:t>ShadingModel</a:t>
             </a:r>
-            <a:endParaRPr lang="en-US" dirty="0"/>
           </a:p>
         </p:txBody>
       </p:sp>
@@ -28112,7 +28047,7 @@
             </a:r>
             <a:r>
               <a:rPr lang="en-US" dirty="0"/>
-              <a:t>Texture</a:t>
+              <a:t>Texture2D</a:t>
             </a:r>
           </a:p>
         </p:txBody>
@@ -28395,10 +28330,9 @@
           <a:p>
             <a:pPr algn="ctr"/>
             <a:r>
-              <a:rPr lang="en-US" dirty="0" err="1"/>
+              <a:rPr lang="en-US" dirty="0"/>
               <a:t>RenderMesh</a:t>
             </a:r>
-            <a:endParaRPr lang="en-US" dirty="0"/>
           </a:p>
         </p:txBody>
       </p:sp>
@@ -28641,10 +28575,9 @@
           <a:p>
             <a:pPr algn="ctr"/>
             <a:r>
-              <a:rPr lang="en-US" dirty="0" err="1"/>
+              <a:rPr lang="en-US" dirty="0"/>
               <a:t>ShadingModel</a:t>
             </a:r>
-            <a:endParaRPr lang="en-US" dirty="0"/>
           </a:p>
         </p:txBody>
       </p:sp>
@@ -28691,10 +28624,9 @@
           <a:p>
             <a:pPr algn="ctr"/>
             <a:r>
-              <a:rPr lang="en-US" dirty="0" err="1"/>
+              <a:rPr lang="en-US" dirty="0"/>
               <a:t>SkinnedModel</a:t>
             </a:r>
-            <a:endParaRPr lang="en-US" dirty="0"/>
           </a:p>
         </p:txBody>
       </p:sp>
@@ -28758,7 +28690,7 @@
           <p:nvPr>
             <p:extLst>
               <p:ext uri="{D42A27DB-BD31-4B8C-83A1-F6EECF244321}">
-                <p14:modId xmlns:p14="http://schemas.microsoft.com/office/powerpoint/2010/main" val="798058038"/>
+                <p14:modId xmlns:p14="http://schemas.microsoft.com/office/powerpoint/2010/main" val="201167692"/>
               </p:ext>
             </p:extLst>
           </p:nvPr>
@@ -29232,15 +29164,7 @@
             <a:pPr algn="ctr"/>
             <a:r>
               <a:rPr lang="en-US" dirty="0"/>
-              <a:t>They also have scene components “simulating” them – asset views. </a:t>
-            </a:r>
-            <a:r>
-              <a:rPr lang="pl-PL" dirty="0" err="1"/>
-              <a:t>This</a:t>
-            </a:r>
-            <a:r>
-              <a:rPr lang="en-US" dirty="0"/>
-              <a:t> allows for runtime dynamic composition.</a:t>
+              <a:t>They also have scene components “simulating” them – asset views. This allows for runtime dynamic composition.</a:t>
             </a:r>
           </a:p>
         </p:txBody>

</xml_diff>